<commit_message>
Update presentation slides and fix formatting in the presentation document
</commit_message>
<xml_diff>
--- a/docs/presentation/Unsupervised Statistical Learning for Kinematic Anomaly Detection in Autonomous Driving Scenarios.pptx
+++ b/docs/presentation/Unsupervised Statistical Learning for Kinematic Anomaly Detection in Autonomous Driving Scenarios.pptx
@@ -132,7 +132,7 @@
 <file path=ppt/revisionInfo.xml><?xml version="1.0" encoding="utf-8"?>
 <p1510:revInfo xmlns:a="http://schemas.openxmlformats.org/drawingml/2006/main" xmlns:r="http://schemas.openxmlformats.org/officeDocument/2006/relationships" xmlns:p1510="http://schemas.microsoft.com/office/powerpoint/2015/10/main">
   <p1510:revLst>
-    <p1510:client id="{E91D200D-BFFE-DF45-BD3E-DC36CCF88744}" v="37" dt="2026-04-12T02:44:56.824"/>
+    <p1510:client id="{E91D200D-BFFE-DF45-BD3E-DC36CCF88744}" v="57" dt="2026-04-12T03:18:04.601"/>
   </p1510:revLst>
 </p1510:revInfo>
 </file>
@@ -141,8 +141,8 @@
 <pc:chgInfo xmlns:a="http://schemas.openxmlformats.org/drawingml/2006/main" xmlns:r="http://schemas.openxmlformats.org/officeDocument/2006/relationships" xmlns:ac="http://schemas.microsoft.com/office/drawing/2013/main/command" xmlns:pc="http://schemas.microsoft.com/office/powerpoint/2013/main/command">
   <pc:docChgLst>
     <pc:chgData name="Stepanov, Pavel Aleksandrovich" userId="b85f6bca-230c-483e-a25b-e13e873626fd" providerId="ADAL" clId="{AB235781-41D1-50B9-86EA-51A98A5F500A}"/>
-    <pc:docChg chg="undo custSel addSld modSld">
-      <pc:chgData name="Stepanov, Pavel Aleksandrovich" userId="b85f6bca-230c-483e-a25b-e13e873626fd" providerId="ADAL" clId="{AB235781-41D1-50B9-86EA-51A98A5F500A}" dt="2026-04-12T02:45:35.358" v="214" actId="20577"/>
+    <pc:docChg chg="undo redo custSel addSld modSld">
+      <pc:chgData name="Stepanov, Pavel Aleksandrovich" userId="b85f6bca-230c-483e-a25b-e13e873626fd" providerId="ADAL" clId="{AB235781-41D1-50B9-86EA-51A98A5F500A}" dt="2026-04-12T03:18:07.237" v="432" actId="1076"/>
       <pc:docMkLst>
         <pc:docMk/>
       </pc:docMkLst>
@@ -199,25 +199,49 @@
           </ac:picMkLst>
         </pc:picChg>
       </pc:sldChg>
-      <pc:sldChg chg="modNotesTx">
-        <pc:chgData name="Stepanov, Pavel Aleksandrovich" userId="b85f6bca-230c-483e-a25b-e13e873626fd" providerId="ADAL" clId="{AB235781-41D1-50B9-86EA-51A98A5F500A}" dt="2026-04-12T02:04:00.518" v="62" actId="20577"/>
+      <pc:sldChg chg="modSp mod modNotesTx">
+        <pc:chgData name="Stepanov, Pavel Aleksandrovich" userId="b85f6bca-230c-483e-a25b-e13e873626fd" providerId="ADAL" clId="{AB235781-41D1-50B9-86EA-51A98A5F500A}" dt="2026-04-12T03:10:56.989" v="313" actId="1076"/>
         <pc:sldMkLst>
           <pc:docMk/>
           <pc:sldMk cId="34899088" sldId="260"/>
         </pc:sldMkLst>
+        <pc:spChg chg="mod">
+          <ac:chgData name="Stepanov, Pavel Aleksandrovich" userId="b85f6bca-230c-483e-a25b-e13e873626fd" providerId="ADAL" clId="{AB235781-41D1-50B9-86EA-51A98A5F500A}" dt="2026-04-12T03:10:56.989" v="313" actId="1076"/>
+          <ac:spMkLst>
+            <pc:docMk/>
+            <pc:sldMk cId="34899088" sldId="260"/>
+            <ac:spMk id="2" creationId="{568FC75A-02FA-BB25-0851-770322A46375}"/>
+          </ac:spMkLst>
+        </pc:spChg>
       </pc:sldChg>
-      <pc:sldChg chg="modSp mod modNotesTx">
-        <pc:chgData name="Stepanov, Pavel Aleksandrovich" userId="b85f6bca-230c-483e-a25b-e13e873626fd" providerId="ADAL" clId="{AB235781-41D1-50B9-86EA-51A98A5F500A}" dt="2026-04-12T02:08:41.912" v="84" actId="1076"/>
+      <pc:sldChg chg="addSp modSp mod modNotesTx">
+        <pc:chgData name="Stepanov, Pavel Aleksandrovich" userId="b85f6bca-230c-483e-a25b-e13e873626fd" providerId="ADAL" clId="{AB235781-41D1-50B9-86EA-51A98A5F500A}" dt="2026-04-12T03:08:47.395" v="304" actId="20577"/>
         <pc:sldMkLst>
           <pc:docMk/>
           <pc:sldMk cId="1027313753" sldId="262"/>
         </pc:sldMkLst>
+        <pc:spChg chg="add mod">
+          <ac:chgData name="Stepanov, Pavel Aleksandrovich" userId="b85f6bca-230c-483e-a25b-e13e873626fd" providerId="ADAL" clId="{AB235781-41D1-50B9-86EA-51A98A5F500A}" dt="2026-04-12T03:07:05.363" v="297" actId="1076"/>
+          <ac:spMkLst>
+            <pc:docMk/>
+            <pc:sldMk cId="1027313753" sldId="262"/>
+            <ac:spMk id="3" creationId="{6FF11A2A-EA04-CBEA-5259-2D7D1F89B0FD}"/>
+          </ac:spMkLst>
+        </pc:spChg>
         <pc:spChg chg="mod">
           <ac:chgData name="Stepanov, Pavel Aleksandrovich" userId="b85f6bca-230c-483e-a25b-e13e873626fd" providerId="ADAL" clId="{AB235781-41D1-50B9-86EA-51A98A5F500A}" dt="2026-04-12T02:08:37.478" v="83" actId="1076"/>
           <ac:spMkLst>
             <pc:docMk/>
             <pc:sldMk cId="1027313753" sldId="262"/>
             <ac:spMk id="16" creationId="{F7FF29CB-B9A0-D774-8556-025972A6411F}"/>
+          </ac:spMkLst>
+        </pc:spChg>
+        <pc:spChg chg="mod">
+          <ac:chgData name="Stepanov, Pavel Aleksandrovich" userId="b85f6bca-230c-483e-a25b-e13e873626fd" providerId="ADAL" clId="{AB235781-41D1-50B9-86EA-51A98A5F500A}" dt="2026-04-12T03:05:35.452" v="277" actId="207"/>
+          <ac:spMkLst>
+            <pc:docMk/>
+            <pc:sldMk cId="1027313753" sldId="262"/>
+            <ac:spMk id="22" creationId="{758A5016-C08E-98B3-26B4-A2802863211D}"/>
           </ac:spMkLst>
         </pc:spChg>
         <pc:spChg chg="mod">
@@ -229,15 +253,119 @@
           </ac:spMkLst>
         </pc:spChg>
       </pc:sldChg>
-      <pc:sldChg chg="modNotesTx">
-        <pc:chgData name="Stepanov, Pavel Aleksandrovich" userId="b85f6bca-230c-483e-a25b-e13e873626fd" providerId="ADAL" clId="{AB235781-41D1-50B9-86EA-51A98A5F500A}" dt="2026-04-12T02:02:03.614" v="58" actId="20577"/>
+      <pc:sldChg chg="addSp delSp modSp mod setBg modNotesTx">
+        <pc:chgData name="Stepanov, Pavel Aleksandrovich" userId="b85f6bca-230c-483e-a25b-e13e873626fd" providerId="ADAL" clId="{AB235781-41D1-50B9-86EA-51A98A5F500A}" dt="2026-04-12T03:18:07.237" v="432" actId="1076"/>
         <pc:sldMkLst>
           <pc:docMk/>
           <pc:sldMk cId="2414567693" sldId="263"/>
         </pc:sldMkLst>
+        <pc:spChg chg="mod">
+          <ac:chgData name="Stepanov, Pavel Aleksandrovich" userId="b85f6bca-230c-483e-a25b-e13e873626fd" providerId="ADAL" clId="{AB235781-41D1-50B9-86EA-51A98A5F500A}" dt="2026-04-12T03:10:36.616" v="307" actId="207"/>
+          <ac:spMkLst>
+            <pc:docMk/>
+            <pc:sldMk cId="2414567693" sldId="263"/>
+            <ac:spMk id="4" creationId="{03C362FE-26C6-9E59-253C-0E8E33DFB89E}"/>
+          </ac:spMkLst>
+        </pc:spChg>
+        <pc:spChg chg="del">
+          <ac:chgData name="Stepanov, Pavel Aleksandrovich" userId="b85f6bca-230c-483e-a25b-e13e873626fd" providerId="ADAL" clId="{AB235781-41D1-50B9-86EA-51A98A5F500A}" dt="2026-04-12T03:10:54.387" v="311" actId="478"/>
+          <ac:spMkLst>
+            <pc:docMk/>
+            <pc:sldMk cId="2414567693" sldId="263"/>
+            <ac:spMk id="5" creationId="{1A7F5B05-687E-2A4C-A8CD-9F064CE84592}"/>
+          </ac:spMkLst>
+        </pc:spChg>
+        <pc:spChg chg="del mod">
+          <ac:chgData name="Stepanov, Pavel Aleksandrovich" userId="b85f6bca-230c-483e-a25b-e13e873626fd" providerId="ADAL" clId="{AB235781-41D1-50B9-86EA-51A98A5F500A}" dt="2026-04-12T03:10:42.705" v="309" actId="478"/>
+          <ac:spMkLst>
+            <pc:docMk/>
+            <pc:sldMk cId="2414567693" sldId="263"/>
+            <ac:spMk id="6" creationId="{63141582-FD1E-F62F-4490-D627EFD530A0}"/>
+          </ac:spMkLst>
+        </pc:spChg>
+        <pc:spChg chg="add del mod">
+          <ac:chgData name="Stepanov, Pavel Aleksandrovich" userId="b85f6bca-230c-483e-a25b-e13e873626fd" providerId="ADAL" clId="{AB235781-41D1-50B9-86EA-51A98A5F500A}" dt="2026-04-12T03:02:18.848" v="261" actId="478"/>
+          <ac:spMkLst>
+            <pc:docMk/>
+            <pc:sldMk cId="2414567693" sldId="263"/>
+            <ac:spMk id="7" creationId="{D3A371C0-86C1-D020-1A66-D42D2E55A14F}"/>
+          </ac:spMkLst>
+        </pc:spChg>
+        <pc:spChg chg="mod">
+          <ac:chgData name="Stepanov, Pavel Aleksandrovich" userId="b85f6bca-230c-483e-a25b-e13e873626fd" providerId="ADAL" clId="{AB235781-41D1-50B9-86EA-51A98A5F500A}" dt="2026-04-12T03:10:34.901" v="306" actId="207"/>
+          <ac:spMkLst>
+            <pc:docMk/>
+            <pc:sldMk cId="2414567693" sldId="263"/>
+            <ac:spMk id="8" creationId="{AA0B286F-ACC4-E15E-FE10-F81A14DF3948}"/>
+          </ac:spMkLst>
+        </pc:spChg>
+        <pc:spChg chg="add mod">
+          <ac:chgData name="Stepanov, Pavel Aleksandrovich" userId="b85f6bca-230c-483e-a25b-e13e873626fd" providerId="ADAL" clId="{AB235781-41D1-50B9-86EA-51A98A5F500A}" dt="2026-04-12T03:17:56.342" v="429" actId="167"/>
+          <ac:spMkLst>
+            <pc:docMk/>
+            <pc:sldMk cId="2414567693" sldId="263"/>
+            <ac:spMk id="11" creationId="{00515834-BC50-0B18-62CA-A70C9A9333E0}"/>
+          </ac:spMkLst>
+        </pc:spChg>
+        <pc:spChg chg="add mod">
+          <ac:chgData name="Stepanov, Pavel Aleksandrovich" userId="b85f6bca-230c-483e-a25b-e13e873626fd" providerId="ADAL" clId="{AB235781-41D1-50B9-86EA-51A98A5F500A}" dt="2026-04-12T03:17:31.374" v="421" actId="1076"/>
+          <ac:spMkLst>
+            <pc:docMk/>
+            <pc:sldMk cId="2414567693" sldId="263"/>
+            <ac:spMk id="15" creationId="{CEF7CCBE-156F-9D4E-6D62-90F42BD0C322}"/>
+          </ac:spMkLst>
+        </pc:spChg>
+        <pc:spChg chg="add del mod">
+          <ac:chgData name="Stepanov, Pavel Aleksandrovich" userId="b85f6bca-230c-483e-a25b-e13e873626fd" providerId="ADAL" clId="{AB235781-41D1-50B9-86EA-51A98A5F500A}" dt="2026-04-12T03:18:07.237" v="432" actId="1076"/>
+          <ac:spMkLst>
+            <pc:docMk/>
+            <pc:sldMk cId="2414567693" sldId="263"/>
+            <ac:spMk id="24" creationId="{11818D86-B172-7F3C-A000-ECBB85ED72A7}"/>
+          </ac:spMkLst>
+        </pc:spChg>
+        <pc:graphicFrameChg chg="mod modGraphic">
+          <ac:chgData name="Stepanov, Pavel Aleksandrovich" userId="b85f6bca-230c-483e-a25b-e13e873626fd" providerId="ADAL" clId="{AB235781-41D1-50B9-86EA-51A98A5F500A}" dt="2026-04-12T03:17:44.642" v="427" actId="14100"/>
+          <ac:graphicFrameMkLst>
+            <pc:docMk/>
+            <pc:sldMk cId="2414567693" sldId="263"/>
+            <ac:graphicFrameMk id="3" creationId="{6E5ED46D-9A9D-45B4-50C0-E4B617433E8C}"/>
+          </ac:graphicFrameMkLst>
+        </pc:graphicFrameChg>
+        <pc:picChg chg="del">
+          <ac:chgData name="Stepanov, Pavel Aleksandrovich" userId="b85f6bca-230c-483e-a25b-e13e873626fd" providerId="ADAL" clId="{AB235781-41D1-50B9-86EA-51A98A5F500A}" dt="2026-04-12T03:12:14.648" v="331" actId="478"/>
+          <ac:picMkLst>
+            <pc:docMk/>
+            <pc:sldMk cId="2414567693" sldId="263"/>
+            <ac:picMk id="2" creationId="{0E3246AA-DF2A-798A-F5B3-ED4A58B466E9}"/>
+          </ac:picMkLst>
+        </pc:picChg>
+        <pc:picChg chg="add del mod">
+          <ac:chgData name="Stepanov, Pavel Aleksandrovich" userId="b85f6bca-230c-483e-a25b-e13e873626fd" providerId="ADAL" clId="{AB235781-41D1-50B9-86EA-51A98A5F500A}" dt="2026-04-12T03:02:27.859" v="263" actId="478"/>
+          <ac:picMkLst>
+            <pc:docMk/>
+            <pc:sldMk cId="2414567693" sldId="263"/>
+            <ac:picMk id="10" creationId="{3AF1DCB4-D198-2FC1-AE71-B8ADD1B6AF8D}"/>
+          </ac:picMkLst>
+        </pc:picChg>
+        <pc:picChg chg="add mod">
+          <ac:chgData name="Stepanov, Pavel Aleksandrovich" userId="b85f6bca-230c-483e-a25b-e13e873626fd" providerId="ADAL" clId="{AB235781-41D1-50B9-86EA-51A98A5F500A}" dt="2026-04-12T03:13:42.851" v="347" actId="1076"/>
+          <ac:picMkLst>
+            <pc:docMk/>
+            <pc:sldMk cId="2414567693" sldId="263"/>
+            <ac:picMk id="13" creationId="{9505BAAA-21BA-2316-4D5C-506901CAEEDA}"/>
+          </ac:picMkLst>
+        </pc:picChg>
+        <pc:picChg chg="add mod">
+          <ac:chgData name="Stepanov, Pavel Aleksandrovich" userId="b85f6bca-230c-483e-a25b-e13e873626fd" providerId="ADAL" clId="{AB235781-41D1-50B9-86EA-51A98A5F500A}" dt="2026-04-12T03:12:15.097" v="332"/>
+          <ac:picMkLst>
+            <pc:docMk/>
+            <pc:sldMk cId="2414567693" sldId="263"/>
+            <ac:picMk id="14" creationId="{0AB81574-B623-A466-0C44-7AD8EF55DE3E}"/>
+          </ac:picMkLst>
+        </pc:picChg>
       </pc:sldChg>
-      <pc:sldChg chg="addSp delSp modSp modNotesTx">
-        <pc:chgData name="Stepanov, Pavel Aleksandrovich" userId="b85f6bca-230c-483e-a25b-e13e873626fd" providerId="ADAL" clId="{AB235781-41D1-50B9-86EA-51A98A5F500A}" dt="2026-04-12T02:44:44.652" v="212" actId="20577"/>
+      <pc:sldChg chg="addSp delSp modSp mod modShow modNotesTx">
+        <pc:chgData name="Stepanov, Pavel Aleksandrovich" userId="b85f6bca-230c-483e-a25b-e13e873626fd" providerId="ADAL" clId="{AB235781-41D1-50B9-86EA-51A98A5F500A}" dt="2026-04-12T02:51:55.024" v="225" actId="20577"/>
         <pc:sldMkLst>
           <pc:docMk/>
           <pc:sldMk cId="2606525707" sldId="264"/>
@@ -250,8 +378,8 @@
             <ac:spMk id="2" creationId="{7A68A61C-4608-E59F-E53A-ACC82BDE3BFB}"/>
           </ac:spMkLst>
         </pc:spChg>
-        <pc:spChg chg="add mod">
-          <ac:chgData name="Stepanov, Pavel Aleksandrovich" userId="b85f6bca-230c-483e-a25b-e13e873626fd" providerId="ADAL" clId="{AB235781-41D1-50B9-86EA-51A98A5F500A}" dt="2026-04-12T02:44:33.442" v="210" actId="478"/>
+        <pc:spChg chg="add del mod">
+          <ac:chgData name="Stepanov, Pavel Aleksandrovich" userId="b85f6bca-230c-483e-a25b-e13e873626fd" providerId="ADAL" clId="{AB235781-41D1-50B9-86EA-51A98A5F500A}" dt="2026-04-12T02:51:41.085" v="219" actId="478"/>
           <ac:spMkLst>
             <pc:docMk/>
             <pc:sldMk cId="2606525707" sldId="264"/>
@@ -290,12 +418,28 @@
             <ac:spMk id="8" creationId="{3B39957A-7A79-0237-F7BA-3507FB224EBF}"/>
           </ac:spMkLst>
         </pc:spChg>
+        <pc:spChg chg="add mod">
+          <ac:chgData name="Stepanov, Pavel Aleksandrovich" userId="b85f6bca-230c-483e-a25b-e13e873626fd" providerId="ADAL" clId="{AB235781-41D1-50B9-86EA-51A98A5F500A}" dt="2026-04-12T02:51:29.667" v="217"/>
+          <ac:spMkLst>
+            <pc:docMk/>
+            <pc:sldMk cId="2606525707" sldId="264"/>
+            <ac:spMk id="9" creationId="{048C4A0F-704A-1B42-09A0-E1CEA1F85F1A}"/>
+          </ac:spMkLst>
+        </pc:spChg>
         <pc:spChg chg="del">
           <ac:chgData name="Stepanov, Pavel Aleksandrovich" userId="b85f6bca-230c-483e-a25b-e13e873626fd" providerId="ADAL" clId="{AB235781-41D1-50B9-86EA-51A98A5F500A}" dt="2026-04-12T02:44:33.442" v="210" actId="478"/>
           <ac:spMkLst>
             <pc:docMk/>
             <pc:sldMk cId="2606525707" sldId="264"/>
             <ac:spMk id="10" creationId="{88F07873-F556-363B-D82F-5070AC0E40F8}"/>
+          </ac:spMkLst>
+        </pc:spChg>
+        <pc:spChg chg="add mod">
+          <ac:chgData name="Stepanov, Pavel Aleksandrovich" userId="b85f6bca-230c-483e-a25b-e13e873626fd" providerId="ADAL" clId="{AB235781-41D1-50B9-86EA-51A98A5F500A}" dt="2026-04-12T02:51:39.190" v="218"/>
+          <ac:spMkLst>
+            <pc:docMk/>
+            <pc:sldMk cId="2606525707" sldId="264"/>
+            <ac:spMk id="11" creationId="{B6033FA2-EB1F-F693-6FA4-7BB8813D9CDA}"/>
           </ac:spMkLst>
         </pc:spChg>
         <pc:spChg chg="del">
@@ -322,6 +466,22 @@
             <ac:spMk id="17" creationId="{ADE500D8-7D23-EFBE-E974-8C8A094C2972}"/>
           </ac:spMkLst>
         </pc:spChg>
+        <pc:graphicFrameChg chg="add mod modGraphic">
+          <ac:chgData name="Stepanov, Pavel Aleksandrovich" userId="b85f6bca-230c-483e-a25b-e13e873626fd" providerId="ADAL" clId="{AB235781-41D1-50B9-86EA-51A98A5F500A}" dt="2026-04-12T02:51:55.024" v="225" actId="20577"/>
+          <ac:graphicFrameMkLst>
+            <pc:docMk/>
+            <pc:sldMk cId="2606525707" sldId="264"/>
+            <ac:graphicFrameMk id="12" creationId="{060EF4B2-4504-8D76-A4E4-69FA63C93789}"/>
+          </ac:graphicFrameMkLst>
+        </pc:graphicFrameChg>
+        <pc:picChg chg="add mod">
+          <ac:chgData name="Stepanov, Pavel Aleksandrovich" userId="b85f6bca-230c-483e-a25b-e13e873626fd" providerId="ADAL" clId="{AB235781-41D1-50B9-86EA-51A98A5F500A}" dt="2026-04-12T02:51:10.410" v="215"/>
+          <ac:picMkLst>
+            <pc:docMk/>
+            <pc:sldMk cId="2606525707" sldId="264"/>
+            <ac:picMk id="6" creationId="{73A17D98-85BB-1349-8904-4995BA7F417F}"/>
+          </ac:picMkLst>
+        </pc:picChg>
       </pc:sldChg>
       <pc:sldChg chg="addSp delSp mod modNotesTx">
         <pc:chgData name="Stepanov, Pavel Aleksandrovich" userId="b85f6bca-230c-483e-a25b-e13e873626fd" providerId="ADAL" clId="{AB235781-41D1-50B9-86EA-51A98A5F500A}" dt="2026-04-12T02:44:57.589" v="213" actId="113"/>
@@ -2526,7 +2686,7 @@
               <a:t>PAVEL:</a:t>
             </a:r>
             <a:br>
-              <a:rPr lang="en-US" b="1"/>
+              <a:rPr lang="en-US" b="1" dirty="0"/>
             </a:br>
             <a:endParaRPr lang="en-US" b="1" dirty="0"/>
           </a:p>
@@ -4115,10 +4275,12 @@
                 <a:ea typeface="+mn-ea"/>
                 <a:cs typeface="+mn-cs"/>
               </a:rPr>
-              <a:t>Our pipeline has two stages. First, Python running in Google </a:t>
-            </a:r>
-            <a:r>
-              <a:rPr lang="en-US" sz="1200" b="0" i="0" kern="1200" dirty="0" err="1">
+              <a:t>Our pipeline has two stages. </a:t>
+            </a:r>
+          </a:p>
+          <a:p>
+            <a:r>
+              <a:rPr lang="en-US" sz="1200" b="0" i="0" kern="1200" dirty="0">
                 <a:solidFill>
                   <a:schemeClr val="tx1"/>
                 </a:solidFill>
@@ -4127,10 +4289,10 @@
                 <a:ea typeface="+mn-ea"/>
                 <a:cs typeface="+mn-cs"/>
               </a:rPr>
-              <a:t>Colab</a:t>
-            </a:r>
-            <a:r>
-              <a:rPr lang="en-US" sz="1200" b="0" i="0" kern="1200" dirty="0">
+              <a:t>First, Python running in Google </a:t>
+            </a:r>
+            <a:r>
+              <a:rPr lang="en-US" sz="1200" b="0" i="0" kern="1200" dirty="0" err="1">
                 <a:solidFill>
                   <a:schemeClr val="tx1"/>
                 </a:solidFill>
@@ -4139,10 +4301,10 @@
                 <a:ea typeface="+mn-ea"/>
                 <a:cs typeface="+mn-cs"/>
               </a:rPr>
-              <a:t> pulls raw </a:t>
-            </a:r>
-            <a:r>
-              <a:rPr lang="en-US" sz="1200" b="0" i="0" kern="1200" dirty="0" err="1">
+              <a:t>Colab</a:t>
+            </a:r>
+            <a:r>
+              <a:rPr lang="en-US" sz="1200" b="0" i="0" kern="1200" dirty="0">
                 <a:solidFill>
                   <a:schemeClr val="tx1"/>
                 </a:solidFill>
@@ -4151,10 +4313,10 @@
                 <a:ea typeface="+mn-ea"/>
                 <a:cs typeface="+mn-cs"/>
               </a:rPr>
-              <a:t>TFRecord</a:t>
-            </a:r>
-            <a:r>
-              <a:rPr lang="en-US" sz="1200" b="0" i="0" kern="1200" dirty="0">
+              <a:t> pulls raw </a:t>
+            </a:r>
+            <a:r>
+              <a:rPr lang="en-US" sz="1200" b="0" i="0" kern="1200" dirty="0" err="1">
                 <a:solidFill>
                   <a:schemeClr val="tx1"/>
                 </a:solidFill>
@@ -4163,10 +4325,10 @@
                 <a:ea typeface="+mn-ea"/>
                 <a:cs typeface="+mn-cs"/>
               </a:rPr>
-              <a:t> shards from Waymo's Google Cloud Storage bucket and extracts a tabular feature set for over </a:t>
-            </a:r>
-            <a:r>
-              <a:rPr lang="en-US" sz="1200" b="1" i="0" kern="1200" dirty="0">
+              <a:t>TFRecord</a:t>
+            </a:r>
+            <a:r>
+              <a:rPr lang="en-US" sz="1200" b="0" i="0" kern="1200" dirty="0">
                 <a:solidFill>
                   <a:schemeClr val="tx1"/>
                 </a:solidFill>
@@ -4175,10 +4337,10 @@
                 <a:ea typeface="+mn-ea"/>
                 <a:cs typeface="+mn-cs"/>
               </a:rPr>
-              <a:t>18,000 agents</a:t>
-            </a:r>
-            <a:r>
-              <a:rPr lang="en-US" sz="1200" b="0" i="0" kern="1200" dirty="0">
+              <a:t> shards from Waymo's Google Cloud Storage bucket and extracts a tabular feature set for over </a:t>
+            </a:r>
+            <a:r>
+              <a:rPr lang="en-US" sz="1200" b="1" i="0" kern="1200" dirty="0">
                 <a:solidFill>
                   <a:schemeClr val="tx1"/>
                 </a:solidFill>
@@ -4187,10 +4349,8 @@
                 <a:ea typeface="+mn-ea"/>
                 <a:cs typeface="+mn-cs"/>
               </a:rPr>
-              <a:t> across hundreds of scenarios. We extract the kinematic state at the prediction moment: speed, acceleration, yaw rate, velocity components, and the future 5-second displacement.</a:t>
-            </a:r>
-          </a:p>
-          <a:p>
+              <a:t>18,000 agents</a:t>
+            </a:r>
             <a:r>
               <a:rPr lang="en-US" sz="1200" b="0" i="0" kern="1200" dirty="0">
                 <a:solidFill>
@@ -4201,8 +4361,131 @@
                 <a:ea typeface="+mn-ea"/>
                 <a:cs typeface="+mn-cs"/>
               </a:rPr>
+              <a:t> across hundreds of scenarios. </a:t>
+            </a:r>
+          </a:p>
+          <a:p>
+            <a:endParaRPr lang="en-US" sz="1200" b="0" i="0" kern="1200" dirty="0">
+              <a:solidFill>
+                <a:schemeClr val="tx1"/>
+              </a:solidFill>
+              <a:effectLst/>
+              <a:latin typeface="+mn-lt"/>
+              <a:ea typeface="+mn-ea"/>
+              <a:cs typeface="+mn-cs"/>
+            </a:endParaRPr>
+          </a:p>
+          <a:p>
+            <a:r>
+              <a:rPr lang="en-US" sz="1200" b="0" i="0" kern="1200" dirty="0">
+                <a:solidFill>
+                  <a:schemeClr val="tx1"/>
+                </a:solidFill>
+                <a:effectLst/>
+                <a:latin typeface="+mn-lt"/>
+                <a:ea typeface="+mn-ea"/>
+                <a:cs typeface="+mn-cs"/>
+              </a:rPr>
+              <a:t>We extract the kinematic state at the prediction moment: speed, acceleration, yaw rate, velocity components, and the future 5-second displacement.</a:t>
+            </a:r>
+          </a:p>
+          <a:p>
+            <a:r>
+              <a:rPr lang="en-US" sz="1200" b="0" i="0" kern="1200" dirty="0">
+                <a:solidFill>
+                  <a:schemeClr val="tx1"/>
+                </a:solidFill>
+                <a:effectLst/>
+                <a:latin typeface="+mn-lt"/>
+                <a:ea typeface="+mn-ea"/>
+                <a:cs typeface="+mn-cs"/>
+              </a:rPr>
               <a:t>That CSV then flows into R, where all statistical modeling happens.</a:t>
             </a:r>
+          </a:p>
+          <a:p>
+            <a:endParaRPr lang="en-US" sz="1200" b="1" i="0" kern="1200" dirty="0">
+              <a:solidFill>
+                <a:schemeClr val="tx1"/>
+              </a:solidFill>
+              <a:effectLst/>
+              <a:latin typeface="+mn-lt"/>
+              <a:ea typeface="+mn-ea"/>
+              <a:cs typeface="+mn-cs"/>
+            </a:endParaRPr>
+          </a:p>
+          <a:p>
+            <a:r>
+              <a:rPr lang="en-US" sz="1200" b="0" i="0" kern="1200" dirty="0">
+                <a:solidFill>
+                  <a:schemeClr val="tx1"/>
+                </a:solidFill>
+                <a:effectLst/>
+                <a:latin typeface="+mn-lt"/>
+                <a:ea typeface="+mn-ea"/>
+                <a:cs typeface="+mn-cs"/>
+              </a:rPr>
+              <a:t>The two analyses use different preprocessing. For anomaly detection, we apply the strictest filter: valid sensor frames only, stationary agents removed, and complete cases across all kinematic and geometric features — leaving </a:t>
+            </a:r>
+            <a:r>
+              <a:rPr lang="en-US" sz="1200" b="1" i="0" kern="1200" dirty="0">
+                <a:solidFill>
+                  <a:schemeClr val="tx1"/>
+                </a:solidFill>
+                <a:effectLst/>
+                <a:latin typeface="+mn-lt"/>
+                <a:ea typeface="+mn-ea"/>
+                <a:cs typeface="+mn-cs"/>
+              </a:rPr>
+              <a:t>4,538 moving agents</a:t>
+            </a:r>
+            <a:r>
+              <a:rPr lang="en-US" sz="1200" b="0" i="0" kern="1200" dirty="0">
+                <a:solidFill>
+                  <a:schemeClr val="tx1"/>
+                </a:solidFill>
+                <a:effectLst/>
+                <a:latin typeface="+mn-lt"/>
+                <a:ea typeface="+mn-ea"/>
+                <a:cs typeface="+mn-cs"/>
+              </a:rPr>
+              <a:t>. For regression, the goal is different — we actually want to compare behavior with and without stationary agents — so we start from a more permissive filter: NA removal only, no speed cutoff. That gives us </a:t>
+            </a:r>
+            <a:r>
+              <a:rPr lang="en-US" sz="1200" b="1" i="0" kern="1200" dirty="0">
+                <a:solidFill>
+                  <a:schemeClr val="tx1"/>
+                </a:solidFill>
+                <a:effectLst/>
+                <a:latin typeface="+mn-lt"/>
+                <a:ea typeface="+mn-ea"/>
+                <a:cs typeface="+mn-cs"/>
+              </a:rPr>
+              <a:t>6,614 agents</a:t>
+            </a:r>
+            <a:r>
+              <a:rPr lang="en-US" sz="1200" b="0" i="0" kern="1200" dirty="0">
+                <a:solidFill>
+                  <a:schemeClr val="tx1"/>
+                </a:solidFill>
+                <a:effectLst/>
+                <a:latin typeface="+mn-lt"/>
+                <a:ea typeface="+mn-ea"/>
+                <a:cs typeface="+mn-cs"/>
+              </a:rPr>
+              <a:t> including stationary ones, which we then split into two conditions for the comparison.</a:t>
+            </a:r>
+          </a:p>
+          <a:p>
+            <a:endParaRPr lang="en-US" sz="1200" b="0" i="0" kern="1200" dirty="0">
+              <a:solidFill>
+                <a:schemeClr val="tx1"/>
+              </a:solidFill>
+              <a:effectLst/>
+              <a:latin typeface="+mn-lt"/>
+              <a:ea typeface="+mn-ea"/>
+              <a:cs typeface="+mn-cs"/>
+            </a:endParaRPr>
           </a:p>
         </p:txBody>
       </p:sp>
@@ -4320,7 +4603,7 @@
                 <a:ea typeface="+mn-ea"/>
                 <a:cs typeface="+mn-cs"/>
               </a:rPr>
-              <a:t>PAVEL:</a:t>
+              <a:t>JUSTIN:</a:t>
             </a:r>
           </a:p>
           <a:p>
@@ -4345,10 +4628,12 @@
                 <a:ea typeface="+mn-ea"/>
                 <a:cs typeface="+mn-cs"/>
               </a:rPr>
-              <a:t>The two analyses use different preprocessing. For anomaly detection, we apply the strictest filter: valid sensor frames only, stationary agents removed, and complete cases across all kinematic and geometric features — leaving </a:t>
-            </a:r>
-            <a:r>
-              <a:rPr lang="en-US" sz="1200" b="1" i="0" kern="1200" dirty="0">
+              <a:t>Before diving into the models, let me give you a sense of what this data actually looks like.</a:t>
+            </a:r>
+          </a:p>
+          <a:p>
+            <a:r>
+              <a:rPr lang="en-US" sz="1200" b="0" i="0" kern="1200" dirty="0">
                 <a:solidFill>
                   <a:schemeClr val="tx1"/>
                 </a:solidFill>
@@ -4357,10 +4642,10 @@
                 <a:ea typeface="+mn-ea"/>
                 <a:cs typeface="+mn-cs"/>
               </a:rPr>
-              <a:t>4,538 moving agents</a:t>
-            </a:r>
-            <a:r>
-              <a:rPr lang="en-US" sz="1200" b="0" i="0" kern="1200" dirty="0">
+              <a:t>We extracted from </a:t>
+            </a:r>
+            <a:r>
+              <a:rPr lang="en-US" sz="1200" b="1" i="0" kern="1200" dirty="0">
                 <a:solidFill>
                   <a:schemeClr val="tx1"/>
                 </a:solidFill>
@@ -4369,10 +4654,10 @@
                 <a:ea typeface="+mn-ea"/>
                 <a:cs typeface="+mn-cs"/>
               </a:rPr>
-              <a:t>. For regression, the goal is different — we actually want to compare behavior with and without stationary agents — so we start from a more permissive filter: NA removal only, no speed cutoff. That gives us </a:t>
-            </a:r>
-            <a:r>
-              <a:rPr lang="en-US" sz="1200" b="1" i="0" kern="1200" dirty="0">
+              <a:t>300 scenarios</a:t>
+            </a:r>
+            <a:r>
+              <a:rPr lang="en-US" sz="1200" b="0" i="0" kern="1200" dirty="0">
                 <a:solidFill>
                   <a:schemeClr val="tx1"/>
                 </a:solidFill>
@@ -4381,10 +4666,10 @@
                 <a:ea typeface="+mn-ea"/>
                 <a:cs typeface="+mn-cs"/>
               </a:rPr>
-              <a:t>6,614 agents</a:t>
-            </a:r>
-            <a:r>
-              <a:rPr lang="en-US" sz="1200" b="0" i="0" kern="1200" dirty="0">
+              <a:t> from the validation split of the Waymo Open Motion Dataset — specifically shard 00000-of-00150. That gives us </a:t>
+            </a:r>
+            <a:r>
+              <a:rPr lang="en-US" sz="1200" b="1" i="0" kern="1200" dirty="0">
                 <a:solidFill>
                   <a:schemeClr val="tx1"/>
                 </a:solidFill>
@@ -4393,7 +4678,109 @@
                 <a:ea typeface="+mn-ea"/>
                 <a:cs typeface="+mn-cs"/>
               </a:rPr>
-              <a:t> including stationary ones, which we then split into two conditions for the comparison.</a:t>
+              <a:t>18,311 raw agent observations</a:t>
+            </a:r>
+            <a:r>
+              <a:rPr lang="en-US" sz="1200" b="0" i="0" kern="1200" dirty="0">
+                <a:solidFill>
+                  <a:schemeClr val="tx1"/>
+                </a:solidFill>
+                <a:effectLst/>
+                <a:latin typeface="+mn-lt"/>
+                <a:ea typeface="+mn-ea"/>
+                <a:cs typeface="+mn-cs"/>
+              </a:rPr>
+              <a:t> across vehicles, pedestrians, cyclists, and the Waymo self-driving car itself, which we exclude from all analysis.</a:t>
+            </a:r>
+          </a:p>
+          <a:p>
+            <a:r>
+              <a:rPr lang="en-US" sz="1200" b="0" i="0" kern="1200" dirty="0">
+                <a:solidFill>
+                  <a:schemeClr val="tx1"/>
+                </a:solidFill>
+                <a:effectLst/>
+                <a:latin typeface="+mn-lt"/>
+                <a:ea typeface="+mn-ea"/>
+                <a:cs typeface="+mn-cs"/>
+              </a:rPr>
+              <a:t>In terms of composition: vehicles make up the clear majority of the dataset, pedestrians account for roughly 25%, and cyclists around 5%. This imbalance matters because it affects both the anomaly detection and how we interpret per-class statistics.</a:t>
+            </a:r>
+          </a:p>
+          <a:p>
+            <a:r>
+              <a:rPr lang="en-US" sz="1200" b="0" i="0" kern="1200" dirty="0">
+                <a:solidFill>
+                  <a:schemeClr val="tx1"/>
+                </a:solidFill>
+                <a:effectLst/>
+                <a:latin typeface="+mn-lt"/>
+                <a:ea typeface="+mn-ea"/>
+                <a:cs typeface="+mn-cs"/>
+              </a:rPr>
+              <a:t>A few things worth noting about the raw data before any filtering. When you look at mean speeds including stationary agents, vehicles actually appear slower than cyclists — counterintuitive, and it's entirely because a large fraction of vehicles are stopped at intersections. The moment you filter to moving agents only, the expected ordering returns: vehicles fastest, then cyclists, then pedestrians.</a:t>
+            </a:r>
+          </a:p>
+          <a:p>
+            <a:r>
+              <a:rPr lang="en-US" sz="1200" b="0" i="0" kern="1200" dirty="0">
+                <a:solidFill>
+                  <a:schemeClr val="tx1"/>
+                </a:solidFill>
+                <a:effectLst/>
+                <a:latin typeface="+mn-lt"/>
+                <a:ea typeface="+mn-ea"/>
+                <a:cs typeface="+mn-cs"/>
+              </a:rPr>
+              <a:t>Waymo also provides behavioral flags: </a:t>
+            </a:r>
+            <a:r>
+              <a:rPr lang="en-US" sz="1200" b="0" i="0" kern="1200" dirty="0" err="1">
+                <a:solidFill>
+                  <a:schemeClr val="tx1"/>
+                </a:solidFill>
+                <a:effectLst/>
+                <a:latin typeface="+mn-lt"/>
+                <a:ea typeface="+mn-ea"/>
+                <a:cs typeface="+mn-cs"/>
+              </a:rPr>
+              <a:t>IsInteractive</a:t>
+            </a:r>
+            <a:r>
+              <a:rPr lang="en-US" sz="1200" b="0" i="0" kern="1200" dirty="0">
+                <a:solidFill>
+                  <a:schemeClr val="tx1"/>
+                </a:solidFill>
+                <a:effectLst/>
+                <a:latin typeface="+mn-lt"/>
+                <a:ea typeface="+mn-ea"/>
+                <a:cs typeface="+mn-cs"/>
+              </a:rPr>
+              <a:t> marks agents relevant to the AV's immediate planning — typically nearby vehicles in adjacent lanes or at intersections. </a:t>
+            </a:r>
+            <a:r>
+              <a:rPr lang="en-US" sz="1200" b="0" i="0" kern="1200" dirty="0" err="1">
+                <a:solidFill>
+                  <a:schemeClr val="tx1"/>
+                </a:solidFill>
+                <a:effectLst/>
+                <a:latin typeface="+mn-lt"/>
+                <a:ea typeface="+mn-ea"/>
+                <a:cs typeface="+mn-cs"/>
+              </a:rPr>
+              <a:t>IsSDC</a:t>
+            </a:r>
+            <a:r>
+              <a:rPr lang="en-US" sz="1200" b="0" i="0" kern="1200" dirty="0">
+                <a:solidFill>
+                  <a:schemeClr val="tx1"/>
+                </a:solidFill>
+                <a:effectLst/>
+                <a:latin typeface="+mn-lt"/>
+                <a:ea typeface="+mn-ea"/>
+                <a:cs typeface="+mn-cs"/>
+              </a:rPr>
+              <a:t> identifies the self-driving car itself. These flags are not safety-incident labels — they're proximity-based planning annotations — and that distinction will matter when we interpret the anomaly results.</a:t>
             </a:r>
           </a:p>
           <a:p>
@@ -20879,9 +21266,6 @@
             </a:pPr>
             <a:r>
               <a:rPr lang="en-US" b="0" i="0" dirty="0">
-                <a:solidFill>
-                  <a:schemeClr val="bg1"/>
-                </a:solidFill>
                 <a:effectLst/>
                 <a:latin typeface="GT Walsheim Trial Rg" pitchFamily="2" charset="77"/>
               </a:rPr>
@@ -21207,6 +21591,93 @@
           </a:extLst>
         </p:spPr>
       </p:pic>
+      <p:sp>
+        <p:nvSpPr>
+          <p:cNvPr id="3" name="TextBox 2">
+            <a:extLst>
+              <a:ext uri="{FF2B5EF4-FFF2-40B4-BE49-F238E27FC236}">
+                <a16:creationId xmlns:a16="http://schemas.microsoft.com/office/drawing/2014/main" id="{6FF11A2A-EA04-CBEA-5259-2D7D1F89B0FD}"/>
+              </a:ext>
+            </a:extLst>
+          </p:cNvPr>
+          <p:cNvSpPr txBox="1"/>
+          <p:nvPr/>
+        </p:nvSpPr>
+        <p:spPr>
+          <a:xfrm>
+            <a:off x="2014302" y="6400034"/>
+            <a:ext cx="8266142" cy="323165"/>
+          </a:xfrm>
+          <a:prstGeom prst="rect">
+            <a:avLst/>
+          </a:prstGeom>
+          <a:noFill/>
+        </p:spPr>
+        <p:txBody>
+          <a:bodyPr wrap="square">
+            <a:spAutoFit/>
+          </a:bodyPr>
+          <a:lstStyle/>
+          <a:p>
+            <a:pPr algn="ctr"/>
+            <a:r>
+              <a:rPr lang="en-US" sz="1500" dirty="0">
+                <a:solidFill>
+                  <a:schemeClr val="bg1">
+                    <a:lumMod val="50000"/>
+                  </a:schemeClr>
+                </a:solidFill>
+                <a:latin typeface="GT Walsheim Trial Rg" pitchFamily="2" charset="77"/>
+              </a:rPr>
+              <a:t>*Features extracted: Speed, Acceleration, Yaw Rate, </a:t>
+            </a:r>
+            <a:r>
+              <a:rPr lang="en-US" sz="1500" dirty="0" err="1">
+                <a:solidFill>
+                  <a:schemeClr val="bg1">
+                    <a:lumMod val="50000"/>
+                  </a:schemeClr>
+                </a:solidFill>
+                <a:latin typeface="GT Walsheim Trial Rg" pitchFamily="2" charset="77"/>
+              </a:rPr>
+              <a:t>Vel_X</a:t>
+            </a:r>
+            <a:r>
+              <a:rPr lang="en-US" sz="1500" dirty="0">
+                <a:solidFill>
+                  <a:schemeClr val="bg1">
+                    <a:lumMod val="50000"/>
+                  </a:schemeClr>
+                </a:solidFill>
+                <a:latin typeface="GT Walsheim Trial Rg" pitchFamily="2" charset="77"/>
+              </a:rPr>
+              <a:t>, </a:t>
+            </a:r>
+            <a:r>
+              <a:rPr lang="en-US" sz="1500" dirty="0" err="1">
+                <a:solidFill>
+                  <a:schemeClr val="bg1">
+                    <a:lumMod val="50000"/>
+                  </a:schemeClr>
+                </a:solidFill>
+                <a:latin typeface="GT Walsheim Trial Rg" pitchFamily="2" charset="77"/>
+              </a:rPr>
+              <a:t>Vel_Y</a:t>
+            </a:r>
+            <a:r>
+              <a:rPr lang="en-US" sz="1500" dirty="0">
+                <a:solidFill>
+                  <a:schemeClr val="bg1">
+                    <a:lumMod val="50000"/>
+                  </a:schemeClr>
+                </a:solidFill>
+                <a:latin typeface="GT Walsheim Trial Rg" pitchFamily="2" charset="77"/>
+              </a:rPr>
+              <a:t> Length, Width, FutureDist_5s</a:t>
+            </a:r>
+          </a:p>
+        </p:txBody>
+      </p:sp>
     </p:spTree>
     <p:extLst>
       <p:ext uri="{BB962C8B-B14F-4D97-AF65-F5344CB8AC3E}">
@@ -21226,7 +21697,7 @@
     <p:bg>
       <p:bgPr>
         <a:solidFill>
-          <a:schemeClr val="tx1"/>
+          <a:schemeClr val="bg1"/>
         </a:solidFill>
         <a:effectLst/>
       </p:bgPr>
@@ -21253,10 +21724,1148 @@
       </p:grpSpPr>
       <p:sp>
         <p:nvSpPr>
-          <p:cNvPr id="5" name="Freeform 4">
+          <p:cNvPr id="4" name="Title 3">
             <a:extLst>
               <a:ext uri="{FF2B5EF4-FFF2-40B4-BE49-F238E27FC236}">
-                <a16:creationId xmlns:a16="http://schemas.microsoft.com/office/drawing/2014/main" id="{1A7F5B05-687E-2A4C-A8CD-9F064CE84592}"/>
+                <a16:creationId xmlns:a16="http://schemas.microsoft.com/office/drawing/2014/main" id="{03C362FE-26C6-9E59-253C-0E8E33DFB89E}"/>
+              </a:ext>
+            </a:extLst>
+          </p:cNvPr>
+          <p:cNvSpPr>
+            <a:spLocks noGrp="1"/>
+          </p:cNvSpPr>
+          <p:nvPr>
+            <p:ph type="ctrTitle"/>
+          </p:nvPr>
+        </p:nvSpPr>
+        <p:spPr>
+          <a:xfrm>
+            <a:off x="716478" y="447821"/>
+            <a:ext cx="3347522" cy="369333"/>
+          </a:xfrm>
+        </p:spPr>
+        <p:txBody>
+          <a:bodyPr>
+            <a:normAutofit/>
+          </a:bodyPr>
+          <a:lstStyle/>
+          <a:p>
+            <a:pPr algn="l"/>
+            <a:r>
+              <a:rPr lang="en-US" sz="1500" dirty="0">
+                <a:latin typeface="GT Walsheim Trial Rg" pitchFamily="2" charset="77"/>
+              </a:rPr>
+              <a:t>DATASET STATISTICS</a:t>
+            </a:r>
+          </a:p>
+        </p:txBody>
+      </p:sp>
+      <p:sp>
+        <p:nvSpPr>
+          <p:cNvPr id="8" name="TextBox 7">
+            <a:extLst>
+              <a:ext uri="{FF2B5EF4-FFF2-40B4-BE49-F238E27FC236}">
+                <a16:creationId xmlns:a16="http://schemas.microsoft.com/office/drawing/2014/main" id="{AA0B286F-ACC4-E15E-FE10-F81A14DF3948}"/>
+              </a:ext>
+            </a:extLst>
+          </p:cNvPr>
+          <p:cNvSpPr txBox="1"/>
+          <p:nvPr/>
+        </p:nvSpPr>
+        <p:spPr>
+          <a:xfrm>
+            <a:off x="716477" y="952090"/>
+            <a:ext cx="7346867" cy="630942"/>
+          </a:xfrm>
+          <a:prstGeom prst="rect">
+            <a:avLst/>
+          </a:prstGeom>
+          <a:noFill/>
+        </p:spPr>
+        <p:txBody>
+          <a:bodyPr wrap="square">
+            <a:spAutoFit/>
+          </a:bodyPr>
+          <a:lstStyle/>
+          <a:p>
+            <a:r>
+              <a:rPr lang="en-US" sz="3500" dirty="0">
+                <a:latin typeface="GT Walsheim Trial Rg" pitchFamily="2" charset="77"/>
+              </a:rPr>
+              <a:t>What the Data Looks Like</a:t>
+            </a:r>
+          </a:p>
+        </p:txBody>
+      </p:sp>
+      <p:graphicFrame>
+        <p:nvGraphicFramePr>
+          <p:cNvPr id="3" name="Table 2">
+            <a:extLst>
+              <a:ext uri="{FF2B5EF4-FFF2-40B4-BE49-F238E27FC236}">
+                <a16:creationId xmlns:a16="http://schemas.microsoft.com/office/drawing/2014/main" id="{6E5ED46D-9A9D-45B4-50C0-E4B617433E8C}"/>
+              </a:ext>
+            </a:extLst>
+          </p:cNvPr>
+          <p:cNvGraphicFramePr>
+            <a:graphicFrameLocks noGrp="1"/>
+          </p:cNvGraphicFramePr>
+          <p:nvPr>
+            <p:extLst>
+              <p:ext uri="{D42A27DB-BD31-4B8C-83A1-F6EECF244321}">
+                <p14:modId xmlns:p14="http://schemas.microsoft.com/office/powerpoint/2010/main" val="3111455078"/>
+              </p:ext>
+            </p:extLst>
+          </p:nvPr>
+        </p:nvGraphicFramePr>
+        <p:xfrm>
+          <a:off x="716478" y="1932132"/>
+          <a:ext cx="5117164" cy="2247981"/>
+        </p:xfrm>
+        <a:graphic>
+          <a:graphicData uri="http://schemas.openxmlformats.org/drawingml/2006/table">
+            <a:tbl>
+              <a:tblPr firstRow="1" bandRow="1">
+                <a:tableStyleId>{073A0DAA-6AF3-43AB-8588-CEC1D06C72B9}</a:tableStyleId>
+              </a:tblPr>
+              <a:tblGrid>
+                <a:gridCol w="1671122">
+                  <a:extLst>
+                    <a:ext uri="{9D8B030D-6E8A-4147-A177-3AD203B41FA5}">
+                      <a16:colId xmlns:a16="http://schemas.microsoft.com/office/drawing/2014/main" val="1610543496"/>
+                    </a:ext>
+                  </a:extLst>
+                </a:gridCol>
+                <a:gridCol w="1253067">
+                  <a:extLst>
+                    <a:ext uri="{9D8B030D-6E8A-4147-A177-3AD203B41FA5}">
+                      <a16:colId xmlns:a16="http://schemas.microsoft.com/office/drawing/2014/main" val="2940384537"/>
+                    </a:ext>
+                  </a:extLst>
+                </a:gridCol>
+                <a:gridCol w="2192975">
+                  <a:extLst>
+                    <a:ext uri="{9D8B030D-6E8A-4147-A177-3AD203B41FA5}">
+                      <a16:colId xmlns:a16="http://schemas.microsoft.com/office/drawing/2014/main" val="3740313691"/>
+                    </a:ext>
+                  </a:extLst>
+                </a:gridCol>
+              </a:tblGrid>
+              <a:tr h="334565">
+                <a:tc>
+                  <a:txBody>
+                    <a:bodyPr/>
+                    <a:lstStyle/>
+                    <a:p>
+                      <a:r>
+                        <a:rPr lang="en-US" sz="1500" b="0" i="0" dirty="0">
+                          <a:solidFill>
+                            <a:schemeClr val="bg1"/>
+                          </a:solidFill>
+                          <a:latin typeface="GT Walsheim Trial Rg" pitchFamily="2" charset="77"/>
+                        </a:rPr>
+                        <a:t>Agent Type</a:t>
+                      </a:r>
+                    </a:p>
+                  </a:txBody>
+                  <a:tcPr>
+                    <a:lnL w="12700" cap="flat" cmpd="sng" algn="ctr">
+                      <a:noFill/>
+                      <a:prstDash val="solid"/>
+                      <a:round/>
+                      <a:headEnd type="none" w="med" len="med"/>
+                      <a:tailEnd type="none" w="med" len="med"/>
+                    </a:lnL>
+                    <a:lnR w="12700" cap="flat" cmpd="sng" algn="ctr">
+                      <a:noFill/>
+                      <a:prstDash val="solid"/>
+                      <a:round/>
+                      <a:headEnd type="none" w="med" len="med"/>
+                      <a:tailEnd type="none" w="med" len="med"/>
+                    </a:lnR>
+                    <a:lnT w="12700" cap="flat" cmpd="sng" algn="ctr">
+                      <a:noFill/>
+                      <a:prstDash val="solid"/>
+                      <a:round/>
+                      <a:headEnd type="none" w="med" len="med"/>
+                      <a:tailEnd type="none" w="med" len="med"/>
+                    </a:lnT>
+                    <a:lnB w="12700" cap="flat" cmpd="sng" algn="ctr">
+                      <a:noFill/>
+                      <a:prstDash val="solid"/>
+                      <a:round/>
+                      <a:headEnd type="none" w="med" len="med"/>
+                      <a:tailEnd type="none" w="med" len="med"/>
+                    </a:lnB>
+                    <a:lnTlToBr w="12700" cmpd="sng">
+                      <a:noFill/>
+                      <a:prstDash val="solid"/>
+                    </a:lnTlToBr>
+                    <a:lnBlToTr w="12700" cmpd="sng">
+                      <a:noFill/>
+                      <a:prstDash val="solid"/>
+                    </a:lnBlToTr>
+                    <a:solidFill>
+                      <a:srgbClr val="0078FF"/>
+                    </a:solidFill>
+                  </a:tcPr>
+                </a:tc>
+                <a:tc>
+                  <a:txBody>
+                    <a:bodyPr/>
+                    <a:lstStyle/>
+                    <a:p>
+                      <a:r>
+                        <a:rPr lang="en-US" sz="1500" b="0" i="0" dirty="0">
+                          <a:solidFill>
+                            <a:schemeClr val="bg1"/>
+                          </a:solidFill>
+                          <a:latin typeface="GT Walsheim Trial Rg" pitchFamily="2" charset="77"/>
+                        </a:rPr>
+                        <a:t>Count (raw)</a:t>
+                      </a:r>
+                    </a:p>
+                  </a:txBody>
+                  <a:tcPr>
+                    <a:lnL w="12700" cap="flat" cmpd="sng" algn="ctr">
+                      <a:noFill/>
+                      <a:prstDash val="solid"/>
+                      <a:round/>
+                      <a:headEnd type="none" w="med" len="med"/>
+                      <a:tailEnd type="none" w="med" len="med"/>
+                    </a:lnL>
+                    <a:lnR w="12700" cap="flat" cmpd="sng" algn="ctr">
+                      <a:noFill/>
+                      <a:prstDash val="solid"/>
+                      <a:round/>
+                      <a:headEnd type="none" w="med" len="med"/>
+                      <a:tailEnd type="none" w="med" len="med"/>
+                    </a:lnR>
+                    <a:lnT w="12700" cap="flat" cmpd="sng" algn="ctr">
+                      <a:noFill/>
+                      <a:prstDash val="solid"/>
+                      <a:round/>
+                      <a:headEnd type="none" w="med" len="med"/>
+                      <a:tailEnd type="none" w="med" len="med"/>
+                    </a:lnT>
+                    <a:lnB w="12700" cap="flat" cmpd="sng" algn="ctr">
+                      <a:noFill/>
+                      <a:prstDash val="solid"/>
+                      <a:round/>
+                      <a:headEnd type="none" w="med" len="med"/>
+                      <a:tailEnd type="none" w="med" len="med"/>
+                    </a:lnB>
+                    <a:lnTlToBr w="12700" cmpd="sng">
+                      <a:noFill/>
+                      <a:prstDash val="solid"/>
+                    </a:lnTlToBr>
+                    <a:lnBlToTr w="12700" cmpd="sng">
+                      <a:noFill/>
+                      <a:prstDash val="solid"/>
+                    </a:lnBlToTr>
+                    <a:solidFill>
+                      <a:srgbClr val="0078FF"/>
+                    </a:solidFill>
+                  </a:tcPr>
+                </a:tc>
+                <a:tc>
+                  <a:txBody>
+                    <a:bodyPr/>
+                    <a:lstStyle/>
+                    <a:p>
+                      <a:r>
+                        <a:rPr lang="en-US" sz="1500" b="0" i="0" dirty="0">
+                          <a:solidFill>
+                            <a:schemeClr val="bg1"/>
+                          </a:solidFill>
+                          <a:latin typeface="GT Walsheim Trial Rg" pitchFamily="2" charset="77"/>
+                        </a:rPr>
+                        <a:t>After preprocessing</a:t>
+                      </a:r>
+                    </a:p>
+                  </a:txBody>
+                  <a:tcPr>
+                    <a:lnL w="12700" cap="flat" cmpd="sng" algn="ctr">
+                      <a:noFill/>
+                      <a:prstDash val="solid"/>
+                      <a:round/>
+                      <a:headEnd type="none" w="med" len="med"/>
+                      <a:tailEnd type="none" w="med" len="med"/>
+                    </a:lnL>
+                    <a:lnR w="12700" cap="flat" cmpd="sng" algn="ctr">
+                      <a:noFill/>
+                      <a:prstDash val="solid"/>
+                      <a:round/>
+                      <a:headEnd type="none" w="med" len="med"/>
+                      <a:tailEnd type="none" w="med" len="med"/>
+                    </a:lnR>
+                    <a:lnT w="12700" cap="flat" cmpd="sng" algn="ctr">
+                      <a:noFill/>
+                      <a:prstDash val="solid"/>
+                      <a:round/>
+                      <a:headEnd type="none" w="med" len="med"/>
+                      <a:tailEnd type="none" w="med" len="med"/>
+                    </a:lnT>
+                    <a:lnB w="12700" cap="flat" cmpd="sng" algn="ctr">
+                      <a:noFill/>
+                      <a:prstDash val="solid"/>
+                      <a:round/>
+                      <a:headEnd type="none" w="med" len="med"/>
+                      <a:tailEnd type="none" w="med" len="med"/>
+                    </a:lnB>
+                    <a:lnTlToBr w="12700" cmpd="sng">
+                      <a:noFill/>
+                      <a:prstDash val="solid"/>
+                    </a:lnTlToBr>
+                    <a:lnBlToTr w="12700" cmpd="sng">
+                      <a:noFill/>
+                      <a:prstDash val="solid"/>
+                    </a:lnBlToTr>
+                    <a:solidFill>
+                      <a:srgbClr val="0078FF"/>
+                    </a:solidFill>
+                  </a:tcPr>
+                </a:tc>
+                <a:extLst>
+                  <a:ext uri="{0D108BD9-81ED-4DB2-BD59-A6C34878D82A}">
+                    <a16:rowId xmlns:a16="http://schemas.microsoft.com/office/drawing/2014/main" val="4220759275"/>
+                  </a:ext>
+                </a:extLst>
+              </a:tr>
+              <a:tr h="446626">
+                <a:tc>
+                  <a:txBody>
+                    <a:bodyPr/>
+                    <a:lstStyle/>
+                    <a:p>
+                      <a:r>
+                        <a:rPr lang="en-US" sz="1500" b="0" i="0" dirty="0">
+                          <a:solidFill>
+                            <a:schemeClr val="tx1"/>
+                          </a:solidFill>
+                          <a:latin typeface="GT Walsheim Trial Rg" pitchFamily="2" charset="77"/>
+                        </a:rPr>
+                        <a:t>Vehicle</a:t>
+                      </a:r>
+                    </a:p>
+                  </a:txBody>
+                  <a:tcPr>
+                    <a:lnL w="12700" cap="flat" cmpd="sng" algn="ctr">
+                      <a:noFill/>
+                      <a:prstDash val="solid"/>
+                      <a:round/>
+                      <a:headEnd type="none" w="med" len="med"/>
+                      <a:tailEnd type="none" w="med" len="med"/>
+                    </a:lnL>
+                    <a:lnR w="12700" cap="flat" cmpd="sng" algn="ctr">
+                      <a:noFill/>
+                      <a:prstDash val="solid"/>
+                      <a:round/>
+                      <a:headEnd type="none" w="med" len="med"/>
+                      <a:tailEnd type="none" w="med" len="med"/>
+                    </a:lnR>
+                    <a:lnT w="12700" cap="flat" cmpd="sng" algn="ctr">
+                      <a:noFill/>
+                      <a:prstDash val="solid"/>
+                      <a:round/>
+                      <a:headEnd type="none" w="med" len="med"/>
+                      <a:tailEnd type="none" w="med" len="med"/>
+                    </a:lnT>
+                    <a:lnB w="12700" cap="flat" cmpd="sng" algn="ctr">
+                      <a:noFill/>
+                      <a:prstDash val="solid"/>
+                      <a:round/>
+                      <a:headEnd type="none" w="med" len="med"/>
+                      <a:tailEnd type="none" w="med" len="med"/>
+                    </a:lnB>
+                    <a:lnTlToBr w="12700" cmpd="sng">
+                      <a:noFill/>
+                      <a:prstDash val="solid"/>
+                    </a:lnTlToBr>
+                    <a:lnBlToTr w="12700" cmpd="sng">
+                      <a:noFill/>
+                      <a:prstDash val="solid"/>
+                    </a:lnBlToTr>
+                    <a:solidFill>
+                      <a:schemeClr val="bg1">
+                        <a:lumMod val="95000"/>
+                      </a:schemeClr>
+                    </a:solidFill>
+                  </a:tcPr>
+                </a:tc>
+                <a:tc>
+                  <a:txBody>
+                    <a:bodyPr/>
+                    <a:lstStyle/>
+                    <a:p>
+                      <a:r>
+                        <a:rPr lang="en-US" sz="1500" b="0" i="0" dirty="0">
+                          <a:solidFill>
+                            <a:schemeClr val="tx1"/>
+                          </a:solidFill>
+                          <a:latin typeface="GT Walsheim Trial Rg" pitchFamily="2" charset="77"/>
+                        </a:rPr>
+                        <a:t>majority</a:t>
+                      </a:r>
+                    </a:p>
+                  </a:txBody>
+                  <a:tcPr>
+                    <a:lnL w="12700" cap="flat" cmpd="sng" algn="ctr">
+                      <a:noFill/>
+                      <a:prstDash val="solid"/>
+                      <a:round/>
+                      <a:headEnd type="none" w="med" len="med"/>
+                      <a:tailEnd type="none" w="med" len="med"/>
+                    </a:lnL>
+                    <a:lnR w="12700" cap="flat" cmpd="sng" algn="ctr">
+                      <a:noFill/>
+                      <a:prstDash val="solid"/>
+                      <a:round/>
+                      <a:headEnd type="none" w="med" len="med"/>
+                      <a:tailEnd type="none" w="med" len="med"/>
+                    </a:lnR>
+                    <a:lnT w="12700" cap="flat" cmpd="sng" algn="ctr">
+                      <a:noFill/>
+                      <a:prstDash val="solid"/>
+                      <a:round/>
+                      <a:headEnd type="none" w="med" len="med"/>
+                      <a:tailEnd type="none" w="med" len="med"/>
+                    </a:lnT>
+                    <a:lnB w="12700" cap="flat" cmpd="sng" algn="ctr">
+                      <a:noFill/>
+                      <a:prstDash val="solid"/>
+                      <a:round/>
+                      <a:headEnd type="none" w="med" len="med"/>
+                      <a:tailEnd type="none" w="med" len="med"/>
+                    </a:lnB>
+                    <a:lnTlToBr w="12700" cmpd="sng">
+                      <a:noFill/>
+                      <a:prstDash val="solid"/>
+                    </a:lnTlToBr>
+                    <a:lnBlToTr w="12700" cmpd="sng">
+                      <a:noFill/>
+                      <a:prstDash val="solid"/>
+                    </a:lnBlToTr>
+                    <a:solidFill>
+                      <a:schemeClr val="bg1">
+                        <a:lumMod val="95000"/>
+                      </a:schemeClr>
+                    </a:solidFill>
+                  </a:tcPr>
+                </a:tc>
+                <a:tc>
+                  <a:txBody>
+                    <a:bodyPr/>
+                    <a:lstStyle/>
+                    <a:p>
+                      <a:r>
+                        <a:rPr lang="en-US" sz="1500" b="0" i="0" dirty="0">
+                          <a:solidFill>
+                            <a:schemeClr val="tx1"/>
+                          </a:solidFill>
+                          <a:latin typeface="GT Walsheim Trial Rg" pitchFamily="2" charset="77"/>
+                        </a:rPr>
+                        <a:t>included</a:t>
+                      </a:r>
+                    </a:p>
+                  </a:txBody>
+                  <a:tcPr>
+                    <a:lnL w="12700" cap="flat" cmpd="sng" algn="ctr">
+                      <a:noFill/>
+                      <a:prstDash val="solid"/>
+                      <a:round/>
+                      <a:headEnd type="none" w="med" len="med"/>
+                      <a:tailEnd type="none" w="med" len="med"/>
+                    </a:lnL>
+                    <a:lnR w="12700" cap="flat" cmpd="sng" algn="ctr">
+                      <a:noFill/>
+                      <a:prstDash val="solid"/>
+                      <a:round/>
+                      <a:headEnd type="none" w="med" len="med"/>
+                      <a:tailEnd type="none" w="med" len="med"/>
+                    </a:lnR>
+                    <a:lnT w="12700" cap="flat" cmpd="sng" algn="ctr">
+                      <a:noFill/>
+                      <a:prstDash val="solid"/>
+                      <a:round/>
+                      <a:headEnd type="none" w="med" len="med"/>
+                      <a:tailEnd type="none" w="med" len="med"/>
+                    </a:lnT>
+                    <a:lnB w="12700" cap="flat" cmpd="sng" algn="ctr">
+                      <a:noFill/>
+                      <a:prstDash val="solid"/>
+                      <a:round/>
+                      <a:headEnd type="none" w="med" len="med"/>
+                      <a:tailEnd type="none" w="med" len="med"/>
+                    </a:lnB>
+                    <a:lnTlToBr w="12700" cmpd="sng">
+                      <a:noFill/>
+                      <a:prstDash val="solid"/>
+                    </a:lnTlToBr>
+                    <a:lnBlToTr w="12700" cmpd="sng">
+                      <a:noFill/>
+                      <a:prstDash val="solid"/>
+                    </a:lnBlToTr>
+                    <a:solidFill>
+                      <a:schemeClr val="bg1">
+                        <a:lumMod val="95000"/>
+                      </a:schemeClr>
+                    </a:solidFill>
+                  </a:tcPr>
+                </a:tc>
+                <a:extLst>
+                  <a:ext uri="{0D108BD9-81ED-4DB2-BD59-A6C34878D82A}">
+                    <a16:rowId xmlns:a16="http://schemas.microsoft.com/office/drawing/2014/main" val="4152326013"/>
+                  </a:ext>
+                </a:extLst>
+              </a:tr>
+              <a:tr h="446626">
+                <a:tc>
+                  <a:txBody>
+                    <a:bodyPr/>
+                    <a:lstStyle/>
+                    <a:p>
+                      <a:r>
+                        <a:rPr lang="en-US" sz="1500" b="0" i="0" dirty="0">
+                          <a:solidFill>
+                            <a:schemeClr val="tx1"/>
+                          </a:solidFill>
+                          <a:latin typeface="GT Walsheim Trial Rg" pitchFamily="2" charset="77"/>
+                        </a:rPr>
+                        <a:t>Pedestrian</a:t>
+                      </a:r>
+                    </a:p>
+                  </a:txBody>
+                  <a:tcPr>
+                    <a:lnL w="12700" cap="flat" cmpd="sng" algn="ctr">
+                      <a:noFill/>
+                      <a:prstDash val="solid"/>
+                      <a:round/>
+                      <a:headEnd type="none" w="med" len="med"/>
+                      <a:tailEnd type="none" w="med" len="med"/>
+                    </a:lnL>
+                    <a:lnR w="12700" cap="flat" cmpd="sng" algn="ctr">
+                      <a:noFill/>
+                      <a:prstDash val="solid"/>
+                      <a:round/>
+                      <a:headEnd type="none" w="med" len="med"/>
+                      <a:tailEnd type="none" w="med" len="med"/>
+                    </a:lnR>
+                    <a:lnT w="12700" cap="flat" cmpd="sng" algn="ctr">
+                      <a:noFill/>
+                      <a:prstDash val="solid"/>
+                      <a:round/>
+                      <a:headEnd type="none" w="med" len="med"/>
+                      <a:tailEnd type="none" w="med" len="med"/>
+                    </a:lnT>
+                    <a:lnB w="12700" cap="flat" cmpd="sng" algn="ctr">
+                      <a:noFill/>
+                      <a:prstDash val="solid"/>
+                      <a:round/>
+                      <a:headEnd type="none" w="med" len="med"/>
+                      <a:tailEnd type="none" w="med" len="med"/>
+                    </a:lnB>
+                    <a:lnTlToBr w="12700" cmpd="sng">
+                      <a:noFill/>
+                      <a:prstDash val="solid"/>
+                    </a:lnTlToBr>
+                    <a:lnBlToTr w="12700" cmpd="sng">
+                      <a:noFill/>
+                      <a:prstDash val="solid"/>
+                    </a:lnBlToTr>
+                    <a:solidFill>
+                      <a:schemeClr val="bg1">
+                        <a:lumMod val="85000"/>
+                      </a:schemeClr>
+                    </a:solidFill>
+                  </a:tcPr>
+                </a:tc>
+                <a:tc>
+                  <a:txBody>
+                    <a:bodyPr/>
+                    <a:lstStyle/>
+                    <a:p>
+                      <a:r>
+                        <a:rPr lang="en-US" sz="1500" b="0" i="0" dirty="0">
+                          <a:solidFill>
+                            <a:schemeClr val="tx1"/>
+                          </a:solidFill>
+                          <a:latin typeface="GT Walsheim Trial Rg" pitchFamily="2" charset="77"/>
+                        </a:rPr>
+                        <a:t>~25%</a:t>
+                      </a:r>
+                    </a:p>
+                  </a:txBody>
+                  <a:tcPr>
+                    <a:lnL w="12700" cap="flat" cmpd="sng" algn="ctr">
+                      <a:noFill/>
+                      <a:prstDash val="solid"/>
+                      <a:round/>
+                      <a:headEnd type="none" w="med" len="med"/>
+                      <a:tailEnd type="none" w="med" len="med"/>
+                    </a:lnL>
+                    <a:lnR w="12700" cap="flat" cmpd="sng" algn="ctr">
+                      <a:noFill/>
+                      <a:prstDash val="solid"/>
+                      <a:round/>
+                      <a:headEnd type="none" w="med" len="med"/>
+                      <a:tailEnd type="none" w="med" len="med"/>
+                    </a:lnR>
+                    <a:lnT w="12700" cap="flat" cmpd="sng" algn="ctr">
+                      <a:noFill/>
+                      <a:prstDash val="solid"/>
+                      <a:round/>
+                      <a:headEnd type="none" w="med" len="med"/>
+                      <a:tailEnd type="none" w="med" len="med"/>
+                    </a:lnT>
+                    <a:lnB w="12700" cap="flat" cmpd="sng" algn="ctr">
+                      <a:noFill/>
+                      <a:prstDash val="solid"/>
+                      <a:round/>
+                      <a:headEnd type="none" w="med" len="med"/>
+                      <a:tailEnd type="none" w="med" len="med"/>
+                    </a:lnB>
+                    <a:lnTlToBr w="12700" cmpd="sng">
+                      <a:noFill/>
+                      <a:prstDash val="solid"/>
+                    </a:lnTlToBr>
+                    <a:lnBlToTr w="12700" cmpd="sng">
+                      <a:noFill/>
+                      <a:prstDash val="solid"/>
+                    </a:lnBlToTr>
+                    <a:solidFill>
+                      <a:schemeClr val="bg1">
+                        <a:lumMod val="85000"/>
+                      </a:schemeClr>
+                    </a:solidFill>
+                  </a:tcPr>
+                </a:tc>
+                <a:tc>
+                  <a:txBody>
+                    <a:bodyPr/>
+                    <a:lstStyle/>
+                    <a:p>
+                      <a:r>
+                        <a:rPr lang="en-US" sz="1500" b="0" i="0" dirty="0">
+                          <a:solidFill>
+                            <a:schemeClr val="tx1"/>
+                          </a:solidFill>
+                          <a:latin typeface="GT Walsheim Trial Rg" pitchFamily="2" charset="77"/>
+                        </a:rPr>
+                        <a:t>included</a:t>
+                      </a:r>
+                    </a:p>
+                  </a:txBody>
+                  <a:tcPr>
+                    <a:lnL w="12700" cap="flat" cmpd="sng" algn="ctr">
+                      <a:noFill/>
+                      <a:prstDash val="solid"/>
+                      <a:round/>
+                      <a:headEnd type="none" w="med" len="med"/>
+                      <a:tailEnd type="none" w="med" len="med"/>
+                    </a:lnL>
+                    <a:lnR w="12700" cap="flat" cmpd="sng" algn="ctr">
+                      <a:noFill/>
+                      <a:prstDash val="solid"/>
+                      <a:round/>
+                      <a:headEnd type="none" w="med" len="med"/>
+                      <a:tailEnd type="none" w="med" len="med"/>
+                    </a:lnR>
+                    <a:lnT w="12700" cap="flat" cmpd="sng" algn="ctr">
+                      <a:noFill/>
+                      <a:prstDash val="solid"/>
+                      <a:round/>
+                      <a:headEnd type="none" w="med" len="med"/>
+                      <a:tailEnd type="none" w="med" len="med"/>
+                    </a:lnT>
+                    <a:lnB w="12700" cap="flat" cmpd="sng" algn="ctr">
+                      <a:noFill/>
+                      <a:prstDash val="solid"/>
+                      <a:round/>
+                      <a:headEnd type="none" w="med" len="med"/>
+                      <a:tailEnd type="none" w="med" len="med"/>
+                    </a:lnB>
+                    <a:lnTlToBr w="12700" cmpd="sng">
+                      <a:noFill/>
+                      <a:prstDash val="solid"/>
+                    </a:lnTlToBr>
+                    <a:lnBlToTr w="12700" cmpd="sng">
+                      <a:noFill/>
+                      <a:prstDash val="solid"/>
+                    </a:lnBlToTr>
+                    <a:solidFill>
+                      <a:schemeClr val="bg1">
+                        <a:lumMod val="85000"/>
+                      </a:schemeClr>
+                    </a:solidFill>
+                  </a:tcPr>
+                </a:tc>
+                <a:extLst>
+                  <a:ext uri="{0D108BD9-81ED-4DB2-BD59-A6C34878D82A}">
+                    <a16:rowId xmlns:a16="http://schemas.microsoft.com/office/drawing/2014/main" val="3142999530"/>
+                  </a:ext>
+                </a:extLst>
+              </a:tr>
+              <a:tr h="446626">
+                <a:tc>
+                  <a:txBody>
+                    <a:bodyPr/>
+                    <a:lstStyle/>
+                    <a:p>
+                      <a:r>
+                        <a:rPr lang="en-US" sz="1500" b="0" i="0" dirty="0">
+                          <a:solidFill>
+                            <a:schemeClr val="tx1"/>
+                          </a:solidFill>
+                          <a:latin typeface="GT Walsheim Trial Rg" pitchFamily="2" charset="77"/>
+                        </a:rPr>
+                        <a:t>Cyclist</a:t>
+                      </a:r>
+                    </a:p>
+                  </a:txBody>
+                  <a:tcPr>
+                    <a:lnL w="12700" cap="flat" cmpd="sng" algn="ctr">
+                      <a:noFill/>
+                      <a:prstDash val="solid"/>
+                      <a:round/>
+                      <a:headEnd type="none" w="med" len="med"/>
+                      <a:tailEnd type="none" w="med" len="med"/>
+                    </a:lnL>
+                    <a:lnR w="12700" cap="flat" cmpd="sng" algn="ctr">
+                      <a:noFill/>
+                      <a:prstDash val="solid"/>
+                      <a:round/>
+                      <a:headEnd type="none" w="med" len="med"/>
+                      <a:tailEnd type="none" w="med" len="med"/>
+                    </a:lnR>
+                    <a:lnT w="12700" cap="flat" cmpd="sng" algn="ctr">
+                      <a:noFill/>
+                      <a:prstDash val="solid"/>
+                      <a:round/>
+                      <a:headEnd type="none" w="med" len="med"/>
+                      <a:tailEnd type="none" w="med" len="med"/>
+                    </a:lnT>
+                    <a:lnB w="12700" cap="flat" cmpd="sng" algn="ctr">
+                      <a:noFill/>
+                      <a:prstDash val="solid"/>
+                      <a:round/>
+                      <a:headEnd type="none" w="med" len="med"/>
+                      <a:tailEnd type="none" w="med" len="med"/>
+                    </a:lnB>
+                    <a:lnTlToBr w="12700" cmpd="sng">
+                      <a:noFill/>
+                      <a:prstDash val="solid"/>
+                    </a:lnTlToBr>
+                    <a:lnBlToTr w="12700" cmpd="sng">
+                      <a:noFill/>
+                      <a:prstDash val="solid"/>
+                    </a:lnBlToTr>
+                    <a:solidFill>
+                      <a:schemeClr val="bg1">
+                        <a:lumMod val="95000"/>
+                      </a:schemeClr>
+                    </a:solidFill>
+                  </a:tcPr>
+                </a:tc>
+                <a:tc>
+                  <a:txBody>
+                    <a:bodyPr/>
+                    <a:lstStyle/>
+                    <a:p>
+                      <a:r>
+                        <a:rPr lang="en-US" sz="1500" b="0" i="0" dirty="0">
+                          <a:solidFill>
+                            <a:schemeClr val="tx1"/>
+                          </a:solidFill>
+                          <a:latin typeface="GT Walsheim Trial Rg" pitchFamily="2" charset="77"/>
+                        </a:rPr>
+                        <a:t>~5%</a:t>
+                      </a:r>
+                    </a:p>
+                  </a:txBody>
+                  <a:tcPr>
+                    <a:lnL w="12700" cap="flat" cmpd="sng" algn="ctr">
+                      <a:noFill/>
+                      <a:prstDash val="solid"/>
+                      <a:round/>
+                      <a:headEnd type="none" w="med" len="med"/>
+                      <a:tailEnd type="none" w="med" len="med"/>
+                    </a:lnL>
+                    <a:lnR w="12700" cap="flat" cmpd="sng" algn="ctr">
+                      <a:noFill/>
+                      <a:prstDash val="solid"/>
+                      <a:round/>
+                      <a:headEnd type="none" w="med" len="med"/>
+                      <a:tailEnd type="none" w="med" len="med"/>
+                    </a:lnR>
+                    <a:lnT w="12700" cap="flat" cmpd="sng" algn="ctr">
+                      <a:noFill/>
+                      <a:prstDash val="solid"/>
+                      <a:round/>
+                      <a:headEnd type="none" w="med" len="med"/>
+                      <a:tailEnd type="none" w="med" len="med"/>
+                    </a:lnT>
+                    <a:lnB w="12700" cap="flat" cmpd="sng" algn="ctr">
+                      <a:noFill/>
+                      <a:prstDash val="solid"/>
+                      <a:round/>
+                      <a:headEnd type="none" w="med" len="med"/>
+                      <a:tailEnd type="none" w="med" len="med"/>
+                    </a:lnB>
+                    <a:lnTlToBr w="12700" cmpd="sng">
+                      <a:noFill/>
+                      <a:prstDash val="solid"/>
+                    </a:lnTlToBr>
+                    <a:lnBlToTr w="12700" cmpd="sng">
+                      <a:noFill/>
+                      <a:prstDash val="solid"/>
+                    </a:lnBlToTr>
+                    <a:solidFill>
+                      <a:schemeClr val="bg1">
+                        <a:lumMod val="95000"/>
+                      </a:schemeClr>
+                    </a:solidFill>
+                  </a:tcPr>
+                </a:tc>
+                <a:tc>
+                  <a:txBody>
+                    <a:bodyPr/>
+                    <a:lstStyle/>
+                    <a:p>
+                      <a:r>
+                        <a:rPr lang="en-US" sz="1500" b="0" i="0" dirty="0">
+                          <a:solidFill>
+                            <a:schemeClr val="tx1"/>
+                          </a:solidFill>
+                          <a:latin typeface="GT Walsheim Trial Rg" pitchFamily="2" charset="77"/>
+                        </a:rPr>
+                        <a:t>included</a:t>
+                      </a:r>
+                    </a:p>
+                  </a:txBody>
+                  <a:tcPr>
+                    <a:lnL w="12700" cap="flat" cmpd="sng" algn="ctr">
+                      <a:noFill/>
+                      <a:prstDash val="solid"/>
+                      <a:round/>
+                      <a:headEnd type="none" w="med" len="med"/>
+                      <a:tailEnd type="none" w="med" len="med"/>
+                    </a:lnL>
+                    <a:lnR w="12700" cap="flat" cmpd="sng" algn="ctr">
+                      <a:noFill/>
+                      <a:prstDash val="solid"/>
+                      <a:round/>
+                      <a:headEnd type="none" w="med" len="med"/>
+                      <a:tailEnd type="none" w="med" len="med"/>
+                    </a:lnR>
+                    <a:lnT w="12700" cap="flat" cmpd="sng" algn="ctr">
+                      <a:noFill/>
+                      <a:prstDash val="solid"/>
+                      <a:round/>
+                      <a:headEnd type="none" w="med" len="med"/>
+                      <a:tailEnd type="none" w="med" len="med"/>
+                    </a:lnT>
+                    <a:lnB w="12700" cap="flat" cmpd="sng" algn="ctr">
+                      <a:noFill/>
+                      <a:prstDash val="solid"/>
+                      <a:round/>
+                      <a:headEnd type="none" w="med" len="med"/>
+                      <a:tailEnd type="none" w="med" len="med"/>
+                    </a:lnB>
+                    <a:lnTlToBr w="12700" cmpd="sng">
+                      <a:noFill/>
+                      <a:prstDash val="solid"/>
+                    </a:lnTlToBr>
+                    <a:lnBlToTr w="12700" cmpd="sng">
+                      <a:noFill/>
+                      <a:prstDash val="solid"/>
+                    </a:lnBlToTr>
+                    <a:solidFill>
+                      <a:schemeClr val="bg1">
+                        <a:lumMod val="95000"/>
+                      </a:schemeClr>
+                    </a:solidFill>
+                  </a:tcPr>
+                </a:tc>
+                <a:extLst>
+                  <a:ext uri="{0D108BD9-81ED-4DB2-BD59-A6C34878D82A}">
+                    <a16:rowId xmlns:a16="http://schemas.microsoft.com/office/drawing/2014/main" val="1523425920"/>
+                  </a:ext>
+                </a:extLst>
+              </a:tr>
+              <a:tr h="573538">
+                <a:tc>
+                  <a:txBody>
+                    <a:bodyPr/>
+                    <a:lstStyle/>
+                    <a:p>
+                      <a:r>
+                        <a:rPr lang="en-US" sz="1500" b="0" i="0" dirty="0">
+                          <a:solidFill>
+                            <a:schemeClr val="tx1"/>
+                          </a:solidFill>
+                          <a:latin typeface="GT Walsheim Trial Rg" pitchFamily="2" charset="77"/>
+                        </a:rPr>
+                        <a:t>SDC (AV itself)</a:t>
+                      </a:r>
+                    </a:p>
+                  </a:txBody>
+                  <a:tcPr>
+                    <a:lnL w="12700" cap="flat" cmpd="sng" algn="ctr">
+                      <a:noFill/>
+                      <a:prstDash val="solid"/>
+                      <a:round/>
+                      <a:headEnd type="none" w="med" len="med"/>
+                      <a:tailEnd type="none" w="med" len="med"/>
+                    </a:lnL>
+                    <a:lnR w="12700" cap="flat" cmpd="sng" algn="ctr">
+                      <a:noFill/>
+                      <a:prstDash val="solid"/>
+                      <a:round/>
+                      <a:headEnd type="none" w="med" len="med"/>
+                      <a:tailEnd type="none" w="med" len="med"/>
+                    </a:lnR>
+                    <a:lnT w="12700" cap="flat" cmpd="sng" algn="ctr">
+                      <a:noFill/>
+                      <a:prstDash val="solid"/>
+                      <a:round/>
+                      <a:headEnd type="none" w="med" len="med"/>
+                      <a:tailEnd type="none" w="med" len="med"/>
+                    </a:lnT>
+                    <a:lnB w="12700" cap="flat" cmpd="sng" algn="ctr">
+                      <a:noFill/>
+                      <a:prstDash val="solid"/>
+                      <a:round/>
+                      <a:headEnd type="none" w="med" len="med"/>
+                      <a:tailEnd type="none" w="med" len="med"/>
+                    </a:lnB>
+                    <a:lnTlToBr w="12700" cmpd="sng">
+                      <a:noFill/>
+                      <a:prstDash val="solid"/>
+                    </a:lnTlToBr>
+                    <a:lnBlToTr w="12700" cmpd="sng">
+                      <a:noFill/>
+                      <a:prstDash val="solid"/>
+                    </a:lnBlToTr>
+                    <a:solidFill>
+                      <a:schemeClr val="bg1">
+                        <a:lumMod val="85000"/>
+                      </a:schemeClr>
+                    </a:solidFill>
+                  </a:tcPr>
+                </a:tc>
+                <a:tc>
+                  <a:txBody>
+                    <a:bodyPr/>
+                    <a:lstStyle/>
+                    <a:p>
+                      <a:r>
+                        <a:rPr lang="en-US" sz="1500" b="0" i="0" dirty="0">
+                          <a:solidFill>
+                            <a:schemeClr val="tx1"/>
+                          </a:solidFill>
+                          <a:latin typeface="GT Walsheim Trial Rg" pitchFamily="2" charset="77"/>
+                        </a:rPr>
+                        <a:t>removed</a:t>
+                      </a:r>
+                    </a:p>
+                  </a:txBody>
+                  <a:tcPr>
+                    <a:lnL w="12700" cap="flat" cmpd="sng" algn="ctr">
+                      <a:noFill/>
+                      <a:prstDash val="solid"/>
+                      <a:round/>
+                      <a:headEnd type="none" w="med" len="med"/>
+                      <a:tailEnd type="none" w="med" len="med"/>
+                    </a:lnL>
+                    <a:lnR w="12700" cap="flat" cmpd="sng" algn="ctr">
+                      <a:noFill/>
+                      <a:prstDash val="solid"/>
+                      <a:round/>
+                      <a:headEnd type="none" w="med" len="med"/>
+                      <a:tailEnd type="none" w="med" len="med"/>
+                    </a:lnR>
+                    <a:lnT w="12700" cap="flat" cmpd="sng" algn="ctr">
+                      <a:noFill/>
+                      <a:prstDash val="solid"/>
+                      <a:round/>
+                      <a:headEnd type="none" w="med" len="med"/>
+                      <a:tailEnd type="none" w="med" len="med"/>
+                    </a:lnT>
+                    <a:lnB w="12700" cap="flat" cmpd="sng" algn="ctr">
+                      <a:noFill/>
+                      <a:prstDash val="solid"/>
+                      <a:round/>
+                      <a:headEnd type="none" w="med" len="med"/>
+                      <a:tailEnd type="none" w="med" len="med"/>
+                    </a:lnB>
+                    <a:lnTlToBr w="12700" cmpd="sng">
+                      <a:noFill/>
+                      <a:prstDash val="solid"/>
+                    </a:lnTlToBr>
+                    <a:lnBlToTr w="12700" cmpd="sng">
+                      <a:noFill/>
+                      <a:prstDash val="solid"/>
+                    </a:lnBlToTr>
+                    <a:solidFill>
+                      <a:schemeClr val="bg1">
+                        <a:lumMod val="85000"/>
+                      </a:schemeClr>
+                    </a:solidFill>
+                  </a:tcPr>
+                </a:tc>
+                <a:tc>
+                  <a:txBody>
+                    <a:bodyPr/>
+                    <a:lstStyle/>
+                    <a:p>
+                      <a:r>
+                        <a:rPr lang="en-US" sz="1500" b="0" i="0" dirty="0">
+                          <a:solidFill>
+                            <a:schemeClr val="tx1"/>
+                          </a:solidFill>
+                          <a:latin typeface="GT Walsheim Trial Rg" pitchFamily="2" charset="77"/>
+                        </a:rPr>
+                        <a:t>excluded</a:t>
+                      </a:r>
+                    </a:p>
+                  </a:txBody>
+                  <a:tcPr>
+                    <a:lnL w="12700" cap="flat" cmpd="sng" algn="ctr">
+                      <a:noFill/>
+                      <a:prstDash val="solid"/>
+                      <a:round/>
+                      <a:headEnd type="none" w="med" len="med"/>
+                      <a:tailEnd type="none" w="med" len="med"/>
+                    </a:lnL>
+                    <a:lnR w="12700" cap="flat" cmpd="sng" algn="ctr">
+                      <a:noFill/>
+                      <a:prstDash val="solid"/>
+                      <a:round/>
+                      <a:headEnd type="none" w="med" len="med"/>
+                      <a:tailEnd type="none" w="med" len="med"/>
+                    </a:lnR>
+                    <a:lnT w="12700" cap="flat" cmpd="sng" algn="ctr">
+                      <a:noFill/>
+                      <a:prstDash val="solid"/>
+                      <a:round/>
+                      <a:headEnd type="none" w="med" len="med"/>
+                      <a:tailEnd type="none" w="med" len="med"/>
+                    </a:lnT>
+                    <a:lnB w="12700" cap="flat" cmpd="sng" algn="ctr">
+                      <a:noFill/>
+                      <a:prstDash val="solid"/>
+                      <a:round/>
+                      <a:headEnd type="none" w="med" len="med"/>
+                      <a:tailEnd type="none" w="med" len="med"/>
+                    </a:lnB>
+                    <a:lnTlToBr w="12700" cmpd="sng">
+                      <a:noFill/>
+                      <a:prstDash val="solid"/>
+                    </a:lnTlToBr>
+                    <a:lnBlToTr w="12700" cmpd="sng">
+                      <a:noFill/>
+                      <a:prstDash val="solid"/>
+                    </a:lnBlToTr>
+                    <a:solidFill>
+                      <a:schemeClr val="bg1">
+                        <a:lumMod val="85000"/>
+                      </a:schemeClr>
+                    </a:solidFill>
+                  </a:tcPr>
+                </a:tc>
+                <a:extLst>
+                  <a:ext uri="{0D108BD9-81ED-4DB2-BD59-A6C34878D82A}">
+                    <a16:rowId xmlns:a16="http://schemas.microsoft.com/office/drawing/2014/main" val="1062120210"/>
+                  </a:ext>
+                </a:extLst>
+              </a:tr>
+            </a:tbl>
+          </a:graphicData>
+        </a:graphic>
+      </p:graphicFrame>
+      <p:pic>
+        <p:nvPicPr>
+          <p:cNvPr id="13" name="Picture 12">
+            <a:extLst>
+              <a:ext uri="{FF2B5EF4-FFF2-40B4-BE49-F238E27FC236}">
+                <a16:creationId xmlns:a16="http://schemas.microsoft.com/office/drawing/2014/main" id="{9505BAAA-21BA-2316-4D5C-506901CAEEDA}"/>
+              </a:ext>
+            </a:extLst>
+          </p:cNvPr>
+          <p:cNvPicPr>
+            <a:picLocks noChangeAspect="1"/>
+          </p:cNvPicPr>
+          <p:nvPr/>
+        </p:nvPicPr>
+        <p:blipFill>
+          <a:blip r:embed="rId3"/>
+          <a:stretch>
+            <a:fillRect/>
+          </a:stretch>
+        </p:blipFill>
+        <p:spPr>
+          <a:xfrm>
+            <a:off x="6342984" y="1583032"/>
+            <a:ext cx="5254264" cy="4503655"/>
+          </a:xfrm>
+          <a:prstGeom prst="rect">
+            <a:avLst/>
+          </a:prstGeom>
+        </p:spPr>
+      </p:pic>
+      <p:pic>
+        <p:nvPicPr>
+          <p:cNvPr id="14" name="Picture 2" descr="Waymo Logo">
+            <a:extLst>
+              <a:ext uri="{FF2B5EF4-FFF2-40B4-BE49-F238E27FC236}">
+                <a16:creationId xmlns:a16="http://schemas.microsoft.com/office/drawing/2014/main" id="{0AB81574-B623-A466-0C44-7AD8EF55DE3E}"/>
+              </a:ext>
+            </a:extLst>
+          </p:cNvPr>
+          <p:cNvPicPr>
+            <a:picLocks noChangeAspect="1" noChangeArrowheads="1"/>
+          </p:cNvPicPr>
+          <p:nvPr/>
+        </p:nvPicPr>
+        <p:blipFill>
+          <a:blip r:embed="rId4">
+            <a:extLst>
+              <a:ext uri="{28A0092B-C50C-407E-A947-70E740481C1C}">
+                <a14:useLocalDpi xmlns:a14="http://schemas.microsoft.com/office/drawing/2010/main" val="0"/>
+              </a:ext>
+            </a:extLst>
+          </a:blip>
+          <a:srcRect/>
+          <a:stretch>
+            <a:fillRect/>
+          </a:stretch>
+        </p:blipFill>
+        <p:spPr bwMode="auto">
+          <a:xfrm>
+            <a:off x="10795378" y="425703"/>
+            <a:ext cx="782903" cy="782903"/>
+          </a:xfrm>
+          <a:prstGeom prst="rect">
+            <a:avLst/>
+          </a:prstGeom>
+          <a:noFill/>
+          <a:extLst>
+            <a:ext uri="{909E8E84-426E-40DD-AFC4-6F175D3DCCD1}">
+              <a14:hiddenFill xmlns:a14="http://schemas.microsoft.com/office/drawing/2010/main">
+                <a:solidFill>
+                  <a:srgbClr val="FFFFFF"/>
+                </a:solidFill>
+              </a14:hiddenFill>
+            </a:ext>
+          </a:extLst>
+        </p:spPr>
+      </p:pic>
+      <p:sp>
+        <p:nvSpPr>
+          <p:cNvPr id="11" name="Freeform 10">
+            <a:extLst>
+              <a:ext uri="{FF2B5EF4-FFF2-40B4-BE49-F238E27FC236}">
+                <a16:creationId xmlns:a16="http://schemas.microsoft.com/office/drawing/2014/main" id="{00515834-BC50-0B18-62CA-A70C9A9333E0}"/>
               </a:ext>
             </a:extLst>
           </p:cNvPr>
@@ -21264,9 +22873,9 @@
           <p:nvPr/>
         </p:nvSpPr>
         <p:spPr>
-          <a:xfrm>
-            <a:off x="-6144266" y="5082576"/>
-            <a:ext cx="18800064" cy="7187173"/>
+          <a:xfrm rot="7893553">
+            <a:off x="-317208" y="-322814"/>
+            <a:ext cx="18800064" cy="6958229"/>
           </a:xfrm>
           <a:custGeom>
             <a:avLst/>
@@ -21312,8 +22921,8 @@
           <a:noFill/>
           <a:ln w="635000">
             <a:solidFill>
-              <a:schemeClr val="bg1">
-                <a:alpha val="10000"/>
+              <a:schemeClr val="tx1">
+                <a:alpha val="3000"/>
               </a:schemeClr>
             </a:solidFill>
           </a:ln>
@@ -21356,8 +22965,8 @@
           <p:nvPr/>
         </p:nvSpPr>
         <p:spPr>
-          <a:xfrm rot="724800">
-            <a:off x="-2872042" y="3203933"/>
+          <a:xfrm rot="967553">
+            <a:off x="-8289652" y="4450746"/>
             <a:ext cx="18325767" cy="1340166"/>
           </a:xfrm>
           <a:custGeom>
@@ -21415,16 +23024,16 @@
           <a:ln w="762000" cap="flat">
             <a:gradFill flip="none" rotWithShape="1">
               <a:gsLst>
-                <a:gs pos="69000">
+                <a:gs pos="49000">
                   <a:srgbClr val="0078FF"/>
                 </a:gs>
                 <a:gs pos="0">
                   <a:srgbClr val="0078FF"/>
                 </a:gs>
-                <a:gs pos="29000">
+                <a:gs pos="21000">
                   <a:srgbClr val="0078FF"/>
                 </a:gs>
-                <a:gs pos="46000">
+                <a:gs pos="36000">
                   <a:srgbClr val="0078FF"/>
                 </a:gs>
                 <a:gs pos="77000">
@@ -21465,55 +23074,155 @@
           </a:p>
         </p:txBody>
       </p:sp>
-      <p:sp>
-        <p:nvSpPr>
-          <p:cNvPr id="4" name="Title 3">
+    </p:spTree>
+    <p:extLst>
+      <p:ext uri="{BB962C8B-B14F-4D97-AF65-F5344CB8AC3E}">
+        <p14:creationId xmlns:p14="http://schemas.microsoft.com/office/powerpoint/2010/main" val="2414567693"/>
+      </p:ext>
+    </p:extLst>
+  </p:cSld>
+  <p:clrMapOvr>
+    <a:masterClrMapping/>
+  </p:clrMapOvr>
+</p:sld>
+</file>
+
+<file path=ppt/slides/slide7.xml><?xml version="1.0" encoding="utf-8"?>
+<p:sld xmlns:a="http://schemas.openxmlformats.org/drawingml/2006/main" xmlns:r="http://schemas.openxmlformats.org/officeDocument/2006/relationships" xmlns:p="http://schemas.openxmlformats.org/presentationml/2006/main">
+  <p:cSld>
+    <p:spTree>
+      <p:nvGrpSpPr>
+        <p:cNvPr id="1" name="">
+          <a:extLst>
+            <a:ext uri="{FF2B5EF4-FFF2-40B4-BE49-F238E27FC236}">
+              <a16:creationId xmlns:a16="http://schemas.microsoft.com/office/drawing/2014/main" id="{684AF451-3682-FF2C-D616-3F71F91C5AC6}"/>
+            </a:ext>
+          </a:extLst>
+        </p:cNvPr>
+        <p:cNvGrpSpPr/>
+        <p:nvPr/>
+      </p:nvGrpSpPr>
+      <p:grpSpPr>
+        <a:xfrm>
+          <a:off x="0" y="0"/>
+          <a:ext cx="0" cy="0"/>
+          <a:chOff x="0" y="0"/>
+          <a:chExt cx="0" cy="0"/>
+        </a:xfrm>
+      </p:grpSpPr>
+      <p:pic>
+        <p:nvPicPr>
+          <p:cNvPr id="6" name="Picture 2" descr="Waymo Logo">
             <a:extLst>
               <a:ext uri="{FF2B5EF4-FFF2-40B4-BE49-F238E27FC236}">
-                <a16:creationId xmlns:a16="http://schemas.microsoft.com/office/drawing/2014/main" id="{03C362FE-26C6-9E59-253C-0E8E33DFB89E}"/>
+                <a16:creationId xmlns:a16="http://schemas.microsoft.com/office/drawing/2014/main" id="{73A17D98-85BB-1349-8904-4995BA7F417F}"/>
               </a:ext>
             </a:extLst>
           </p:cNvPr>
-          <p:cNvSpPr>
-            <a:spLocks noGrp="1"/>
+          <p:cNvPicPr>
+            <a:picLocks noChangeAspect="1" noChangeArrowheads="1"/>
+          </p:cNvPicPr>
+          <p:nvPr/>
+        </p:nvPicPr>
+        <p:blipFill>
+          <a:blip r:embed="rId3">
+            <a:extLst>
+              <a:ext uri="{28A0092B-C50C-407E-A947-70E740481C1C}">
+                <a14:useLocalDpi xmlns:a14="http://schemas.microsoft.com/office/drawing/2010/main" val="0"/>
+              </a:ext>
+            </a:extLst>
+          </a:blip>
+          <a:srcRect/>
+          <a:stretch>
+            <a:fillRect/>
+          </a:stretch>
+        </p:blipFill>
+        <p:spPr bwMode="auto">
+          <a:xfrm>
+            <a:off x="10795378" y="425703"/>
+            <a:ext cx="782903" cy="782903"/>
+          </a:xfrm>
+          <a:prstGeom prst="rect">
+            <a:avLst/>
+          </a:prstGeom>
+          <a:noFill/>
+          <a:extLst>
+            <a:ext uri="{909E8E84-426E-40DD-AFC4-6F175D3DCCD1}">
+              <a14:hiddenFill xmlns:a14="http://schemas.microsoft.com/office/drawing/2010/main">
+                <a:solidFill>
+                  <a:srgbClr val="FFFFFF"/>
+                </a:solidFill>
+              </a14:hiddenFill>
+            </a:ext>
+          </a:extLst>
+        </p:spPr>
+      </p:pic>
+      <p:sp>
+        <p:nvSpPr>
+          <p:cNvPr id="9" name="Title 3">
+            <a:extLst>
+              <a:ext uri="{FF2B5EF4-FFF2-40B4-BE49-F238E27FC236}">
+                <a16:creationId xmlns:a16="http://schemas.microsoft.com/office/drawing/2014/main" id="{048C4A0F-704A-1B42-09A0-E1CEA1F85F1A}"/>
+              </a:ext>
+            </a:extLst>
+          </p:cNvPr>
+          <p:cNvSpPr txBox="1">
+            <a:spLocks/>
           </p:cNvSpPr>
-          <p:nvPr>
-            <p:ph type="ctrTitle"/>
-          </p:nvPr>
+          <p:nvPr/>
         </p:nvSpPr>
         <p:spPr>
           <a:xfrm>
             <a:off x="716478" y="447821"/>
-            <a:ext cx="3347522" cy="369333"/>
+            <a:ext cx="2406732" cy="369333"/>
           </a:xfrm>
+          <a:prstGeom prst="rect">
+            <a:avLst/>
+          </a:prstGeom>
         </p:spPr>
         <p:txBody>
-          <a:bodyPr>
+          <a:bodyPr vert="horz" lIns="91440" tIns="45720" rIns="91440" bIns="45720" rtlCol="0" anchor="b">
             <a:normAutofit/>
           </a:bodyPr>
-          <a:lstStyle/>
+          <a:lstStyle>
+            <a:lvl1pPr algn="ctr" defTabSz="914400" rtl="0" eaLnBrk="1" latinLnBrk="0" hangingPunct="1">
+              <a:lnSpc>
+                <a:spcPct val="90000"/>
+              </a:lnSpc>
+              <a:spcBef>
+                <a:spcPct val="0"/>
+              </a:spcBef>
+              <a:buNone/>
+              <a:defRPr sz="6000" kern="1200">
+                <a:solidFill>
+                  <a:schemeClr val="tx1"/>
+                </a:solidFill>
+                <a:latin typeface="+mj-lt"/>
+                <a:ea typeface="+mj-ea"/>
+                <a:cs typeface="+mj-cs"/>
+              </a:defRPr>
+            </a:lvl1pPr>
+          </a:lstStyle>
           <a:p>
             <a:pPr algn="l"/>
             <a:r>
               <a:rPr lang="en-US" sz="1500" dirty="0">
                 <a:solidFill>
-                  <a:schemeClr val="bg1">
-                    <a:lumMod val="50000"/>
-                  </a:schemeClr>
+                  <a:srgbClr val="989DA2"/>
                 </a:solidFill>
                 <a:latin typeface="GT Walsheim Trial Rg" pitchFamily="2" charset="77"/>
               </a:rPr>
-              <a:t>DATASET &amp; PIPLINE [AGENT TYPE]</a:t>
+              <a:t>DATASET STATISTICS</a:t>
             </a:r>
           </a:p>
         </p:txBody>
       </p:sp>
       <p:sp>
         <p:nvSpPr>
-          <p:cNvPr id="8" name="TextBox 7">
+          <p:cNvPr id="11" name="TextBox 10">
             <a:extLst>
               <a:ext uri="{FF2B5EF4-FFF2-40B4-BE49-F238E27FC236}">
-                <a16:creationId xmlns:a16="http://schemas.microsoft.com/office/drawing/2014/main" id="{AA0B286F-ACC4-E15E-FE10-F81A14DF3948}"/>
+                <a16:creationId xmlns:a16="http://schemas.microsoft.com/office/drawing/2014/main" id="{B6033FA2-EB1F-F693-6FA4-7BB8813D9CDA}"/>
               </a:ext>
             </a:extLst>
           </p:cNvPr>
@@ -21522,8 +23231,8 @@
         </p:nvSpPr>
         <p:spPr>
           <a:xfrm>
-            <a:off x="716477" y="952090"/>
-            <a:ext cx="7346867" cy="630942"/>
+            <a:off x="716478" y="952090"/>
+            <a:ext cx="6097978" cy="630942"/>
           </a:xfrm>
           <a:prstGeom prst="rect">
             <a:avLst/>
@@ -21538,22 +23247,19 @@
           <a:p>
             <a:r>
               <a:rPr lang="en-US" sz="3500" dirty="0">
-                <a:solidFill>
-                  <a:schemeClr val="bg1"/>
-                </a:solidFill>
                 <a:latin typeface="GT Walsheim Trial Rg" pitchFamily="2" charset="77"/>
               </a:rPr>
-              <a:t>Waymo Open Motion Dataset v1.3.1</a:t>
+              <a:t>What the Data Looks Like</a:t>
             </a:r>
           </a:p>
         </p:txBody>
       </p:sp>
       <p:graphicFrame>
         <p:nvGraphicFramePr>
-          <p:cNvPr id="3" name="Table 2">
+          <p:cNvPr id="12" name="Table 11">
             <a:extLst>
               <a:ext uri="{FF2B5EF4-FFF2-40B4-BE49-F238E27FC236}">
-                <a16:creationId xmlns:a16="http://schemas.microsoft.com/office/drawing/2014/main" id="{6E5ED46D-9A9D-45B4-50C0-E4B617433E8C}"/>
+                <a16:creationId xmlns:a16="http://schemas.microsoft.com/office/drawing/2014/main" id="{060EF4B2-4504-8D76-A4E4-69FA63C93789}"/>
               </a:ext>
             </a:extLst>
           </p:cNvPr>
@@ -21563,7 +23269,7 @@
           <p:nvPr>
             <p:extLst>
               <p:ext uri="{D42A27DB-BD31-4B8C-83A1-F6EECF244321}">
-                <p14:modId xmlns:p14="http://schemas.microsoft.com/office/powerpoint/2010/main" val="3777935987"/>
+                <p14:modId xmlns:p14="http://schemas.microsoft.com/office/powerpoint/2010/main" val="4168928733"/>
               </p:ext>
             </p:extLst>
           </p:nvPr>
@@ -21672,7 +23378,7 @@
                           </a:solidFill>
                           <a:latin typeface="GT Walsheim Trial Rg" pitchFamily="2" charset="77"/>
                         </a:rPr>
-                        <a:t>Count (raw)</a:t>
+                        <a:t>Share</a:t>
                       </a:r>
                     </a:p>
                   </a:txBody>
@@ -22534,220 +24240,6 @@
           </a:graphicData>
         </a:graphic>
       </p:graphicFrame>
-      <p:sp>
-        <p:nvSpPr>
-          <p:cNvPr id="6" name="TextBox 5">
-            <a:extLst>
-              <a:ext uri="{FF2B5EF4-FFF2-40B4-BE49-F238E27FC236}">
-                <a16:creationId xmlns:a16="http://schemas.microsoft.com/office/drawing/2014/main" id="{63141582-FD1E-F62F-4490-D627EFD530A0}"/>
-              </a:ext>
-            </a:extLst>
-          </p:cNvPr>
-          <p:cNvSpPr txBox="1"/>
-          <p:nvPr/>
-        </p:nvSpPr>
-        <p:spPr>
-          <a:xfrm>
-            <a:off x="624468" y="5082576"/>
-            <a:ext cx="6676929" cy="1015663"/>
-          </a:xfrm>
-          <a:prstGeom prst="rect">
-            <a:avLst/>
-          </a:prstGeom>
-          <a:noFill/>
-        </p:spPr>
-        <p:txBody>
-          <a:bodyPr wrap="square">
-            <a:spAutoFit/>
-          </a:bodyPr>
-          <a:lstStyle/>
-          <a:p>
-            <a:r>
-              <a:rPr lang="en-US" sz="1500" dirty="0">
-                <a:solidFill>
-                  <a:schemeClr val="bg1"/>
-                </a:solidFill>
-                <a:latin typeface="GT Walsheim Trial Md" pitchFamily="2" charset="77"/>
-              </a:rPr>
-              <a:t>Features extracted: </a:t>
-            </a:r>
-            <a:r>
-              <a:rPr lang="en-US" sz="1500" dirty="0">
-                <a:solidFill>
-                  <a:schemeClr val="bg1"/>
-                </a:solidFill>
-                <a:latin typeface="GT Walsheim Trial Lt" pitchFamily="2" charset="77"/>
-              </a:rPr>
-              <a:t>Speed, Acceleration, Yaw Rate,</a:t>
-            </a:r>
-          </a:p>
-          <a:p>
-            <a:r>
-              <a:rPr lang="en-US" sz="1500" dirty="0" err="1">
-                <a:solidFill>
-                  <a:schemeClr val="bg1"/>
-                </a:solidFill>
-                <a:latin typeface="GT Walsheim Trial Lt" pitchFamily="2" charset="77"/>
-              </a:rPr>
-              <a:t>Vel_X</a:t>
-            </a:r>
-            <a:r>
-              <a:rPr lang="en-US" sz="1500" dirty="0">
-                <a:solidFill>
-                  <a:schemeClr val="bg1"/>
-                </a:solidFill>
-                <a:latin typeface="GT Walsheim Trial Lt" pitchFamily="2" charset="77"/>
-              </a:rPr>
-              <a:t>, </a:t>
-            </a:r>
-            <a:r>
-              <a:rPr lang="en-US" sz="1500" dirty="0" err="1">
-                <a:solidFill>
-                  <a:schemeClr val="bg1"/>
-                </a:solidFill>
-                <a:latin typeface="GT Walsheim Trial Lt" pitchFamily="2" charset="77"/>
-              </a:rPr>
-              <a:t>Vel_Y</a:t>
-            </a:r>
-            <a:endParaRPr lang="en-US" sz="1500" dirty="0">
-              <a:solidFill>
-                <a:schemeClr val="bg1"/>
-              </a:solidFill>
-              <a:latin typeface="GT Walsheim Trial Lt" pitchFamily="2" charset="77"/>
-            </a:endParaRPr>
-          </a:p>
-          <a:p>
-            <a:r>
-              <a:rPr lang="en-US" sz="1500" dirty="0">
-                <a:solidFill>
-                  <a:schemeClr val="bg1"/>
-                </a:solidFill>
-                <a:latin typeface="GT Walsheim Trial Lt" pitchFamily="2" charset="77"/>
-              </a:rPr>
-              <a:t>Length, Width</a:t>
-            </a:r>
-          </a:p>
-          <a:p>
-            <a:r>
-              <a:rPr lang="en-US" sz="1500" dirty="0">
-                <a:solidFill>
-                  <a:schemeClr val="bg1"/>
-                </a:solidFill>
-                <a:latin typeface="GT Walsheim Trial Lt" pitchFamily="2" charset="77"/>
-              </a:rPr>
-              <a:t>FutureDist_5s</a:t>
-            </a:r>
-          </a:p>
-        </p:txBody>
-      </p:sp>
-      <p:pic>
-        <p:nvPicPr>
-          <p:cNvPr id="2" name="Picture 6" descr="Our Trademarks">
-            <a:extLst>
-              <a:ext uri="{FF2B5EF4-FFF2-40B4-BE49-F238E27FC236}">
-                <a16:creationId xmlns:a16="http://schemas.microsoft.com/office/drawing/2014/main" id="{0E3246AA-DF2A-798A-F5B3-ED4A58B466E9}"/>
-              </a:ext>
-            </a:extLst>
-          </p:cNvPr>
-          <p:cNvPicPr>
-            <a:picLocks noChangeAspect="1" noChangeArrowheads="1"/>
-          </p:cNvPicPr>
-          <p:nvPr/>
-        </p:nvPicPr>
-        <p:blipFill>
-          <a:blip r:embed="rId3">
-            <a:extLst>
-              <a:ext uri="{28A0092B-C50C-407E-A947-70E740481C1C}">
-                <a14:useLocalDpi xmlns:a14="http://schemas.microsoft.com/office/drawing/2010/main" val="0"/>
-              </a:ext>
-            </a:extLst>
-          </a:blip>
-          <a:srcRect/>
-          <a:stretch>
-            <a:fillRect/>
-          </a:stretch>
-        </p:blipFill>
-        <p:spPr bwMode="auto">
-          <a:xfrm>
-            <a:off x="10780831" y="411156"/>
-            <a:ext cx="811996" cy="811996"/>
-          </a:xfrm>
-          <a:prstGeom prst="rect">
-            <a:avLst/>
-          </a:prstGeom>
-          <a:noFill/>
-          <a:extLst>
-            <a:ext uri="{909E8E84-426E-40DD-AFC4-6F175D3DCCD1}">
-              <a14:hiddenFill xmlns:a14="http://schemas.microsoft.com/office/drawing/2010/main">
-                <a:solidFill>
-                  <a:srgbClr val="FFFFFF"/>
-                </a:solidFill>
-              </a14:hiddenFill>
-            </a:ext>
-          </a:extLst>
-        </p:spPr>
-      </p:pic>
-    </p:spTree>
-    <p:extLst>
-      <p:ext uri="{BB962C8B-B14F-4D97-AF65-F5344CB8AC3E}">
-        <p14:creationId xmlns:p14="http://schemas.microsoft.com/office/powerpoint/2010/main" val="2414567693"/>
-      </p:ext>
-    </p:extLst>
-  </p:cSld>
-  <p:clrMapOvr>
-    <a:masterClrMapping/>
-  </p:clrMapOvr>
-</p:sld>
-</file>
-
-<file path=ppt/slides/slide7.xml><?xml version="1.0" encoding="utf-8"?>
-<p:sld xmlns:a="http://schemas.openxmlformats.org/drawingml/2006/main" xmlns:r="http://schemas.openxmlformats.org/officeDocument/2006/relationships" xmlns:p="http://schemas.openxmlformats.org/presentationml/2006/main" show="0">
-  <p:cSld>
-    <p:spTree>
-      <p:nvGrpSpPr>
-        <p:cNvPr id="1" name="">
-          <a:extLst>
-            <a:ext uri="{FF2B5EF4-FFF2-40B4-BE49-F238E27FC236}">
-              <a16:creationId xmlns:a16="http://schemas.microsoft.com/office/drawing/2014/main" id="{684AF451-3682-FF2C-D616-3F71F91C5AC6}"/>
-            </a:ext>
-          </a:extLst>
-        </p:cNvPr>
-        <p:cNvGrpSpPr/>
-        <p:nvPr/>
-      </p:nvGrpSpPr>
-      <p:grpSpPr>
-        <a:xfrm>
-          <a:off x="0" y="0"/>
-          <a:ext cx="0" cy="0"/>
-          <a:chOff x="0" y="0"/>
-          <a:chExt cx="0" cy="0"/>
-        </a:xfrm>
-      </p:grpSpPr>
-      <p:sp>
-        <p:nvSpPr>
-          <p:cNvPr id="3" name="Title 2">
-            <a:extLst>
-              <a:ext uri="{FF2B5EF4-FFF2-40B4-BE49-F238E27FC236}">
-                <a16:creationId xmlns:a16="http://schemas.microsoft.com/office/drawing/2014/main" id="{CE7B1E02-7E04-CB0C-3314-A673C2BD6DEC}"/>
-              </a:ext>
-            </a:extLst>
-          </p:cNvPr>
-          <p:cNvSpPr>
-            <a:spLocks noGrp="1"/>
-          </p:cNvSpPr>
-          <p:nvPr>
-            <p:ph type="ctrTitle"/>
-          </p:nvPr>
-        </p:nvSpPr>
-        <p:spPr/>
-        <p:txBody>
-          <a:bodyPr/>
-          <a:lstStyle/>
-          <a:p>
-            <a:endParaRPr lang="en-US"/>
-          </a:p>
-        </p:txBody>
-      </p:sp>
     </p:spTree>
     <p:extLst>
       <p:ext uri="{BB962C8B-B14F-4D97-AF65-F5344CB8AC3E}">

</xml_diff>

<commit_message>
Update presentation file for improved content and clarity
</commit_message>
<xml_diff>
--- a/docs/presentation/Unsupervised Statistical Learning for Kinematic Anomaly Detection in Autonomous Driving Scenarios.pptx
+++ b/docs/presentation/Unsupervised Statistical Learning for Kinematic Anomaly Detection in Autonomous Driving Scenarios.pptx
@@ -14,7 +14,7 @@
     <p:sldId id="260" r:id="rId5"/>
     <p:sldId id="262" r:id="rId6"/>
     <p:sldId id="263" r:id="rId7"/>
-    <p:sldId id="264" r:id="rId8"/>
+    <p:sldId id="273" r:id="rId8"/>
     <p:sldId id="272" r:id="rId9"/>
     <p:sldId id="265" r:id="rId10"/>
     <p:sldId id="266" r:id="rId11"/>
@@ -132,7 +132,7 @@
 <file path=ppt/revisionInfo.xml><?xml version="1.0" encoding="utf-8"?>
 <p1510:revInfo xmlns:a="http://schemas.openxmlformats.org/drawingml/2006/main" xmlns:r="http://schemas.openxmlformats.org/officeDocument/2006/relationships" xmlns:p1510="http://schemas.microsoft.com/office/powerpoint/2015/10/main">
   <p1510:revLst>
-    <p1510:client id="{E91D200D-BFFE-DF45-BD3E-DC36CCF88744}" v="57" dt="2026-04-12T03:18:04.601"/>
+    <p1510:client id="{E91D200D-BFFE-DF45-BD3E-DC36CCF88744}" v="61" dt="2026-04-12T03:20:01.662"/>
   </p1510:revLst>
 </p1510:revInfo>
 </file>
@@ -141,8 +141,8 @@
 <pc:chgInfo xmlns:a="http://schemas.openxmlformats.org/drawingml/2006/main" xmlns:r="http://schemas.openxmlformats.org/officeDocument/2006/relationships" xmlns:ac="http://schemas.microsoft.com/office/drawing/2013/main/command" xmlns:pc="http://schemas.microsoft.com/office/powerpoint/2013/main/command">
   <pc:docChgLst>
     <pc:chgData name="Stepanov, Pavel Aleksandrovich" userId="b85f6bca-230c-483e-a25b-e13e873626fd" providerId="ADAL" clId="{AB235781-41D1-50B9-86EA-51A98A5F500A}"/>
-    <pc:docChg chg="undo redo custSel addSld modSld">
-      <pc:chgData name="Stepanov, Pavel Aleksandrovich" userId="b85f6bca-230c-483e-a25b-e13e873626fd" providerId="ADAL" clId="{AB235781-41D1-50B9-86EA-51A98A5F500A}" dt="2026-04-12T03:18:07.237" v="432" actId="1076"/>
+    <pc:docChg chg="undo redo custSel addSld delSld modSld">
+      <pc:chgData name="Stepanov, Pavel Aleksandrovich" userId="b85f6bca-230c-483e-a25b-e13e873626fd" providerId="ADAL" clId="{AB235781-41D1-50B9-86EA-51A98A5F500A}" dt="2026-04-12T03:20:28.396" v="474" actId="1076"/>
       <pc:docMkLst>
         <pc:docMk/>
       </pc:docMkLst>
@@ -254,13 +254,13 @@
         </pc:spChg>
       </pc:sldChg>
       <pc:sldChg chg="addSp delSp modSp mod setBg modNotesTx">
-        <pc:chgData name="Stepanov, Pavel Aleksandrovich" userId="b85f6bca-230c-483e-a25b-e13e873626fd" providerId="ADAL" clId="{AB235781-41D1-50B9-86EA-51A98A5F500A}" dt="2026-04-12T03:18:07.237" v="432" actId="1076"/>
+        <pc:chgData name="Stepanov, Pavel Aleksandrovich" userId="b85f6bca-230c-483e-a25b-e13e873626fd" providerId="ADAL" clId="{AB235781-41D1-50B9-86EA-51A98A5F500A}" dt="2026-04-12T03:19:45.517" v="461" actId="20577"/>
         <pc:sldMkLst>
           <pc:docMk/>
           <pc:sldMk cId="2414567693" sldId="263"/>
         </pc:sldMkLst>
         <pc:spChg chg="mod">
-          <ac:chgData name="Stepanov, Pavel Aleksandrovich" userId="b85f6bca-230c-483e-a25b-e13e873626fd" providerId="ADAL" clId="{AB235781-41D1-50B9-86EA-51A98A5F500A}" dt="2026-04-12T03:10:36.616" v="307" actId="207"/>
+          <ac:chgData name="Stepanov, Pavel Aleksandrovich" userId="b85f6bca-230c-483e-a25b-e13e873626fd" providerId="ADAL" clId="{AB235781-41D1-50B9-86EA-51A98A5F500A}" dt="2026-04-12T03:19:45.517" v="461" actId="20577"/>
           <ac:spMkLst>
             <pc:docMk/>
             <pc:sldMk cId="2414567693" sldId="263"/>
@@ -364,8 +364,8 @@
           </ac:picMkLst>
         </pc:picChg>
       </pc:sldChg>
-      <pc:sldChg chg="addSp delSp modSp mod modShow modNotesTx">
-        <pc:chgData name="Stepanov, Pavel Aleksandrovich" userId="b85f6bca-230c-483e-a25b-e13e873626fd" providerId="ADAL" clId="{AB235781-41D1-50B9-86EA-51A98A5F500A}" dt="2026-04-12T02:51:55.024" v="225" actId="20577"/>
+      <pc:sldChg chg="addSp delSp modSp del mod modShow modNotesTx">
+        <pc:chgData name="Stepanov, Pavel Aleksandrovich" userId="b85f6bca-230c-483e-a25b-e13e873626fd" providerId="ADAL" clId="{AB235781-41D1-50B9-86EA-51A98A5F500A}" dt="2026-04-12T03:18:40.014" v="433" actId="2696"/>
         <pc:sldMkLst>
           <pc:docMk/>
           <pc:sldMk cId="2606525707" sldId="264"/>
@@ -667,6 +667,69 @@
           </ac:spMkLst>
         </pc:spChg>
       </pc:sldChg>
+      <pc:sldChg chg="addSp delSp modSp add mod setBg">
+        <pc:chgData name="Stepanov, Pavel Aleksandrovich" userId="b85f6bca-230c-483e-a25b-e13e873626fd" providerId="ADAL" clId="{AB235781-41D1-50B9-86EA-51A98A5F500A}" dt="2026-04-12T03:20:28.396" v="474" actId="1076"/>
+        <pc:sldMkLst>
+          <pc:docMk/>
+          <pc:sldMk cId="1281361301" sldId="273"/>
+        </pc:sldMkLst>
+        <pc:spChg chg="mod">
+          <ac:chgData name="Stepanov, Pavel Aleksandrovich" userId="b85f6bca-230c-483e-a25b-e13e873626fd" providerId="ADAL" clId="{AB235781-41D1-50B9-86EA-51A98A5F500A}" dt="2026-04-12T03:19:37.455" v="452" actId="20577"/>
+          <ac:spMkLst>
+            <pc:docMk/>
+            <pc:sldMk cId="1281361301" sldId="273"/>
+            <ac:spMk id="4" creationId="{3BC7CBD6-37D5-6E4F-C6C3-1A6035A75370}"/>
+          </ac:spMkLst>
+        </pc:spChg>
+        <pc:spChg chg="add mod">
+          <ac:chgData name="Stepanov, Pavel Aleksandrovich" userId="b85f6bca-230c-483e-a25b-e13e873626fd" providerId="ADAL" clId="{AB235781-41D1-50B9-86EA-51A98A5F500A}" dt="2026-04-12T03:20:28.396" v="474" actId="1076"/>
+          <ac:spMkLst>
+            <pc:docMk/>
+            <pc:sldMk cId="1281361301" sldId="273"/>
+            <ac:spMk id="6" creationId="{B02F38D1-095A-4D26-04B1-8A6E8A730D5B}"/>
+          </ac:spMkLst>
+        </pc:spChg>
+        <pc:spChg chg="mod">
+          <ac:chgData name="Stepanov, Pavel Aleksandrovich" userId="b85f6bca-230c-483e-a25b-e13e873626fd" providerId="ADAL" clId="{AB235781-41D1-50B9-86EA-51A98A5F500A}" dt="2026-04-12T03:20:00.882" v="464" actId="166"/>
+          <ac:spMkLst>
+            <pc:docMk/>
+            <pc:sldMk cId="1281361301" sldId="273"/>
+            <ac:spMk id="11" creationId="{FAECF00B-BAAD-8062-AE21-7865670210D8}"/>
+          </ac:spMkLst>
+        </pc:spChg>
+        <pc:spChg chg="del">
+          <ac:chgData name="Stepanov, Pavel Aleksandrovich" userId="b85f6bca-230c-483e-a25b-e13e873626fd" providerId="ADAL" clId="{AB235781-41D1-50B9-86EA-51A98A5F500A}" dt="2026-04-12T03:19:54.452" v="462" actId="478"/>
+          <ac:spMkLst>
+            <pc:docMk/>
+            <pc:sldMk cId="1281361301" sldId="273"/>
+            <ac:spMk id="24" creationId="{4199E7C9-C651-748D-B448-AF87E6E635B2}"/>
+          </ac:spMkLst>
+        </pc:spChg>
+        <pc:graphicFrameChg chg="del">
+          <ac:chgData name="Stepanov, Pavel Aleksandrovich" userId="b85f6bca-230c-483e-a25b-e13e873626fd" providerId="ADAL" clId="{AB235781-41D1-50B9-86EA-51A98A5F500A}" dt="2026-04-12T03:19:15.888" v="435" actId="478"/>
+          <ac:graphicFrameMkLst>
+            <pc:docMk/>
+            <pc:sldMk cId="1281361301" sldId="273"/>
+            <ac:graphicFrameMk id="3" creationId="{0A47DA39-5F6F-5D5E-07F9-E8C3F200C9FB}"/>
+          </ac:graphicFrameMkLst>
+        </pc:graphicFrameChg>
+        <pc:picChg chg="add mod">
+          <ac:chgData name="Stepanov, Pavel Aleksandrovich" userId="b85f6bca-230c-483e-a25b-e13e873626fd" providerId="ADAL" clId="{AB235781-41D1-50B9-86EA-51A98A5F500A}" dt="2026-04-12T03:19:24.909" v="439" actId="1076"/>
+          <ac:picMkLst>
+            <pc:docMk/>
+            <pc:sldMk cId="1281361301" sldId="273"/>
+            <ac:picMk id="5" creationId="{4512D806-F24A-215A-2C44-C03E07EBCB16}"/>
+          </ac:picMkLst>
+        </pc:picChg>
+        <pc:picChg chg="del">
+          <ac:chgData name="Stepanov, Pavel Aleksandrovich" userId="b85f6bca-230c-483e-a25b-e13e873626fd" providerId="ADAL" clId="{AB235781-41D1-50B9-86EA-51A98A5F500A}" dt="2026-04-12T03:19:16.846" v="436" actId="478"/>
+          <ac:picMkLst>
+            <pc:docMk/>
+            <pc:sldMk cId="1281361301" sldId="273"/>
+            <ac:picMk id="13" creationId="{8223FEB2-26FA-FB40-A95B-A7F8D4402C7F}"/>
+          </ac:picMkLst>
+        </pc:picChg>
+      </pc:sldChg>
     </pc:docChg>
   </pc:docChgLst>
 </pc:chgInfo>
@@ -4846,7 +4909,7 @@
         <p:cNvPr id="1" name="">
           <a:extLst>
             <a:ext uri="{FF2B5EF4-FFF2-40B4-BE49-F238E27FC236}">
-              <a16:creationId xmlns:a16="http://schemas.microsoft.com/office/drawing/2014/main" id="{458667FE-FC07-046B-D411-11854A1223C6}"/>
+              <a16:creationId xmlns:a16="http://schemas.microsoft.com/office/drawing/2014/main" id="{97109FF3-0E1E-B595-DAB1-1FA74AC77A6A}"/>
             </a:ext>
           </a:extLst>
         </p:cNvPr>
@@ -4866,7 +4929,7 @@
           <p:cNvPr id="2" name="Slide Image Placeholder 1">
             <a:extLst>
               <a:ext uri="{FF2B5EF4-FFF2-40B4-BE49-F238E27FC236}">
-                <a16:creationId xmlns:a16="http://schemas.microsoft.com/office/drawing/2014/main" id="{38352853-3AB6-9C9D-16AF-B6706B83B479}"/>
+                <a16:creationId xmlns:a16="http://schemas.microsoft.com/office/drawing/2014/main" id="{2F3A3788-FE25-11BE-4F0E-38D803CBA1B1}"/>
               </a:ext>
             </a:extLst>
           </p:cNvPr>
@@ -4884,7 +4947,7 @@
           <p:cNvPr id="3" name="Notes Placeholder 2">
             <a:extLst>
               <a:ext uri="{FF2B5EF4-FFF2-40B4-BE49-F238E27FC236}">
-                <a16:creationId xmlns:a16="http://schemas.microsoft.com/office/drawing/2014/main" id="{6662628F-3F1B-9BED-6991-834FD35D8ACB}"/>
+                <a16:creationId xmlns:a16="http://schemas.microsoft.com/office/drawing/2014/main" id="{29E121FB-12F1-FD40-7BB7-77FE142C8838}"/>
               </a:ext>
             </a:extLst>
           </p:cNvPr>
@@ -4901,23 +4964,7 @@
           <a:lstStyle/>
           <a:p>
             <a:r>
-              <a:rPr lang="en-US" sz="1200" b="1" dirty="0">
-                <a:latin typeface="GT Walsheim Trial Th" pitchFamily="2" charset="77"/>
-              </a:rPr>
-              <a:t>JUSTIN:</a:t>
-            </a:r>
-            <a:br>
-              <a:rPr lang="en-US" sz="1200" b="1" dirty="0">
-                <a:latin typeface="GT Walsheim Trial Th" pitchFamily="2" charset="77"/>
-              </a:rPr>
-            </a:br>
-            <a:br>
-              <a:rPr lang="en-US" sz="1200" b="1" dirty="0">
-                <a:latin typeface="GT Walsheim Trial Th" pitchFamily="2" charset="77"/>
-              </a:rPr>
-            </a:br>
-            <a:r>
-              <a:rPr lang="en-US" sz="1200" b="0" i="0" kern="1200" dirty="0">
+              <a:rPr lang="en-US" sz="1200" b="1" i="0" kern="1200" dirty="0">
                 <a:solidFill>
                   <a:schemeClr val="tx1"/>
                 </a:solidFill>
@@ -4926,87 +4973,11 @@
                 <a:ea typeface="+mn-ea"/>
                 <a:cs typeface="+mn-cs"/>
               </a:rPr>
-              <a:t>Before diving into the models, let me give you a sense of what this data actually looks like.</a:t>
-            </a:r>
-          </a:p>
-          <a:p>
-            <a:r>
-              <a:rPr lang="en-US" sz="1200" b="0" i="0" kern="1200" dirty="0">
-                <a:solidFill>
-                  <a:schemeClr val="tx1"/>
-                </a:solidFill>
-                <a:effectLst/>
-                <a:latin typeface="+mn-lt"/>
-                <a:ea typeface="+mn-ea"/>
-                <a:cs typeface="+mn-cs"/>
-              </a:rPr>
-              <a:t>We extracted from </a:t>
-            </a:r>
-            <a:r>
-              <a:rPr lang="en-US" sz="1200" b="1" i="0" kern="1200" dirty="0">
-                <a:solidFill>
-                  <a:schemeClr val="tx1"/>
-                </a:solidFill>
-                <a:effectLst/>
-                <a:latin typeface="+mn-lt"/>
-                <a:ea typeface="+mn-ea"/>
-                <a:cs typeface="+mn-cs"/>
-              </a:rPr>
-              <a:t>300 scenarios</a:t>
-            </a:r>
-            <a:r>
-              <a:rPr lang="en-US" sz="1200" b="0" i="0" kern="1200" dirty="0">
-                <a:solidFill>
-                  <a:schemeClr val="tx1"/>
-                </a:solidFill>
-                <a:effectLst/>
-                <a:latin typeface="+mn-lt"/>
-                <a:ea typeface="+mn-ea"/>
-                <a:cs typeface="+mn-cs"/>
-              </a:rPr>
-              <a:t> from the validation split of the Waymo Open Motion Dataset — specifically shard 00000-of-00150. That gives us </a:t>
-            </a:r>
-            <a:r>
-              <a:rPr lang="en-US" sz="1200" b="1" i="0" kern="1200" dirty="0">
-                <a:solidFill>
-                  <a:schemeClr val="tx1"/>
-                </a:solidFill>
-                <a:effectLst/>
-                <a:latin typeface="+mn-lt"/>
-                <a:ea typeface="+mn-ea"/>
-                <a:cs typeface="+mn-cs"/>
-              </a:rPr>
-              <a:t>18,311 raw agent observations</a:t>
-            </a:r>
-            <a:r>
-              <a:rPr lang="en-US" sz="1200" b="0" i="0" kern="1200" dirty="0">
-                <a:solidFill>
-                  <a:schemeClr val="tx1"/>
-                </a:solidFill>
-                <a:effectLst/>
-                <a:latin typeface="+mn-lt"/>
-                <a:ea typeface="+mn-ea"/>
-                <a:cs typeface="+mn-cs"/>
-              </a:rPr>
-              <a:t> across vehicles, pedestrians, cyclists, and the Waymo self-driving car itself, which we exclude from all analysis.</a:t>
-            </a:r>
-          </a:p>
-          <a:p>
-            <a:r>
-              <a:rPr lang="en-US" sz="1200" b="0" i="0" kern="1200" dirty="0">
-                <a:solidFill>
-                  <a:schemeClr val="tx1"/>
-                </a:solidFill>
-                <a:effectLst/>
-                <a:latin typeface="+mn-lt"/>
-                <a:ea typeface="+mn-ea"/>
-                <a:cs typeface="+mn-cs"/>
-              </a:rPr>
-              <a:t>In terms of composition: vehicles make up the clear majority of the dataset, pedestrians account for roughly 25%, and cyclists around 5%. This imbalance matters because it affects both the anomaly detection and how we interpret per-class statistics.</a:t>
-            </a:r>
-          </a:p>
-          <a:p>
-            <a:endParaRPr lang="en-US" sz="1200" b="0" i="0" kern="1200" dirty="0">
+              <a:t>JUSTIN:</a:t>
+            </a:r>
+          </a:p>
+          <a:p>
+            <a:endParaRPr lang="en-US" sz="1200" b="1" i="0" kern="1200" dirty="0">
               <a:solidFill>
                 <a:schemeClr val="tx1"/>
               </a:solidFill>
@@ -5027,7 +4998,7 @@
                 <a:ea typeface="+mn-ea"/>
                 <a:cs typeface="+mn-cs"/>
               </a:rPr>
-              <a:t>A few things worth noting about the raw data before any filtering. When you look at mean speeds including stationary agents, vehicles actually appear slower than cyclists — counterintuitive, and it's entirely because a large fraction of vehicles are stopped at intersections. The moment you filter to moving agents only, the expected ordering returns: vehicles fastest, then cyclists, then pedestrians.</a:t>
+              <a:t>Before diving into the models, let me give you a sense of what this data actually looks like.</a:t>
             </a:r>
           </a:p>
           <a:p>
@@ -5041,10 +5012,10 @@
                 <a:ea typeface="+mn-ea"/>
                 <a:cs typeface="+mn-cs"/>
               </a:rPr>
-              <a:t>Waymo also provides behavioral flags: </a:t>
-            </a:r>
-            <a:r>
-              <a:rPr lang="en-US" sz="1200" b="0" i="0" kern="1200" dirty="0" err="1">
+              <a:t>We extracted from </a:t>
+            </a:r>
+            <a:r>
+              <a:rPr lang="en-US" sz="1200" b="1" i="0" kern="1200" dirty="0">
                 <a:solidFill>
                   <a:schemeClr val="tx1"/>
                 </a:solidFill>
@@ -5053,7 +5024,7 @@
                 <a:ea typeface="+mn-ea"/>
                 <a:cs typeface="+mn-cs"/>
               </a:rPr>
-              <a:t>IsInteractive</a:t>
+              <a:t>300 scenarios</a:t>
             </a:r>
             <a:r>
               <a:rPr lang="en-US" sz="1200" b="0" i="0" kern="1200" dirty="0">
@@ -5065,10 +5036,10 @@
                 <a:ea typeface="+mn-ea"/>
                 <a:cs typeface="+mn-cs"/>
               </a:rPr>
-              <a:t> marks agents relevant to the AV's immediate planning — typically nearby vehicles in adjacent lanes or at intersections. </a:t>
-            </a:r>
-            <a:r>
-              <a:rPr lang="en-US" sz="1200" b="0" i="0" kern="1200" dirty="0" err="1">
+              <a:t> from the validation split of the Waymo Open Motion Dataset — specifically shard 00000-of-00150. That gives us </a:t>
+            </a:r>
+            <a:r>
+              <a:rPr lang="en-US" sz="1200" b="1" i="0" kern="1200" dirty="0">
                 <a:solidFill>
                   <a:schemeClr val="tx1"/>
                 </a:solidFill>
@@ -5077,7 +5048,7 @@
                 <a:ea typeface="+mn-ea"/>
                 <a:cs typeface="+mn-cs"/>
               </a:rPr>
-              <a:t>IsSDC</a:t>
+              <a:t>18,311 raw agent observations</a:t>
             </a:r>
             <a:r>
               <a:rPr lang="en-US" sz="1200" b="0" i="0" kern="1200" dirty="0">
@@ -5089,11 +5060,109 @@
                 <a:ea typeface="+mn-ea"/>
                 <a:cs typeface="+mn-cs"/>
               </a:rPr>
+              <a:t> across vehicles, pedestrians, cyclists, and the Waymo self-driving car itself, which we exclude from all analysis.</a:t>
+            </a:r>
+          </a:p>
+          <a:p>
+            <a:r>
+              <a:rPr lang="en-US" sz="1200" b="0" i="0" kern="1200" dirty="0">
+                <a:solidFill>
+                  <a:schemeClr val="tx1"/>
+                </a:solidFill>
+                <a:effectLst/>
+                <a:latin typeface="+mn-lt"/>
+                <a:ea typeface="+mn-ea"/>
+                <a:cs typeface="+mn-cs"/>
+              </a:rPr>
+              <a:t>In terms of composition: vehicles make up the clear majority of the dataset, pedestrians account for roughly 25%, and cyclists around 5%. This imbalance matters because it affects both the anomaly detection and how we interpret per-class statistics.</a:t>
+            </a:r>
+          </a:p>
+          <a:p>
+            <a:r>
+              <a:rPr lang="en-US" sz="1200" b="0" i="0" kern="1200" dirty="0">
+                <a:solidFill>
+                  <a:schemeClr val="tx1"/>
+                </a:solidFill>
+                <a:effectLst/>
+                <a:latin typeface="+mn-lt"/>
+                <a:ea typeface="+mn-ea"/>
+                <a:cs typeface="+mn-cs"/>
+              </a:rPr>
+              <a:t>A few things worth noting about the raw data before any filtering. When you look at mean speeds including stationary agents, vehicles actually appear slower than cyclists — counterintuitive, and it's entirely because a large fraction of vehicles are stopped at intersections. The moment you filter to moving agents only, the expected ordering returns: vehicles fastest, then cyclists, then pedestrians.</a:t>
+            </a:r>
+          </a:p>
+          <a:p>
+            <a:r>
+              <a:rPr lang="en-US" sz="1200" b="0" i="0" kern="1200" dirty="0">
+                <a:solidFill>
+                  <a:schemeClr val="tx1"/>
+                </a:solidFill>
+                <a:effectLst/>
+                <a:latin typeface="+mn-lt"/>
+                <a:ea typeface="+mn-ea"/>
+                <a:cs typeface="+mn-cs"/>
+              </a:rPr>
+              <a:t>Waymo also provides behavioral flags: </a:t>
+            </a:r>
+            <a:r>
+              <a:rPr lang="en-US" sz="1200" b="0" i="0" kern="1200" dirty="0" err="1">
+                <a:solidFill>
+                  <a:schemeClr val="tx1"/>
+                </a:solidFill>
+                <a:effectLst/>
+                <a:latin typeface="+mn-lt"/>
+                <a:ea typeface="+mn-ea"/>
+                <a:cs typeface="+mn-cs"/>
+              </a:rPr>
+              <a:t>IsInteractive</a:t>
+            </a:r>
+            <a:r>
+              <a:rPr lang="en-US" sz="1200" b="0" i="0" kern="1200" dirty="0">
+                <a:solidFill>
+                  <a:schemeClr val="tx1"/>
+                </a:solidFill>
+                <a:effectLst/>
+                <a:latin typeface="+mn-lt"/>
+                <a:ea typeface="+mn-ea"/>
+                <a:cs typeface="+mn-cs"/>
+              </a:rPr>
+              <a:t> marks agents relevant to the AV's immediate planning — typically nearby vehicles in adjacent lanes or at intersections. </a:t>
+            </a:r>
+            <a:r>
+              <a:rPr lang="en-US" sz="1200" b="0" i="0" kern="1200" dirty="0" err="1">
+                <a:solidFill>
+                  <a:schemeClr val="tx1"/>
+                </a:solidFill>
+                <a:effectLst/>
+                <a:latin typeface="+mn-lt"/>
+                <a:ea typeface="+mn-ea"/>
+                <a:cs typeface="+mn-cs"/>
+              </a:rPr>
+              <a:t>IsSDC</a:t>
+            </a:r>
+            <a:r>
+              <a:rPr lang="en-US" sz="1200" b="0" i="0" kern="1200" dirty="0">
+                <a:solidFill>
+                  <a:schemeClr val="tx1"/>
+                </a:solidFill>
+                <a:effectLst/>
+                <a:latin typeface="+mn-lt"/>
+                <a:ea typeface="+mn-ea"/>
+                <a:cs typeface="+mn-cs"/>
+              </a:rPr>
               <a:t> identifies the self-driving car itself. These flags are not safety-incident labels — they're proximity-based planning annotations — and that distinction will matter when we interpret the anomaly results.</a:t>
             </a:r>
           </a:p>
           <a:p>
-            <a:endParaRPr lang="en-US" b="1" dirty="0"/>
+            <a:endParaRPr lang="en-US" sz="1200" b="1" i="0" kern="1200" dirty="0">
+              <a:solidFill>
+                <a:schemeClr val="tx1"/>
+              </a:solidFill>
+              <a:effectLst/>
+              <a:latin typeface="+mn-lt"/>
+              <a:ea typeface="+mn-ea"/>
+              <a:cs typeface="+mn-cs"/>
+            </a:endParaRPr>
           </a:p>
         </p:txBody>
       </p:sp>
@@ -5102,7 +5171,7 @@
           <p:cNvPr id="4" name="Slide Number Placeholder 3">
             <a:extLst>
               <a:ext uri="{FF2B5EF4-FFF2-40B4-BE49-F238E27FC236}">
-                <a16:creationId xmlns:a16="http://schemas.microsoft.com/office/drawing/2014/main" id="{858B9044-01F3-7D9D-2FBA-CE7EF15B93B8}"/>
+                <a16:creationId xmlns:a16="http://schemas.microsoft.com/office/drawing/2014/main" id="{5DC55008-2FD4-A8DF-2215-50EE4970E143}"/>
               </a:ext>
             </a:extLst>
           </p:cNvPr>
@@ -5129,7 +5198,7 @@
     </p:spTree>
     <p:extLst>
       <p:ext uri="{BB962C8B-B14F-4D97-AF65-F5344CB8AC3E}">
-        <p14:creationId xmlns:p14="http://schemas.microsoft.com/office/powerpoint/2010/main" val="4041322977"/>
+        <p14:creationId xmlns:p14="http://schemas.microsoft.com/office/powerpoint/2010/main" val="2027805787"/>
       </p:ext>
     </p:extLst>
   </p:cSld>
@@ -21755,7 +21824,7 @@
               <a:rPr lang="en-US" sz="1500" dirty="0">
                 <a:latin typeface="GT Walsheim Trial Rg" pitchFamily="2" charset="77"/>
               </a:rPr>
-              <a:t>DATASET STATISTICS</a:t>
+              <a:t>PART 1: DATASET STATISTICS</a:t>
             </a:r>
           </a:p>
         </p:txBody>
@@ -23095,7 +23164,7 @@
         <p:cNvPr id="1" name="">
           <a:extLst>
             <a:ext uri="{FF2B5EF4-FFF2-40B4-BE49-F238E27FC236}">
-              <a16:creationId xmlns:a16="http://schemas.microsoft.com/office/drawing/2014/main" id="{684AF451-3682-FF2C-D616-3F71F91C5AC6}"/>
+              <a16:creationId xmlns:a16="http://schemas.microsoft.com/office/drawing/2014/main" id="{B7D1694B-ADF8-C7B3-5BF9-D767B9134B8C}"/>
             </a:ext>
           </a:extLst>
         </p:cNvPr>
@@ -23110,12 +23179,87 @@
           <a:chExt cx="0" cy="0"/>
         </a:xfrm>
       </p:grpSpPr>
+      <p:sp>
+        <p:nvSpPr>
+          <p:cNvPr id="4" name="Title 3">
+            <a:extLst>
+              <a:ext uri="{FF2B5EF4-FFF2-40B4-BE49-F238E27FC236}">
+                <a16:creationId xmlns:a16="http://schemas.microsoft.com/office/drawing/2014/main" id="{3BC7CBD6-37D5-6E4F-C6C3-1A6035A75370}"/>
+              </a:ext>
+            </a:extLst>
+          </p:cNvPr>
+          <p:cNvSpPr>
+            <a:spLocks noGrp="1"/>
+          </p:cNvSpPr>
+          <p:nvPr>
+            <p:ph type="ctrTitle"/>
+          </p:nvPr>
+        </p:nvSpPr>
+        <p:spPr>
+          <a:xfrm>
+            <a:off x="716478" y="447821"/>
+            <a:ext cx="3347522" cy="369333"/>
+          </a:xfrm>
+        </p:spPr>
+        <p:txBody>
+          <a:bodyPr>
+            <a:normAutofit/>
+          </a:bodyPr>
+          <a:lstStyle/>
+          <a:p>
+            <a:pPr algn="l"/>
+            <a:r>
+              <a:rPr lang="en-US" sz="1500" dirty="0">
+                <a:latin typeface="GT Walsheim Trial Rg" pitchFamily="2" charset="77"/>
+              </a:rPr>
+              <a:t>PART 2: DATASET STATISTICS </a:t>
+            </a:r>
+          </a:p>
+        </p:txBody>
+      </p:sp>
+      <p:sp>
+        <p:nvSpPr>
+          <p:cNvPr id="8" name="TextBox 7">
+            <a:extLst>
+              <a:ext uri="{FF2B5EF4-FFF2-40B4-BE49-F238E27FC236}">
+                <a16:creationId xmlns:a16="http://schemas.microsoft.com/office/drawing/2014/main" id="{1AD48543-E349-8F3E-32BE-70942649497F}"/>
+              </a:ext>
+            </a:extLst>
+          </p:cNvPr>
+          <p:cNvSpPr txBox="1"/>
+          <p:nvPr/>
+        </p:nvSpPr>
+        <p:spPr>
+          <a:xfrm>
+            <a:off x="716477" y="952090"/>
+            <a:ext cx="7346867" cy="630942"/>
+          </a:xfrm>
+          <a:prstGeom prst="rect">
+            <a:avLst/>
+          </a:prstGeom>
+          <a:noFill/>
+        </p:spPr>
+        <p:txBody>
+          <a:bodyPr wrap="square">
+            <a:spAutoFit/>
+          </a:bodyPr>
+          <a:lstStyle/>
+          <a:p>
+            <a:r>
+              <a:rPr lang="en-US" sz="3500" dirty="0">
+                <a:latin typeface="GT Walsheim Trial Rg" pitchFamily="2" charset="77"/>
+              </a:rPr>
+              <a:t>What the Data Looks Like</a:t>
+            </a:r>
+          </a:p>
+        </p:txBody>
+      </p:sp>
       <p:pic>
         <p:nvPicPr>
-          <p:cNvPr id="6" name="Picture 2" descr="Waymo Logo">
+          <p:cNvPr id="14" name="Picture 2" descr="Waymo Logo">
             <a:extLst>
               <a:ext uri="{FF2B5EF4-FFF2-40B4-BE49-F238E27FC236}">
-                <a16:creationId xmlns:a16="http://schemas.microsoft.com/office/drawing/2014/main" id="{73A17D98-85BB-1349-8904-4995BA7F417F}"/>
+                <a16:creationId xmlns:a16="http://schemas.microsoft.com/office/drawing/2014/main" id="{2B47F978-21C8-273E-24DC-5FC952B51D7C}"/>
               </a:ext>
             </a:extLst>
           </p:cNvPr>
@@ -23157,1093 +23301,224 @@
           </a:extLst>
         </p:spPr>
       </p:pic>
-      <p:sp>
-        <p:nvSpPr>
-          <p:cNvPr id="9" name="Title 3">
+      <p:pic>
+        <p:nvPicPr>
+          <p:cNvPr id="5" name="Picture 4">
             <a:extLst>
               <a:ext uri="{FF2B5EF4-FFF2-40B4-BE49-F238E27FC236}">
-                <a16:creationId xmlns:a16="http://schemas.microsoft.com/office/drawing/2014/main" id="{048C4A0F-704A-1B42-09A0-E1CEA1F85F1A}"/>
+                <a16:creationId xmlns:a16="http://schemas.microsoft.com/office/drawing/2014/main" id="{4512D806-F24A-215A-2C44-C03E07EBCB16}"/>
               </a:ext>
             </a:extLst>
           </p:cNvPr>
-          <p:cNvSpPr txBox="1">
-            <a:spLocks/>
-          </p:cNvSpPr>
+          <p:cNvPicPr>
+            <a:picLocks noChangeAspect="1"/>
+          </p:cNvPicPr>
           <p:nvPr/>
-        </p:nvSpPr>
+        </p:nvPicPr>
+        <p:blipFill>
+          <a:blip r:embed="rId4"/>
+          <a:stretch>
+            <a:fillRect/>
+          </a:stretch>
+        </p:blipFill>
         <p:spPr>
           <a:xfrm>
-            <a:off x="716478" y="447821"/>
-            <a:ext cx="2406732" cy="369333"/>
+            <a:off x="2438400" y="1912451"/>
+            <a:ext cx="7315200" cy="4572000"/>
           </a:xfrm>
           <a:prstGeom prst="rect">
             <a:avLst/>
           </a:prstGeom>
         </p:spPr>
+      </p:pic>
+      <p:sp>
+        <p:nvSpPr>
+          <p:cNvPr id="11" name="Freeform 10">
+            <a:extLst>
+              <a:ext uri="{FF2B5EF4-FFF2-40B4-BE49-F238E27FC236}">
+                <a16:creationId xmlns:a16="http://schemas.microsoft.com/office/drawing/2014/main" id="{FAECF00B-BAAD-8062-AE21-7865670210D8}"/>
+              </a:ext>
+            </a:extLst>
+          </p:cNvPr>
+          <p:cNvSpPr/>
+          <p:nvPr/>
+        </p:nvSpPr>
+        <p:spPr>
+          <a:xfrm rot="7893553">
+            <a:off x="-317208" y="-200894"/>
+            <a:ext cx="18800064" cy="6958229"/>
+          </a:xfrm>
+          <a:custGeom>
+            <a:avLst/>
+            <a:gdLst>
+              <a:gd name="csX0" fmla="*/ 0 w 18800064"/>
+              <a:gd name="csY0" fmla="*/ 7187173 h 7187173"/>
+              <a:gd name="csX1" fmla="*/ 7863840 w 18800064"/>
+              <a:gd name="csY1" fmla="*/ 18277 h 7187173"/>
+              <a:gd name="csX2" fmla="*/ 18800064 w 18800064"/>
+              <a:gd name="csY2" fmla="*/ 5248645 h 7187173"/>
+            </a:gdLst>
+            <a:ahLst/>
+            <a:cxnLst>
+              <a:cxn ang="0">
+                <a:pos x="csX0" y="csY0"/>
+              </a:cxn>
+              <a:cxn ang="0">
+                <a:pos x="csX1" y="csY1"/>
+              </a:cxn>
+              <a:cxn ang="0">
+                <a:pos x="csX2" y="csY2"/>
+              </a:cxn>
+            </a:cxnLst>
+            <a:rect l="l" t="t" r="r" b="b"/>
+            <a:pathLst>
+              <a:path w="18800064" h="7187173">
+                <a:moveTo>
+                  <a:pt x="0" y="7187173"/>
+                </a:moveTo>
+                <a:cubicBezTo>
+                  <a:pt x="2365248" y="3764269"/>
+                  <a:pt x="4730496" y="341365"/>
+                  <a:pt x="7863840" y="18277"/>
+                </a:cubicBezTo>
+                <a:cubicBezTo>
+                  <a:pt x="10997184" y="-304811"/>
+                  <a:pt x="17586960" y="3742933"/>
+                  <a:pt x="18800064" y="5248645"/>
+                </a:cubicBezTo>
+              </a:path>
+            </a:pathLst>
+          </a:custGeom>
+          <a:noFill/>
+          <a:ln w="635000">
+            <a:solidFill>
+              <a:schemeClr val="tx1">
+                <a:alpha val="3000"/>
+              </a:schemeClr>
+            </a:solidFill>
+          </a:ln>
+        </p:spPr>
+        <p:style>
+          <a:lnRef idx="2">
+            <a:schemeClr val="accent1">
+              <a:shade val="15000"/>
+            </a:schemeClr>
+          </a:lnRef>
+          <a:fillRef idx="1">
+            <a:schemeClr val="accent1"/>
+          </a:fillRef>
+          <a:effectRef idx="0">
+            <a:schemeClr val="accent1"/>
+          </a:effectRef>
+          <a:fontRef idx="minor">
+            <a:schemeClr val="lt1"/>
+          </a:fontRef>
+        </p:style>
         <p:txBody>
-          <a:bodyPr vert="horz" lIns="91440" tIns="45720" rIns="91440" bIns="45720" rtlCol="0" anchor="b">
-            <a:normAutofit/>
-          </a:bodyPr>
-          <a:lstStyle>
-            <a:lvl1pPr algn="ctr" defTabSz="914400" rtl="0" eaLnBrk="1" latinLnBrk="0" hangingPunct="1">
-              <a:lnSpc>
-                <a:spcPct val="90000"/>
-              </a:lnSpc>
-              <a:spcBef>
-                <a:spcPct val="0"/>
-              </a:spcBef>
-              <a:buNone/>
-              <a:defRPr sz="6000" kern="1200">
-                <a:solidFill>
-                  <a:schemeClr val="tx1"/>
-                </a:solidFill>
-                <a:latin typeface="+mj-lt"/>
-                <a:ea typeface="+mj-ea"/>
-                <a:cs typeface="+mj-cs"/>
-              </a:defRPr>
-            </a:lvl1pPr>
-          </a:lstStyle>
-          <a:p>
-            <a:pPr algn="l"/>
-            <a:r>
-              <a:rPr lang="en-US" sz="1500" dirty="0">
-                <a:solidFill>
-                  <a:srgbClr val="989DA2"/>
-                </a:solidFill>
-                <a:latin typeface="GT Walsheim Trial Rg" pitchFamily="2" charset="77"/>
-              </a:rPr>
-              <a:t>DATASET STATISTICS</a:t>
-            </a:r>
+          <a:bodyPr rtlCol="0" anchor="ctr"/>
+          <a:lstStyle/>
+          <a:p>
+            <a:pPr algn="ctr"/>
+            <a:endParaRPr lang="en-US"/>
           </a:p>
         </p:txBody>
       </p:sp>
       <p:sp>
         <p:nvSpPr>
-          <p:cNvPr id="11" name="TextBox 10">
+          <p:cNvPr id="6" name="Freeform 5">
             <a:extLst>
               <a:ext uri="{FF2B5EF4-FFF2-40B4-BE49-F238E27FC236}">
-                <a16:creationId xmlns:a16="http://schemas.microsoft.com/office/drawing/2014/main" id="{B6033FA2-EB1F-F693-6FA4-7BB8813D9CDA}"/>
+                <a16:creationId xmlns:a16="http://schemas.microsoft.com/office/drawing/2014/main" id="{B02F38D1-095A-4D26-04B1-8A6E8A730D5B}"/>
               </a:ext>
             </a:extLst>
           </p:cNvPr>
-          <p:cNvSpPr txBox="1"/>
+          <p:cNvSpPr/>
           <p:nvPr/>
         </p:nvSpPr>
         <p:spPr>
-          <a:xfrm>
-            <a:off x="716478" y="952090"/>
-            <a:ext cx="6097978" cy="630942"/>
+          <a:xfrm rot="17550971">
+            <a:off x="-6037072" y="1435617"/>
+            <a:ext cx="18800064" cy="6958229"/>
           </a:xfrm>
-          <a:prstGeom prst="rect">
+          <a:custGeom>
             <a:avLst/>
-          </a:prstGeom>
+            <a:gdLst>
+              <a:gd name="csX0" fmla="*/ 0 w 18800064"/>
+              <a:gd name="csY0" fmla="*/ 7187173 h 7187173"/>
+              <a:gd name="csX1" fmla="*/ 7863840 w 18800064"/>
+              <a:gd name="csY1" fmla="*/ 18277 h 7187173"/>
+              <a:gd name="csX2" fmla="*/ 18800064 w 18800064"/>
+              <a:gd name="csY2" fmla="*/ 5248645 h 7187173"/>
+            </a:gdLst>
+            <a:ahLst/>
+            <a:cxnLst>
+              <a:cxn ang="0">
+                <a:pos x="csX0" y="csY0"/>
+              </a:cxn>
+              <a:cxn ang="0">
+                <a:pos x="csX1" y="csY1"/>
+              </a:cxn>
+              <a:cxn ang="0">
+                <a:pos x="csX2" y="csY2"/>
+              </a:cxn>
+            </a:cxnLst>
+            <a:rect l="l" t="t" r="r" b="b"/>
+            <a:pathLst>
+              <a:path w="18800064" h="7187173">
+                <a:moveTo>
+                  <a:pt x="0" y="7187173"/>
+                </a:moveTo>
+                <a:cubicBezTo>
+                  <a:pt x="2365248" y="3764269"/>
+                  <a:pt x="4730496" y="341365"/>
+                  <a:pt x="7863840" y="18277"/>
+                </a:cubicBezTo>
+                <a:cubicBezTo>
+                  <a:pt x="10997184" y="-304811"/>
+                  <a:pt x="17586960" y="3742933"/>
+                  <a:pt x="18800064" y="5248645"/>
+                </a:cubicBezTo>
+              </a:path>
+            </a:pathLst>
+          </a:custGeom>
           <a:noFill/>
+          <a:ln w="635000">
+            <a:solidFill>
+              <a:schemeClr val="tx1">
+                <a:alpha val="3000"/>
+              </a:schemeClr>
+            </a:solidFill>
+          </a:ln>
         </p:spPr>
+        <p:style>
+          <a:lnRef idx="2">
+            <a:schemeClr val="accent1">
+              <a:shade val="15000"/>
+            </a:schemeClr>
+          </a:lnRef>
+          <a:fillRef idx="1">
+            <a:schemeClr val="accent1"/>
+          </a:fillRef>
+          <a:effectRef idx="0">
+            <a:schemeClr val="accent1"/>
+          </a:effectRef>
+          <a:fontRef idx="minor">
+            <a:schemeClr val="lt1"/>
+          </a:fontRef>
+        </p:style>
         <p:txBody>
-          <a:bodyPr wrap="square">
-            <a:spAutoFit/>
-          </a:bodyPr>
+          <a:bodyPr rtlCol="0" anchor="ctr"/>
           <a:lstStyle/>
           <a:p>
-            <a:r>
-              <a:rPr lang="en-US" sz="3500" dirty="0">
-                <a:latin typeface="GT Walsheim Trial Rg" pitchFamily="2" charset="77"/>
-              </a:rPr>
-              <a:t>What the Data Looks Like</a:t>
-            </a:r>
+            <a:pPr algn="ctr"/>
+            <a:endParaRPr lang="en-US"/>
           </a:p>
         </p:txBody>
       </p:sp>
-      <p:graphicFrame>
-        <p:nvGraphicFramePr>
-          <p:cNvPr id="12" name="Table 11">
-            <a:extLst>
-              <a:ext uri="{FF2B5EF4-FFF2-40B4-BE49-F238E27FC236}">
-                <a16:creationId xmlns:a16="http://schemas.microsoft.com/office/drawing/2014/main" id="{060EF4B2-4504-8D76-A4E4-69FA63C93789}"/>
-              </a:ext>
-            </a:extLst>
-          </p:cNvPr>
-          <p:cNvGraphicFramePr>
-            <a:graphicFrameLocks noGrp="1"/>
-          </p:cNvGraphicFramePr>
-          <p:nvPr>
-            <p:extLst>
-              <p:ext uri="{D42A27DB-BD31-4B8C-83A1-F6EECF244321}">
-                <p14:modId xmlns:p14="http://schemas.microsoft.com/office/powerpoint/2010/main" val="4168928733"/>
-              </p:ext>
-            </p:extLst>
-          </p:nvPr>
-        </p:nvGraphicFramePr>
-        <p:xfrm>
-          <a:off x="716477" y="1932130"/>
-          <a:ext cx="10876350" cy="2646176"/>
-        </p:xfrm>
-        <a:graphic>
-          <a:graphicData uri="http://schemas.openxmlformats.org/drawingml/2006/table">
-            <a:tbl>
-              <a:tblPr firstRow="1" bandRow="1">
-                <a:tableStyleId>{073A0DAA-6AF3-43AB-8588-CEC1D06C72B9}</a:tableStyleId>
-              </a:tblPr>
-              <a:tblGrid>
-                <a:gridCol w="2447977">
-                  <a:extLst>
-                    <a:ext uri="{9D8B030D-6E8A-4147-A177-3AD203B41FA5}">
-                      <a16:colId xmlns:a16="http://schemas.microsoft.com/office/drawing/2014/main" val="1610543496"/>
-                    </a:ext>
-                  </a:extLst>
-                </a:gridCol>
-                <a:gridCol w="3801230">
-                  <a:extLst>
-                    <a:ext uri="{9D8B030D-6E8A-4147-A177-3AD203B41FA5}">
-                      <a16:colId xmlns:a16="http://schemas.microsoft.com/office/drawing/2014/main" val="2940384537"/>
-                    </a:ext>
-                  </a:extLst>
-                </a:gridCol>
-                <a:gridCol w="4627143">
-                  <a:extLst>
-                    <a:ext uri="{9D8B030D-6E8A-4147-A177-3AD203B41FA5}">
-                      <a16:colId xmlns:a16="http://schemas.microsoft.com/office/drawing/2014/main" val="3740313691"/>
-                    </a:ext>
-                  </a:extLst>
-                </a:gridCol>
-              </a:tblGrid>
-              <a:tr h="296694">
-                <a:tc>
-                  <a:txBody>
-                    <a:bodyPr/>
-                    <a:lstStyle/>
-                    <a:p>
-                      <a:r>
-                        <a:rPr lang="en-US" sz="1500" b="0" i="0" dirty="0">
-                          <a:solidFill>
-                            <a:schemeClr val="bg1"/>
-                          </a:solidFill>
-                          <a:latin typeface="GT Walsheim Trial Rg" pitchFamily="2" charset="77"/>
-                        </a:rPr>
-                        <a:t>Agent Type</a:t>
-                      </a:r>
-                    </a:p>
-                  </a:txBody>
-                  <a:tcPr>
-                    <a:lnL w="12700" cap="flat" cmpd="sng" algn="ctr">
-                      <a:noFill/>
-                      <a:prstDash val="solid"/>
-                      <a:round/>
-                      <a:headEnd type="none" w="med" len="med"/>
-                      <a:tailEnd type="none" w="med" len="med"/>
-                    </a:lnL>
-                    <a:lnR w="12700" cap="flat" cmpd="sng" algn="ctr">
-                      <a:noFill/>
-                      <a:prstDash val="solid"/>
-                      <a:round/>
-                      <a:headEnd type="none" w="med" len="med"/>
-                      <a:tailEnd type="none" w="med" len="med"/>
-                    </a:lnR>
-                    <a:lnT w="12700" cap="flat" cmpd="sng" algn="ctr">
-                      <a:noFill/>
-                      <a:prstDash val="solid"/>
-                      <a:round/>
-                      <a:headEnd type="none" w="med" len="med"/>
-                      <a:tailEnd type="none" w="med" len="med"/>
-                    </a:lnT>
-                    <a:lnB w="12700" cap="flat" cmpd="sng" algn="ctr">
-                      <a:noFill/>
-                      <a:prstDash val="solid"/>
-                      <a:round/>
-                      <a:headEnd type="none" w="med" len="med"/>
-                      <a:tailEnd type="none" w="med" len="med"/>
-                    </a:lnB>
-                    <a:lnTlToBr w="12700" cmpd="sng">
-                      <a:noFill/>
-                      <a:prstDash val="solid"/>
-                    </a:lnTlToBr>
-                    <a:lnBlToTr w="12700" cmpd="sng">
-                      <a:noFill/>
-                      <a:prstDash val="solid"/>
-                    </a:lnBlToTr>
-                    <a:solidFill>
-                      <a:srgbClr val="0078FF"/>
-                    </a:solidFill>
-                  </a:tcPr>
-                </a:tc>
-                <a:tc>
-                  <a:txBody>
-                    <a:bodyPr/>
-                    <a:lstStyle/>
-                    <a:p>
-                      <a:r>
-                        <a:rPr lang="en-US" sz="1500" b="0" i="0" dirty="0">
-                          <a:solidFill>
-                            <a:schemeClr val="bg1"/>
-                          </a:solidFill>
-                          <a:latin typeface="GT Walsheim Trial Rg" pitchFamily="2" charset="77"/>
-                        </a:rPr>
-                        <a:t>Share</a:t>
-                      </a:r>
-                    </a:p>
-                  </a:txBody>
-                  <a:tcPr>
-                    <a:lnL w="12700" cap="flat" cmpd="sng" algn="ctr">
-                      <a:noFill/>
-                      <a:prstDash val="solid"/>
-                      <a:round/>
-                      <a:headEnd type="none" w="med" len="med"/>
-                      <a:tailEnd type="none" w="med" len="med"/>
-                    </a:lnL>
-                    <a:lnR w="12700" cap="flat" cmpd="sng" algn="ctr">
-                      <a:noFill/>
-                      <a:prstDash val="solid"/>
-                      <a:round/>
-                      <a:headEnd type="none" w="med" len="med"/>
-                      <a:tailEnd type="none" w="med" len="med"/>
-                    </a:lnR>
-                    <a:lnT w="12700" cap="flat" cmpd="sng" algn="ctr">
-                      <a:noFill/>
-                      <a:prstDash val="solid"/>
-                      <a:round/>
-                      <a:headEnd type="none" w="med" len="med"/>
-                      <a:tailEnd type="none" w="med" len="med"/>
-                    </a:lnT>
-                    <a:lnB w="12700" cap="flat" cmpd="sng" algn="ctr">
-                      <a:noFill/>
-                      <a:prstDash val="solid"/>
-                      <a:round/>
-                      <a:headEnd type="none" w="med" len="med"/>
-                      <a:tailEnd type="none" w="med" len="med"/>
-                    </a:lnB>
-                    <a:lnTlToBr w="12700" cmpd="sng">
-                      <a:noFill/>
-                      <a:prstDash val="solid"/>
-                    </a:lnTlToBr>
-                    <a:lnBlToTr w="12700" cmpd="sng">
-                      <a:noFill/>
-                      <a:prstDash val="solid"/>
-                    </a:lnBlToTr>
-                    <a:solidFill>
-                      <a:srgbClr val="0078FF"/>
-                    </a:solidFill>
-                  </a:tcPr>
-                </a:tc>
-                <a:tc>
-                  <a:txBody>
-                    <a:bodyPr/>
-                    <a:lstStyle/>
-                    <a:p>
-                      <a:r>
-                        <a:rPr lang="en-US" sz="1500" b="0" i="0" dirty="0">
-                          <a:solidFill>
-                            <a:schemeClr val="bg1"/>
-                          </a:solidFill>
-                          <a:latin typeface="GT Walsheim Trial Rg" pitchFamily="2" charset="77"/>
-                        </a:rPr>
-                        <a:t>After preprocessing</a:t>
-                      </a:r>
-                    </a:p>
-                  </a:txBody>
-                  <a:tcPr>
-                    <a:lnL w="12700" cap="flat" cmpd="sng" algn="ctr">
-                      <a:noFill/>
-                      <a:prstDash val="solid"/>
-                      <a:round/>
-                      <a:headEnd type="none" w="med" len="med"/>
-                      <a:tailEnd type="none" w="med" len="med"/>
-                    </a:lnL>
-                    <a:lnR w="12700" cap="flat" cmpd="sng" algn="ctr">
-                      <a:noFill/>
-                      <a:prstDash val="solid"/>
-                      <a:round/>
-                      <a:headEnd type="none" w="med" len="med"/>
-                      <a:tailEnd type="none" w="med" len="med"/>
-                    </a:lnR>
-                    <a:lnT w="12700" cap="flat" cmpd="sng" algn="ctr">
-                      <a:noFill/>
-                      <a:prstDash val="solid"/>
-                      <a:round/>
-                      <a:headEnd type="none" w="med" len="med"/>
-                      <a:tailEnd type="none" w="med" len="med"/>
-                    </a:lnT>
-                    <a:lnB w="12700" cap="flat" cmpd="sng" algn="ctr">
-                      <a:noFill/>
-                      <a:prstDash val="solid"/>
-                      <a:round/>
-                      <a:headEnd type="none" w="med" len="med"/>
-                      <a:tailEnd type="none" w="med" len="med"/>
-                    </a:lnB>
-                    <a:lnTlToBr w="12700" cmpd="sng">
-                      <a:noFill/>
-                      <a:prstDash val="solid"/>
-                    </a:lnTlToBr>
-                    <a:lnBlToTr w="12700" cmpd="sng">
-                      <a:noFill/>
-                      <a:prstDash val="solid"/>
-                    </a:lnBlToTr>
-                    <a:solidFill>
-                      <a:srgbClr val="0078FF"/>
-                    </a:solidFill>
-                  </a:tcPr>
-                </a:tc>
-                <a:extLst>
-                  <a:ext uri="{0D108BD9-81ED-4DB2-BD59-A6C34878D82A}">
-                    <a16:rowId xmlns:a16="http://schemas.microsoft.com/office/drawing/2014/main" val="4220759275"/>
-                  </a:ext>
-                </a:extLst>
-              </a:tr>
-              <a:tr h="581534">
-                <a:tc>
-                  <a:txBody>
-                    <a:bodyPr/>
-                    <a:lstStyle/>
-                    <a:p>
-                      <a:r>
-                        <a:rPr lang="en-US" sz="1500" b="0" i="0" dirty="0">
-                          <a:solidFill>
-                            <a:schemeClr val="tx1"/>
-                          </a:solidFill>
-                          <a:latin typeface="GT Walsheim Trial Rg" pitchFamily="2" charset="77"/>
-                        </a:rPr>
-                        <a:t>Vehicle</a:t>
-                      </a:r>
-                    </a:p>
-                  </a:txBody>
-                  <a:tcPr>
-                    <a:lnL w="12700" cap="flat" cmpd="sng" algn="ctr">
-                      <a:noFill/>
-                      <a:prstDash val="solid"/>
-                      <a:round/>
-                      <a:headEnd type="none" w="med" len="med"/>
-                      <a:tailEnd type="none" w="med" len="med"/>
-                    </a:lnL>
-                    <a:lnR w="12700" cap="flat" cmpd="sng" algn="ctr">
-                      <a:noFill/>
-                      <a:prstDash val="solid"/>
-                      <a:round/>
-                      <a:headEnd type="none" w="med" len="med"/>
-                      <a:tailEnd type="none" w="med" len="med"/>
-                    </a:lnR>
-                    <a:lnT w="12700" cap="flat" cmpd="sng" algn="ctr">
-                      <a:noFill/>
-                      <a:prstDash val="solid"/>
-                      <a:round/>
-                      <a:headEnd type="none" w="med" len="med"/>
-                      <a:tailEnd type="none" w="med" len="med"/>
-                    </a:lnT>
-                    <a:lnB w="12700" cap="flat" cmpd="sng" algn="ctr">
-                      <a:noFill/>
-                      <a:prstDash val="solid"/>
-                      <a:round/>
-                      <a:headEnd type="none" w="med" len="med"/>
-                      <a:tailEnd type="none" w="med" len="med"/>
-                    </a:lnB>
-                    <a:lnTlToBr w="12700" cmpd="sng">
-                      <a:noFill/>
-                      <a:prstDash val="solid"/>
-                    </a:lnTlToBr>
-                    <a:lnBlToTr w="12700" cmpd="sng">
-                      <a:noFill/>
-                      <a:prstDash val="solid"/>
-                    </a:lnBlToTr>
-                    <a:solidFill>
-                      <a:schemeClr val="bg1">
-                        <a:lumMod val="95000"/>
-                      </a:schemeClr>
-                    </a:solidFill>
-                  </a:tcPr>
-                </a:tc>
-                <a:tc>
-                  <a:txBody>
-                    <a:bodyPr/>
-                    <a:lstStyle/>
-                    <a:p>
-                      <a:r>
-                        <a:rPr lang="en-US" sz="1500" b="0" i="0" dirty="0">
-                          <a:solidFill>
-                            <a:schemeClr val="tx1"/>
-                          </a:solidFill>
-                          <a:latin typeface="GT Walsheim Trial Rg" pitchFamily="2" charset="77"/>
-                        </a:rPr>
-                        <a:t>majority</a:t>
-                      </a:r>
-                    </a:p>
-                  </a:txBody>
-                  <a:tcPr>
-                    <a:lnL w="12700" cap="flat" cmpd="sng" algn="ctr">
-                      <a:noFill/>
-                      <a:prstDash val="solid"/>
-                      <a:round/>
-                      <a:headEnd type="none" w="med" len="med"/>
-                      <a:tailEnd type="none" w="med" len="med"/>
-                    </a:lnL>
-                    <a:lnR w="12700" cap="flat" cmpd="sng" algn="ctr">
-                      <a:noFill/>
-                      <a:prstDash val="solid"/>
-                      <a:round/>
-                      <a:headEnd type="none" w="med" len="med"/>
-                      <a:tailEnd type="none" w="med" len="med"/>
-                    </a:lnR>
-                    <a:lnT w="12700" cap="flat" cmpd="sng" algn="ctr">
-                      <a:noFill/>
-                      <a:prstDash val="solid"/>
-                      <a:round/>
-                      <a:headEnd type="none" w="med" len="med"/>
-                      <a:tailEnd type="none" w="med" len="med"/>
-                    </a:lnT>
-                    <a:lnB w="12700" cap="flat" cmpd="sng" algn="ctr">
-                      <a:noFill/>
-                      <a:prstDash val="solid"/>
-                      <a:round/>
-                      <a:headEnd type="none" w="med" len="med"/>
-                      <a:tailEnd type="none" w="med" len="med"/>
-                    </a:lnB>
-                    <a:lnTlToBr w="12700" cmpd="sng">
-                      <a:noFill/>
-                      <a:prstDash val="solid"/>
-                    </a:lnTlToBr>
-                    <a:lnBlToTr w="12700" cmpd="sng">
-                      <a:noFill/>
-                      <a:prstDash val="solid"/>
-                    </a:lnBlToTr>
-                    <a:solidFill>
-                      <a:schemeClr val="bg1">
-                        <a:lumMod val="95000"/>
-                      </a:schemeClr>
-                    </a:solidFill>
-                  </a:tcPr>
-                </a:tc>
-                <a:tc>
-                  <a:txBody>
-                    <a:bodyPr/>
-                    <a:lstStyle/>
-                    <a:p>
-                      <a:r>
-                        <a:rPr lang="en-US" sz="1500" b="0" i="0" dirty="0">
-                          <a:solidFill>
-                            <a:schemeClr val="tx1"/>
-                          </a:solidFill>
-                          <a:latin typeface="GT Walsheim Trial Rg" pitchFamily="2" charset="77"/>
-                        </a:rPr>
-                        <a:t>included</a:t>
-                      </a:r>
-                    </a:p>
-                  </a:txBody>
-                  <a:tcPr>
-                    <a:lnL w="12700" cap="flat" cmpd="sng" algn="ctr">
-                      <a:noFill/>
-                      <a:prstDash val="solid"/>
-                      <a:round/>
-                      <a:headEnd type="none" w="med" len="med"/>
-                      <a:tailEnd type="none" w="med" len="med"/>
-                    </a:lnL>
-                    <a:lnR w="12700" cap="flat" cmpd="sng" algn="ctr">
-                      <a:noFill/>
-                      <a:prstDash val="solid"/>
-                      <a:round/>
-                      <a:headEnd type="none" w="med" len="med"/>
-                      <a:tailEnd type="none" w="med" len="med"/>
-                    </a:lnR>
-                    <a:lnT w="12700" cap="flat" cmpd="sng" algn="ctr">
-                      <a:noFill/>
-                      <a:prstDash val="solid"/>
-                      <a:round/>
-                      <a:headEnd type="none" w="med" len="med"/>
-                      <a:tailEnd type="none" w="med" len="med"/>
-                    </a:lnT>
-                    <a:lnB w="12700" cap="flat" cmpd="sng" algn="ctr">
-                      <a:noFill/>
-                      <a:prstDash val="solid"/>
-                      <a:round/>
-                      <a:headEnd type="none" w="med" len="med"/>
-                      <a:tailEnd type="none" w="med" len="med"/>
-                    </a:lnB>
-                    <a:lnTlToBr w="12700" cmpd="sng">
-                      <a:noFill/>
-                      <a:prstDash val="solid"/>
-                    </a:lnTlToBr>
-                    <a:lnBlToTr w="12700" cmpd="sng">
-                      <a:noFill/>
-                      <a:prstDash val="solid"/>
-                    </a:lnBlToTr>
-                    <a:solidFill>
-                      <a:schemeClr val="bg1">
-                        <a:lumMod val="95000"/>
-                      </a:schemeClr>
-                    </a:solidFill>
-                  </a:tcPr>
-                </a:tc>
-                <a:extLst>
-                  <a:ext uri="{0D108BD9-81ED-4DB2-BD59-A6C34878D82A}">
-                    <a16:rowId xmlns:a16="http://schemas.microsoft.com/office/drawing/2014/main" val="4152326013"/>
-                  </a:ext>
-                </a:extLst>
-              </a:tr>
-              <a:tr h="581534">
-                <a:tc>
-                  <a:txBody>
-                    <a:bodyPr/>
-                    <a:lstStyle/>
-                    <a:p>
-                      <a:r>
-                        <a:rPr lang="en-US" sz="1500" b="0" i="0" dirty="0">
-                          <a:solidFill>
-                            <a:schemeClr val="tx1"/>
-                          </a:solidFill>
-                          <a:latin typeface="GT Walsheim Trial Rg" pitchFamily="2" charset="77"/>
-                        </a:rPr>
-                        <a:t>Pedestrian</a:t>
-                      </a:r>
-                    </a:p>
-                  </a:txBody>
-                  <a:tcPr>
-                    <a:lnL w="12700" cap="flat" cmpd="sng" algn="ctr">
-                      <a:noFill/>
-                      <a:prstDash val="solid"/>
-                      <a:round/>
-                      <a:headEnd type="none" w="med" len="med"/>
-                      <a:tailEnd type="none" w="med" len="med"/>
-                    </a:lnL>
-                    <a:lnR w="12700" cap="flat" cmpd="sng" algn="ctr">
-                      <a:noFill/>
-                      <a:prstDash val="solid"/>
-                      <a:round/>
-                      <a:headEnd type="none" w="med" len="med"/>
-                      <a:tailEnd type="none" w="med" len="med"/>
-                    </a:lnR>
-                    <a:lnT w="12700" cap="flat" cmpd="sng" algn="ctr">
-                      <a:noFill/>
-                      <a:prstDash val="solid"/>
-                      <a:round/>
-                      <a:headEnd type="none" w="med" len="med"/>
-                      <a:tailEnd type="none" w="med" len="med"/>
-                    </a:lnT>
-                    <a:lnB w="12700" cap="flat" cmpd="sng" algn="ctr">
-                      <a:noFill/>
-                      <a:prstDash val="solid"/>
-                      <a:round/>
-                      <a:headEnd type="none" w="med" len="med"/>
-                      <a:tailEnd type="none" w="med" len="med"/>
-                    </a:lnB>
-                    <a:lnTlToBr w="12700" cmpd="sng">
-                      <a:noFill/>
-                      <a:prstDash val="solid"/>
-                    </a:lnTlToBr>
-                    <a:lnBlToTr w="12700" cmpd="sng">
-                      <a:noFill/>
-                      <a:prstDash val="solid"/>
-                    </a:lnBlToTr>
-                    <a:solidFill>
-                      <a:schemeClr val="bg1">
-                        <a:lumMod val="85000"/>
-                      </a:schemeClr>
-                    </a:solidFill>
-                  </a:tcPr>
-                </a:tc>
-                <a:tc>
-                  <a:txBody>
-                    <a:bodyPr/>
-                    <a:lstStyle/>
-                    <a:p>
-                      <a:r>
-                        <a:rPr lang="en-US" sz="1500" b="0" i="0" dirty="0">
-                          <a:solidFill>
-                            <a:schemeClr val="tx1"/>
-                          </a:solidFill>
-                          <a:latin typeface="GT Walsheim Trial Rg" pitchFamily="2" charset="77"/>
-                        </a:rPr>
-                        <a:t>~25%</a:t>
-                      </a:r>
-                    </a:p>
-                  </a:txBody>
-                  <a:tcPr>
-                    <a:lnL w="12700" cap="flat" cmpd="sng" algn="ctr">
-                      <a:noFill/>
-                      <a:prstDash val="solid"/>
-                      <a:round/>
-                      <a:headEnd type="none" w="med" len="med"/>
-                      <a:tailEnd type="none" w="med" len="med"/>
-                    </a:lnL>
-                    <a:lnR w="12700" cap="flat" cmpd="sng" algn="ctr">
-                      <a:noFill/>
-                      <a:prstDash val="solid"/>
-                      <a:round/>
-                      <a:headEnd type="none" w="med" len="med"/>
-                      <a:tailEnd type="none" w="med" len="med"/>
-                    </a:lnR>
-                    <a:lnT w="12700" cap="flat" cmpd="sng" algn="ctr">
-                      <a:noFill/>
-                      <a:prstDash val="solid"/>
-                      <a:round/>
-                      <a:headEnd type="none" w="med" len="med"/>
-                      <a:tailEnd type="none" w="med" len="med"/>
-                    </a:lnT>
-                    <a:lnB w="12700" cap="flat" cmpd="sng" algn="ctr">
-                      <a:noFill/>
-                      <a:prstDash val="solid"/>
-                      <a:round/>
-                      <a:headEnd type="none" w="med" len="med"/>
-                      <a:tailEnd type="none" w="med" len="med"/>
-                    </a:lnB>
-                    <a:lnTlToBr w="12700" cmpd="sng">
-                      <a:noFill/>
-                      <a:prstDash val="solid"/>
-                    </a:lnTlToBr>
-                    <a:lnBlToTr w="12700" cmpd="sng">
-                      <a:noFill/>
-                      <a:prstDash val="solid"/>
-                    </a:lnBlToTr>
-                    <a:solidFill>
-                      <a:schemeClr val="bg1">
-                        <a:lumMod val="85000"/>
-                      </a:schemeClr>
-                    </a:solidFill>
-                  </a:tcPr>
-                </a:tc>
-                <a:tc>
-                  <a:txBody>
-                    <a:bodyPr/>
-                    <a:lstStyle/>
-                    <a:p>
-                      <a:r>
-                        <a:rPr lang="en-US" sz="1500" b="0" i="0" dirty="0">
-                          <a:solidFill>
-                            <a:schemeClr val="tx1"/>
-                          </a:solidFill>
-                          <a:latin typeface="GT Walsheim Trial Rg" pitchFamily="2" charset="77"/>
-                        </a:rPr>
-                        <a:t>included</a:t>
-                      </a:r>
-                    </a:p>
-                  </a:txBody>
-                  <a:tcPr>
-                    <a:lnL w="12700" cap="flat" cmpd="sng" algn="ctr">
-                      <a:noFill/>
-                      <a:prstDash val="solid"/>
-                      <a:round/>
-                      <a:headEnd type="none" w="med" len="med"/>
-                      <a:tailEnd type="none" w="med" len="med"/>
-                    </a:lnL>
-                    <a:lnR w="12700" cap="flat" cmpd="sng" algn="ctr">
-                      <a:noFill/>
-                      <a:prstDash val="solid"/>
-                      <a:round/>
-                      <a:headEnd type="none" w="med" len="med"/>
-                      <a:tailEnd type="none" w="med" len="med"/>
-                    </a:lnR>
-                    <a:lnT w="12700" cap="flat" cmpd="sng" algn="ctr">
-                      <a:noFill/>
-                      <a:prstDash val="solid"/>
-                      <a:round/>
-                      <a:headEnd type="none" w="med" len="med"/>
-                      <a:tailEnd type="none" w="med" len="med"/>
-                    </a:lnT>
-                    <a:lnB w="12700" cap="flat" cmpd="sng" algn="ctr">
-                      <a:noFill/>
-                      <a:prstDash val="solid"/>
-                      <a:round/>
-                      <a:headEnd type="none" w="med" len="med"/>
-                      <a:tailEnd type="none" w="med" len="med"/>
-                    </a:lnB>
-                    <a:lnTlToBr w="12700" cmpd="sng">
-                      <a:noFill/>
-                      <a:prstDash val="solid"/>
-                    </a:lnTlToBr>
-                    <a:lnBlToTr w="12700" cmpd="sng">
-                      <a:noFill/>
-                      <a:prstDash val="solid"/>
-                    </a:lnBlToTr>
-                    <a:solidFill>
-                      <a:schemeClr val="bg1">
-                        <a:lumMod val="85000"/>
-                      </a:schemeClr>
-                    </a:solidFill>
-                  </a:tcPr>
-                </a:tc>
-                <a:extLst>
-                  <a:ext uri="{0D108BD9-81ED-4DB2-BD59-A6C34878D82A}">
-                    <a16:rowId xmlns:a16="http://schemas.microsoft.com/office/drawing/2014/main" val="3142999530"/>
-                  </a:ext>
-                </a:extLst>
-              </a:tr>
-              <a:tr h="581534">
-                <a:tc>
-                  <a:txBody>
-                    <a:bodyPr/>
-                    <a:lstStyle/>
-                    <a:p>
-                      <a:r>
-                        <a:rPr lang="en-US" sz="1500" b="0" i="0" dirty="0">
-                          <a:solidFill>
-                            <a:schemeClr val="tx1"/>
-                          </a:solidFill>
-                          <a:latin typeface="GT Walsheim Trial Rg" pitchFamily="2" charset="77"/>
-                        </a:rPr>
-                        <a:t>Cyclist</a:t>
-                      </a:r>
-                    </a:p>
-                  </a:txBody>
-                  <a:tcPr>
-                    <a:lnL w="12700" cap="flat" cmpd="sng" algn="ctr">
-                      <a:noFill/>
-                      <a:prstDash val="solid"/>
-                      <a:round/>
-                      <a:headEnd type="none" w="med" len="med"/>
-                      <a:tailEnd type="none" w="med" len="med"/>
-                    </a:lnL>
-                    <a:lnR w="12700" cap="flat" cmpd="sng" algn="ctr">
-                      <a:noFill/>
-                      <a:prstDash val="solid"/>
-                      <a:round/>
-                      <a:headEnd type="none" w="med" len="med"/>
-                      <a:tailEnd type="none" w="med" len="med"/>
-                    </a:lnR>
-                    <a:lnT w="12700" cap="flat" cmpd="sng" algn="ctr">
-                      <a:noFill/>
-                      <a:prstDash val="solid"/>
-                      <a:round/>
-                      <a:headEnd type="none" w="med" len="med"/>
-                      <a:tailEnd type="none" w="med" len="med"/>
-                    </a:lnT>
-                    <a:lnB w="12700" cap="flat" cmpd="sng" algn="ctr">
-                      <a:noFill/>
-                      <a:prstDash val="solid"/>
-                      <a:round/>
-                      <a:headEnd type="none" w="med" len="med"/>
-                      <a:tailEnd type="none" w="med" len="med"/>
-                    </a:lnB>
-                    <a:lnTlToBr w="12700" cmpd="sng">
-                      <a:noFill/>
-                      <a:prstDash val="solid"/>
-                    </a:lnTlToBr>
-                    <a:lnBlToTr w="12700" cmpd="sng">
-                      <a:noFill/>
-                      <a:prstDash val="solid"/>
-                    </a:lnBlToTr>
-                    <a:solidFill>
-                      <a:schemeClr val="bg1">
-                        <a:lumMod val="95000"/>
-                      </a:schemeClr>
-                    </a:solidFill>
-                  </a:tcPr>
-                </a:tc>
-                <a:tc>
-                  <a:txBody>
-                    <a:bodyPr/>
-                    <a:lstStyle/>
-                    <a:p>
-                      <a:r>
-                        <a:rPr lang="en-US" sz="1500" b="0" i="0" dirty="0">
-                          <a:solidFill>
-                            <a:schemeClr val="tx1"/>
-                          </a:solidFill>
-                          <a:latin typeface="GT Walsheim Trial Rg" pitchFamily="2" charset="77"/>
-                        </a:rPr>
-                        <a:t>~5%</a:t>
-                      </a:r>
-                    </a:p>
-                  </a:txBody>
-                  <a:tcPr>
-                    <a:lnL w="12700" cap="flat" cmpd="sng" algn="ctr">
-                      <a:noFill/>
-                      <a:prstDash val="solid"/>
-                      <a:round/>
-                      <a:headEnd type="none" w="med" len="med"/>
-                      <a:tailEnd type="none" w="med" len="med"/>
-                    </a:lnL>
-                    <a:lnR w="12700" cap="flat" cmpd="sng" algn="ctr">
-                      <a:noFill/>
-                      <a:prstDash val="solid"/>
-                      <a:round/>
-                      <a:headEnd type="none" w="med" len="med"/>
-                      <a:tailEnd type="none" w="med" len="med"/>
-                    </a:lnR>
-                    <a:lnT w="12700" cap="flat" cmpd="sng" algn="ctr">
-                      <a:noFill/>
-                      <a:prstDash val="solid"/>
-                      <a:round/>
-                      <a:headEnd type="none" w="med" len="med"/>
-                      <a:tailEnd type="none" w="med" len="med"/>
-                    </a:lnT>
-                    <a:lnB w="12700" cap="flat" cmpd="sng" algn="ctr">
-                      <a:noFill/>
-                      <a:prstDash val="solid"/>
-                      <a:round/>
-                      <a:headEnd type="none" w="med" len="med"/>
-                      <a:tailEnd type="none" w="med" len="med"/>
-                    </a:lnB>
-                    <a:lnTlToBr w="12700" cmpd="sng">
-                      <a:noFill/>
-                      <a:prstDash val="solid"/>
-                    </a:lnTlToBr>
-                    <a:lnBlToTr w="12700" cmpd="sng">
-                      <a:noFill/>
-                      <a:prstDash val="solid"/>
-                    </a:lnBlToTr>
-                    <a:solidFill>
-                      <a:schemeClr val="bg1">
-                        <a:lumMod val="95000"/>
-                      </a:schemeClr>
-                    </a:solidFill>
-                  </a:tcPr>
-                </a:tc>
-                <a:tc>
-                  <a:txBody>
-                    <a:bodyPr/>
-                    <a:lstStyle/>
-                    <a:p>
-                      <a:r>
-                        <a:rPr lang="en-US" sz="1500" b="0" i="0" dirty="0">
-                          <a:solidFill>
-                            <a:schemeClr val="tx1"/>
-                          </a:solidFill>
-                          <a:latin typeface="GT Walsheim Trial Rg" pitchFamily="2" charset="77"/>
-                        </a:rPr>
-                        <a:t>included</a:t>
-                      </a:r>
-                    </a:p>
-                  </a:txBody>
-                  <a:tcPr>
-                    <a:lnL w="12700" cap="flat" cmpd="sng" algn="ctr">
-                      <a:noFill/>
-                      <a:prstDash val="solid"/>
-                      <a:round/>
-                      <a:headEnd type="none" w="med" len="med"/>
-                      <a:tailEnd type="none" w="med" len="med"/>
-                    </a:lnL>
-                    <a:lnR w="12700" cap="flat" cmpd="sng" algn="ctr">
-                      <a:noFill/>
-                      <a:prstDash val="solid"/>
-                      <a:round/>
-                      <a:headEnd type="none" w="med" len="med"/>
-                      <a:tailEnd type="none" w="med" len="med"/>
-                    </a:lnR>
-                    <a:lnT w="12700" cap="flat" cmpd="sng" algn="ctr">
-                      <a:noFill/>
-                      <a:prstDash val="solid"/>
-                      <a:round/>
-                      <a:headEnd type="none" w="med" len="med"/>
-                      <a:tailEnd type="none" w="med" len="med"/>
-                    </a:lnT>
-                    <a:lnB w="12700" cap="flat" cmpd="sng" algn="ctr">
-                      <a:noFill/>
-                      <a:prstDash val="solid"/>
-                      <a:round/>
-                      <a:headEnd type="none" w="med" len="med"/>
-                      <a:tailEnd type="none" w="med" len="med"/>
-                    </a:lnB>
-                    <a:lnTlToBr w="12700" cmpd="sng">
-                      <a:noFill/>
-                      <a:prstDash val="solid"/>
-                    </a:lnTlToBr>
-                    <a:lnBlToTr w="12700" cmpd="sng">
-                      <a:noFill/>
-                      <a:prstDash val="solid"/>
-                    </a:lnBlToTr>
-                    <a:solidFill>
-                      <a:schemeClr val="bg1">
-                        <a:lumMod val="95000"/>
-                      </a:schemeClr>
-                    </a:solidFill>
-                  </a:tcPr>
-                </a:tc>
-                <a:extLst>
-                  <a:ext uri="{0D108BD9-81ED-4DB2-BD59-A6C34878D82A}">
-                    <a16:rowId xmlns:a16="http://schemas.microsoft.com/office/drawing/2014/main" val="1523425920"/>
-                  </a:ext>
-                </a:extLst>
-              </a:tr>
-              <a:tr h="581534">
-                <a:tc>
-                  <a:txBody>
-                    <a:bodyPr/>
-                    <a:lstStyle/>
-                    <a:p>
-                      <a:r>
-                        <a:rPr lang="en-US" sz="1500" b="0" i="0" dirty="0">
-                          <a:solidFill>
-                            <a:schemeClr val="tx1"/>
-                          </a:solidFill>
-                          <a:latin typeface="GT Walsheim Trial Rg" pitchFamily="2" charset="77"/>
-                        </a:rPr>
-                        <a:t>SDC (AV itself)</a:t>
-                      </a:r>
-                    </a:p>
-                  </a:txBody>
-                  <a:tcPr>
-                    <a:lnL w="12700" cap="flat" cmpd="sng" algn="ctr">
-                      <a:noFill/>
-                      <a:prstDash val="solid"/>
-                      <a:round/>
-                      <a:headEnd type="none" w="med" len="med"/>
-                      <a:tailEnd type="none" w="med" len="med"/>
-                    </a:lnL>
-                    <a:lnR w="12700" cap="flat" cmpd="sng" algn="ctr">
-                      <a:noFill/>
-                      <a:prstDash val="solid"/>
-                      <a:round/>
-                      <a:headEnd type="none" w="med" len="med"/>
-                      <a:tailEnd type="none" w="med" len="med"/>
-                    </a:lnR>
-                    <a:lnT w="12700" cap="flat" cmpd="sng" algn="ctr">
-                      <a:noFill/>
-                      <a:prstDash val="solid"/>
-                      <a:round/>
-                      <a:headEnd type="none" w="med" len="med"/>
-                      <a:tailEnd type="none" w="med" len="med"/>
-                    </a:lnT>
-                    <a:lnB w="12700" cap="flat" cmpd="sng" algn="ctr">
-                      <a:noFill/>
-                      <a:prstDash val="solid"/>
-                      <a:round/>
-                      <a:headEnd type="none" w="med" len="med"/>
-                      <a:tailEnd type="none" w="med" len="med"/>
-                    </a:lnB>
-                    <a:lnTlToBr w="12700" cmpd="sng">
-                      <a:noFill/>
-                      <a:prstDash val="solid"/>
-                    </a:lnTlToBr>
-                    <a:lnBlToTr w="12700" cmpd="sng">
-                      <a:noFill/>
-                      <a:prstDash val="solid"/>
-                    </a:lnBlToTr>
-                    <a:solidFill>
-                      <a:schemeClr val="bg1">
-                        <a:lumMod val="85000"/>
-                      </a:schemeClr>
-                    </a:solidFill>
-                  </a:tcPr>
-                </a:tc>
-                <a:tc>
-                  <a:txBody>
-                    <a:bodyPr/>
-                    <a:lstStyle/>
-                    <a:p>
-                      <a:r>
-                        <a:rPr lang="en-US" sz="1500" b="0" i="0" dirty="0">
-                          <a:solidFill>
-                            <a:schemeClr val="tx1"/>
-                          </a:solidFill>
-                          <a:latin typeface="GT Walsheim Trial Rg" pitchFamily="2" charset="77"/>
-                        </a:rPr>
-                        <a:t>removed</a:t>
-                      </a:r>
-                    </a:p>
-                  </a:txBody>
-                  <a:tcPr>
-                    <a:lnL w="12700" cap="flat" cmpd="sng" algn="ctr">
-                      <a:noFill/>
-                      <a:prstDash val="solid"/>
-                      <a:round/>
-                      <a:headEnd type="none" w="med" len="med"/>
-                      <a:tailEnd type="none" w="med" len="med"/>
-                    </a:lnL>
-                    <a:lnR w="12700" cap="flat" cmpd="sng" algn="ctr">
-                      <a:noFill/>
-                      <a:prstDash val="solid"/>
-                      <a:round/>
-                      <a:headEnd type="none" w="med" len="med"/>
-                      <a:tailEnd type="none" w="med" len="med"/>
-                    </a:lnR>
-                    <a:lnT w="12700" cap="flat" cmpd="sng" algn="ctr">
-                      <a:noFill/>
-                      <a:prstDash val="solid"/>
-                      <a:round/>
-                      <a:headEnd type="none" w="med" len="med"/>
-                      <a:tailEnd type="none" w="med" len="med"/>
-                    </a:lnT>
-                    <a:lnB w="12700" cap="flat" cmpd="sng" algn="ctr">
-                      <a:noFill/>
-                      <a:prstDash val="solid"/>
-                      <a:round/>
-                      <a:headEnd type="none" w="med" len="med"/>
-                      <a:tailEnd type="none" w="med" len="med"/>
-                    </a:lnB>
-                    <a:lnTlToBr w="12700" cmpd="sng">
-                      <a:noFill/>
-                      <a:prstDash val="solid"/>
-                    </a:lnTlToBr>
-                    <a:lnBlToTr w="12700" cmpd="sng">
-                      <a:noFill/>
-                      <a:prstDash val="solid"/>
-                    </a:lnBlToTr>
-                    <a:solidFill>
-                      <a:schemeClr val="bg1">
-                        <a:lumMod val="85000"/>
-                      </a:schemeClr>
-                    </a:solidFill>
-                  </a:tcPr>
-                </a:tc>
-                <a:tc>
-                  <a:txBody>
-                    <a:bodyPr/>
-                    <a:lstStyle/>
-                    <a:p>
-                      <a:r>
-                        <a:rPr lang="en-US" sz="1500" b="0" i="0" dirty="0">
-                          <a:solidFill>
-                            <a:schemeClr val="tx1"/>
-                          </a:solidFill>
-                          <a:latin typeface="GT Walsheim Trial Rg" pitchFamily="2" charset="77"/>
-                        </a:rPr>
-                        <a:t>excluded</a:t>
-                      </a:r>
-                    </a:p>
-                  </a:txBody>
-                  <a:tcPr>
-                    <a:lnL w="12700" cap="flat" cmpd="sng" algn="ctr">
-                      <a:noFill/>
-                      <a:prstDash val="solid"/>
-                      <a:round/>
-                      <a:headEnd type="none" w="med" len="med"/>
-                      <a:tailEnd type="none" w="med" len="med"/>
-                    </a:lnL>
-                    <a:lnR w="12700" cap="flat" cmpd="sng" algn="ctr">
-                      <a:noFill/>
-                      <a:prstDash val="solid"/>
-                      <a:round/>
-                      <a:headEnd type="none" w="med" len="med"/>
-                      <a:tailEnd type="none" w="med" len="med"/>
-                    </a:lnR>
-                    <a:lnT w="12700" cap="flat" cmpd="sng" algn="ctr">
-                      <a:noFill/>
-                      <a:prstDash val="solid"/>
-                      <a:round/>
-                      <a:headEnd type="none" w="med" len="med"/>
-                      <a:tailEnd type="none" w="med" len="med"/>
-                    </a:lnT>
-                    <a:lnB w="12700" cap="flat" cmpd="sng" algn="ctr">
-                      <a:noFill/>
-                      <a:prstDash val="solid"/>
-                      <a:round/>
-                      <a:headEnd type="none" w="med" len="med"/>
-                      <a:tailEnd type="none" w="med" len="med"/>
-                    </a:lnB>
-                    <a:lnTlToBr w="12700" cmpd="sng">
-                      <a:noFill/>
-                      <a:prstDash val="solid"/>
-                    </a:lnTlToBr>
-                    <a:lnBlToTr w="12700" cmpd="sng">
-                      <a:noFill/>
-                      <a:prstDash val="solid"/>
-                    </a:lnBlToTr>
-                    <a:solidFill>
-                      <a:schemeClr val="bg1">
-                        <a:lumMod val="85000"/>
-                      </a:schemeClr>
-                    </a:solidFill>
-                  </a:tcPr>
-                </a:tc>
-                <a:extLst>
-                  <a:ext uri="{0D108BD9-81ED-4DB2-BD59-A6C34878D82A}">
-                    <a16:rowId xmlns:a16="http://schemas.microsoft.com/office/drawing/2014/main" val="1062120210"/>
-                  </a:ext>
-                </a:extLst>
-              </a:tr>
-            </a:tbl>
-          </a:graphicData>
-        </a:graphic>
-      </p:graphicFrame>
     </p:spTree>
     <p:extLst>
       <p:ext uri="{BB962C8B-B14F-4D97-AF65-F5344CB8AC3E}">
-        <p14:creationId xmlns:p14="http://schemas.microsoft.com/office/powerpoint/2010/main" val="2606525707"/>
+        <p14:creationId xmlns:p14="http://schemas.microsoft.com/office/powerpoint/2010/main" val="1281361301"/>
       </p:ext>
     </p:extLst>
   </p:cSld>

</xml_diff>